<commit_message>
chore: update legacy template PPTX and README formatting
</commit_message>
<xml_diff>
--- a/scripts/legacy_template.pptx
+++ b/scripts/legacy_template.pptx
@@ -6,32 +6,32 @@
     <p:sldMasterId id="2147483900" r:id="rId5"/>
   </p:sldMasterIdLst>
   <p:notesMasterIdLst>
-    <p:notesMasterId r:id="rId14"/>
+    <p:notesMasterId r:id="rId8"/>
   </p:notesMasterIdLst>
   <p:handoutMasterIdLst>
-    <p:handoutMasterId r:id="rId15"/>
+    <p:handoutMasterId r:id="rId9"/>
   </p:handoutMasterIdLst>
   <p:sldIdLst>
     <p:sldId id="3815" r:id="rId6"/>
-    <p:sldId id="3887" r:id="rId9"/>
+    <p:sldId id="3887" r:id="rId7"/>
   </p:sldIdLst>
   <p:sldSz cx="12192000" cy="6858000"/>
   <p:notesSz cx="7102475" cy="9388475"/>
   <p:embeddedFontLst>
     <p:embeddedFont>
-      <p:font typeface="Helvetica 75 Bold" panose="020B0804020202020204" charset="0"/>
-      <p:bold r:id="rId16"/>
+      <p:font typeface="Helvetica 75 Bold" panose="020B0804020202020204" pitchFamily="34" charset="0"/>
+      <p:bold r:id="rId10"/>
     </p:embeddedFont>
     <p:embeddedFont>
       <p:font typeface="Segoe UI" panose="020B0502040204020203" pitchFamily="34" charset="0"/>
-      <p:regular r:id="rId17"/>
-      <p:bold r:id="rId18"/>
-      <p:italic r:id="rId19"/>
-      <p:boldItalic r:id="rId20"/>
+      <p:regular r:id="rId11"/>
+      <p:bold r:id="rId12"/>
+      <p:italic r:id="rId13"/>
+      <p:boldItalic r:id="rId14"/>
     </p:embeddedFont>
   </p:embeddedFontLst>
   <p:custDataLst>
-    <p:tags r:id="rId21"/>
+    <p:tags r:id="rId15"/>
   </p:custDataLst>
   <p:defaultTextStyle>
     <a:defPPr>
@@ -128,6 +128,11 @@
       </a:defRPr>
     </a:lvl9pPr>
   </p:defaultTextStyle>
+  <p:extLst>
+    <p:ext uri="{EFAFB233-063F-42B5-8137-9DF3F51BA10A}">
+      <p15:sldGuideLst xmlns:p15="http://schemas.microsoft.com/office/powerpoint/2012/main"/>
+    </p:ext>
+  </p:extLst>
 </p:presentation>
 </file>
 
@@ -1376,7 +1381,7 @@
           <a:p>
             <a:fld id="{A6BD5B6C-20AF-4F0F-889A-7AADC7535123}" type="datetime3">
               <a:rPr lang="en-US" smtClean="0"/>
-              <a:t>28 September 2026</a:t>
+              <a:t>21 October 2026</a:t>
             </a:fld>
             <a:endParaRPr lang="en-US"/>
           </a:p>
@@ -1454,7 +1459,7 @@
           <a:p>
             <a:fld id="{D2610F73-99D1-48E7-A408-B5EB5C8393F8}" type="slidenum">
               <a:rPr lang="en-US" smtClean="0"/>
-              <a:t>‹#›</a:t>
+              <a:t>‹Nº›</a:t>
             </a:fld>
             <a:endParaRPr lang="en-US"/>
           </a:p>
@@ -1561,7 +1566,7 @@
             <a:fld id="{1DF34805-1F01-4BDA-A8CA-FCEA2B4BC8D0}" type="datetime3">
               <a:rPr lang="en-US" smtClean="0"/>
               <a:pPr/>
-              <a:t>28 September 2026</a:t>
+              <a:t>21 October 2026</a:t>
             </a:fld>
             <a:endParaRPr lang="en-US"/>
           </a:p>
@@ -1667,7 +1672,7 @@
             <a:fld id="{CF5EBCF4-26FC-4F76-8DA1-52FDDC328D44}" type="slidenum">
               <a:rPr lang="en-US" smtClean="0"/>
               <a:pPr/>
-              <a:t>‹#›</a:t>
+              <a:t>‹Nº›</a:t>
             </a:fld>
             <a:endParaRPr lang="en-US"/>
           </a:p>
@@ -1957,7 +1962,7 @@
                 <a:tabLst/>
                 <a:defRPr/>
               </a:pPr>
-              <a:t>28 September 2026</a:t>
+              <a:t>21 October 2026</a:t>
             </a:fld>
             <a:endParaRPr kumimoji="0" lang="en-US" sz="900" b="0" i="0" u="none" strike="noStrike" kern="1200" cap="none" spc="0" normalizeH="0" baseline="0" noProof="0">
               <a:ln>
@@ -2158,12 +2163,12 @@
           <a:graphicData uri="http://schemas.openxmlformats.org/presentationml/2006/ole">
             <mc:AlternateContent xmlns:mc="http://schemas.openxmlformats.org/markup-compatibility/2006">
               <mc:Choice xmlns:v="urn:schemas-microsoft-com:vml" Requires="v">
-                <p:oleObj name="think-cell Slide" r:id="rId7" imgW="592" imgH="591" progId="TCLayout.ActiveDocument.1">
+                <p:oleObj name="think-cell Slide" r:id="rId6" imgW="592" imgH="591" progId="TCLayout.ActiveDocument.1">
                   <p:embed/>
                 </p:oleObj>
               </mc:Choice>
               <mc:Fallback>
-                <p:oleObj name="think-cell Slide" r:id="rId7" imgW="592" imgH="591" progId="TCLayout.ActiveDocument.1">
+                <p:oleObj name="think-cell Slide" r:id="rId6" imgW="592" imgH="591" progId="TCLayout.ActiveDocument.1">
                   <p:embed/>
                   <p:pic>
                     <p:nvPicPr>
@@ -2178,7 +2183,7 @@
                       <p:nvPr/>
                     </p:nvPicPr>
                     <p:blipFill>
-                      <a:blip r:embed="rId8"/>
+                      <a:blip r:embed="rId7"/>
                       <a:stretch>
                         <a:fillRect/>
                       </a:stretch>
@@ -2348,7 +2353,7 @@
           <p:nvPr>
             <p:ph type="title"/>
             <p:custDataLst>
-              <p:tags r:id="rId5"/>
+              <p:tags r:id="rId4"/>
             </p:custDataLst>
           </p:nvPr>
         </p:nvSpPr>
@@ -2405,7 +2410,7 @@
           <p:nvPr userDrawn="1"/>
         </p:nvPicPr>
         <p:blipFill rotWithShape="1">
-          <a:blip r:embed="rId9"/>
+          <a:blip r:embed="rId8"/>
           <a:srcRect l="16758" t="20725" r="11635" b="24190"/>
           <a:stretch/>
         </p:blipFill>
@@ -2434,7 +2439,7 @@
           <p:nvPr/>
         </p:nvPicPr>
         <p:blipFill>
-          <a:blip r:embed="rId10"/>
+          <a:blip r:embed="rId9"/>
           <a:stretch>
             <a:fillRect/>
           </a:stretch>
@@ -2464,7 +2469,7 @@
           <p:nvPr/>
         </p:nvPicPr>
         <p:blipFill rotWithShape="1">
-          <a:blip r:embed="rId11"/>
+          <a:blip r:embed="rId10"/>
           <a:srcRect l="84827" t="-11201" r="-444" b="13414"/>
           <a:stretch/>
         </p:blipFill>
@@ -2493,7 +2498,7 @@
           <p:nvPr userDrawn="1"/>
         </p:nvPicPr>
         <p:blipFill>
-          <a:blip r:embed="rId12"/>
+          <a:blip r:embed="rId11"/>
           <a:stretch>
             <a:fillRect/>
           </a:stretch>
@@ -2523,7 +2528,7 @@
           <p:nvPr/>
         </p:nvPicPr>
         <p:blipFill rotWithShape="1">
-          <a:blip r:embed="rId13"/>
+          <a:blip r:embed="rId12"/>
           <a:srcRect l="8432" t="13808" r="3866" b="22570"/>
           <a:stretch/>
         </p:blipFill>
@@ -2552,7 +2557,7 @@
           <p:nvPr/>
         </p:nvPicPr>
         <p:blipFill rotWithShape="1">
-          <a:blip r:embed="rId14"/>
+          <a:blip r:embed="rId13"/>
           <a:srcRect l="6973" t="22509" r="3652" b="29230"/>
           <a:stretch/>
         </p:blipFill>
@@ -2581,7 +2586,7 @@
           <p:nvPr/>
         </p:nvPicPr>
         <p:blipFill rotWithShape="1">
-          <a:blip r:embed="rId15"/>
+          <a:blip r:embed="rId14"/>
           <a:srcRect l="22218" r="21421"/>
           <a:stretch/>
         </p:blipFill>
@@ -2610,7 +2615,7 @@
           <p:nvPr/>
         </p:nvPicPr>
         <p:blipFill>
-          <a:blip r:embed="rId16"/>
+          <a:blip r:embed="rId15"/>
           <a:stretch>
             <a:fillRect/>
           </a:stretch>
@@ -2640,7 +2645,7 @@
           <p:nvPr/>
         </p:nvPicPr>
         <p:blipFill>
-          <a:blip r:embed="rId17"/>
+          <a:blip r:embed="rId16"/>
           <a:stretch>
             <a:fillRect/>
           </a:stretch>
@@ -2670,7 +2675,7 @@
           <p:nvPr/>
         </p:nvPicPr>
         <p:blipFill>
-          <a:blip r:embed="rId18">
+          <a:blip r:embed="rId17">
             <a:extLst>
               <a:ext uri="{28A0092B-C50C-407E-A947-70E740481C1C}">
                 <a14:useLocalDpi xmlns:a14="http://schemas.microsoft.com/office/drawing/2010/main" val="0"/>
@@ -2730,7 +2735,7 @@
           <p:nvPr/>
         </p:nvPicPr>
         <p:blipFill>
-          <a:blip r:embed="rId19">
+          <a:blip r:embed="rId18">
             <a:extLst>
               <a:ext uri="{28A0092B-C50C-407E-A947-70E740481C1C}">
                 <a14:useLocalDpi xmlns:a14="http://schemas.microsoft.com/office/drawing/2010/main" val="0"/>
@@ -2777,7 +2782,7 @@
           <p:nvPr/>
         </p:nvPicPr>
         <p:blipFill>
-          <a:blip r:embed="rId20">
+          <a:blip r:embed="rId19">
             <a:extLst>
               <a:ext uri="{28A0092B-C50C-407E-A947-70E740481C1C}">
                 <a14:useLocalDpi xmlns:a14="http://schemas.microsoft.com/office/drawing/2010/main" val="0"/>
@@ -2869,7 +2874,7 @@
           <p:nvPr/>
         </p:nvPicPr>
         <p:blipFill rotWithShape="1">
-          <a:blip r:embed="rId21">
+          <a:blip r:embed="rId20">
             <a:extLst>
               <a:ext uri="{28A0092B-C50C-407E-A947-70E740481C1C}">
                 <a14:useLocalDpi xmlns:a14="http://schemas.microsoft.com/office/drawing/2010/main" val="0"/>
@@ -2927,7 +2932,7 @@
           <p:nvPr/>
         </p:nvPicPr>
         <p:blipFill>
-          <a:blip r:embed="rId22">
+          <a:blip r:embed="rId21">
             <a:extLst>
               <a:ext uri="{28A0092B-C50C-407E-A947-70E740481C1C}">
                 <a14:useLocalDpi xmlns:a14="http://schemas.microsoft.com/office/drawing/2010/main" val="0"/>
@@ -2987,7 +2992,7 @@
           <p:nvPr userDrawn="1"/>
         </p:nvPicPr>
         <p:blipFill>
-          <a:blip r:embed="rId23"/>
+          <a:blip r:embed="rId22"/>
           <a:stretch>
             <a:fillRect/>
           </a:stretch>
@@ -3017,7 +3022,7 @@
           <p:nvPr userDrawn="1"/>
         </p:nvPicPr>
         <p:blipFill>
-          <a:blip r:embed="rId24"/>
+          <a:blip r:embed="rId23"/>
           <a:stretch>
             <a:fillRect/>
           </a:stretch>
@@ -3093,12 +3098,12 @@
           <a:graphicData uri="http://schemas.openxmlformats.org/presentationml/2006/ole">
             <mc:AlternateContent xmlns:mc="http://schemas.openxmlformats.org/markup-compatibility/2006">
               <mc:Choice xmlns:v="urn:schemas-microsoft-com:vml" Requires="v">
-                <p:oleObj name="think-cell Slide" r:id="rId10" imgW="413" imgH="416" progId="TCLayout.ActiveDocument.1">
+                <p:oleObj name="think-cell Slide" r:id="rId7" imgW="413" imgH="416" progId="TCLayout.ActiveDocument.1">
                   <p:embed/>
                 </p:oleObj>
               </mc:Choice>
               <mc:Fallback>
-                <p:oleObj name="think-cell Slide" r:id="rId10" imgW="413" imgH="416" progId="TCLayout.ActiveDocument.1">
+                <p:oleObj name="think-cell Slide" r:id="rId7" imgW="413" imgH="416" progId="TCLayout.ActiveDocument.1">
                   <p:embed/>
                   <p:pic>
                     <p:nvPicPr>
@@ -3113,7 +3118,7 @@
                       <p:nvPr/>
                     </p:nvPicPr>
                     <p:blipFill>
-                      <a:blip r:embed="rId11"/>
+                      <a:blip r:embed="rId8"/>
                       <a:stretch>
                         <a:fillRect/>
                       </a:stretch>
@@ -3346,7 +3351,7 @@
                 </a:spcAft>
                 <a:defRPr/>
               </a:pPr>
-              <a:t>‹#›</a:t>
+              <a:t>‹Nº›</a:t>
             </a:fld>
             <a:endParaRPr lang="en-US" sz="900" b="0">
               <a:solidFill>
@@ -3374,7 +3379,7 @@
           <p:nvPr>
             <p:ph type="title"/>
             <p:custDataLst>
-              <p:tags r:id="rId8"/>
+              <p:tags r:id="rId5"/>
             </p:custDataLst>
           </p:nvPr>
         </p:nvSpPr>
@@ -3416,7 +3421,7 @@
           <p:nvPr userDrawn="1"/>
         </p:nvPicPr>
         <p:blipFill rotWithShape="1">
-          <a:blip r:embed="rId12">
+          <a:blip r:embed="rId9">
             <a:clrChange>
               <a:clrFrom>
                 <a:srgbClr val="FFFFFF"/>
@@ -3502,12 +3507,12 @@
           <a:graphicData uri="http://schemas.openxmlformats.org/presentationml/2006/ole">
             <mc:AlternateContent xmlns:mc="http://schemas.openxmlformats.org/markup-compatibility/2006">
               <mc:Choice xmlns:v="urn:schemas-microsoft-com:vml" Requires="v">
-                <p:oleObj name="think-cell Slide" r:id="rId10" imgW="413" imgH="416" progId="TCLayout.ActiveDocument.1">
+                <p:oleObj name="think-cell Slide" r:id="rId7" imgW="413" imgH="416" progId="TCLayout.ActiveDocument.1">
                   <p:embed/>
                 </p:oleObj>
               </mc:Choice>
               <mc:Fallback>
-                <p:oleObj name="think-cell Slide" r:id="rId10" imgW="413" imgH="416" progId="TCLayout.ActiveDocument.1">
+                <p:oleObj name="think-cell Slide" r:id="rId7" imgW="413" imgH="416" progId="TCLayout.ActiveDocument.1">
                   <p:embed/>
                   <p:pic>
                     <p:nvPicPr>
@@ -3522,7 +3527,7 @@
                       <p:nvPr/>
                     </p:nvPicPr>
                     <p:blipFill>
-                      <a:blip r:embed="rId11"/>
+                      <a:blip r:embed="rId8"/>
                       <a:stretch>
                         <a:fillRect/>
                       </a:stretch>
@@ -3755,7 +3760,7 @@
                 </a:spcAft>
                 <a:defRPr/>
               </a:pPr>
-              <a:t>‹#›</a:t>
+              <a:t>‹Nº›</a:t>
             </a:fld>
             <a:endParaRPr lang="en-US" sz="900" b="0">
               <a:solidFill>
@@ -3825,7 +3830,7 @@
           <p:nvPr userDrawn="1"/>
         </p:nvPicPr>
         <p:blipFill rotWithShape="1">
-          <a:blip r:embed="rId12">
+          <a:blip r:embed="rId9">
             <a:clrChange>
               <a:clrFrom>
                 <a:srgbClr val="FFFFFF"/>
@@ -3911,12 +3916,12 @@
           <a:graphicData uri="http://schemas.openxmlformats.org/presentationml/2006/ole">
             <mc:AlternateContent xmlns:mc="http://schemas.openxmlformats.org/markup-compatibility/2006">
               <mc:Choice xmlns:v="urn:schemas-microsoft-com:vml" Requires="v">
-                <p:oleObj name="think-cell Slide" r:id="rId10" imgW="572" imgH="588" progId="TCLayout.ActiveDocument.1">
+                <p:oleObj name="think-cell Slide" r:id="rId7" imgW="572" imgH="588" progId="TCLayout.ActiveDocument.1">
                   <p:embed/>
                 </p:oleObj>
               </mc:Choice>
               <mc:Fallback>
-                <p:oleObj name="think-cell Slide" r:id="rId10" imgW="572" imgH="588" progId="TCLayout.ActiveDocument.1">
+                <p:oleObj name="think-cell Slide" r:id="rId7" imgW="572" imgH="588" progId="TCLayout.ActiveDocument.1">
                   <p:embed/>
                   <p:pic>
                     <p:nvPicPr>
@@ -3931,7 +3936,7 @@
                       <p:nvPr/>
                     </p:nvPicPr>
                     <p:blipFill>
-                      <a:blip r:embed="rId11"/>
+                      <a:blip r:embed="rId8"/>
                       <a:stretch>
                         <a:fillRect/>
                       </a:stretch>
@@ -4206,7 +4211,7 @@
                 </a:spcAft>
                 <a:defRPr/>
               </a:pPr>
-              <a:t>‹#›</a:t>
+              <a:t>‹Nº›</a:t>
             </a:fld>
             <a:endParaRPr lang="en-US" sz="900" b="0">
               <a:solidFill>
@@ -4234,7 +4239,7 @@
           <p:nvPr userDrawn="1"/>
         </p:nvPicPr>
         <p:blipFill rotWithShape="1">
-          <a:blip r:embed="rId12">
+          <a:blip r:embed="rId9">
             <a:clrChange>
               <a:clrFrom>
                 <a:srgbClr val="FFFFFF"/>
@@ -4320,12 +4325,12 @@
           <a:graphicData uri="http://schemas.openxmlformats.org/presentationml/2006/ole">
             <mc:AlternateContent xmlns:mc="http://schemas.openxmlformats.org/markup-compatibility/2006">
               <mc:Choice xmlns:v="urn:schemas-microsoft-com:vml" Requires="v">
-                <p:oleObj name="think-cell Slide" r:id="rId10" imgW="413" imgH="416" progId="TCLayout.ActiveDocument.1">
+                <p:oleObj name="think-cell Slide" r:id="rId7" imgW="413" imgH="416" progId="TCLayout.ActiveDocument.1">
                   <p:embed/>
                 </p:oleObj>
               </mc:Choice>
               <mc:Fallback>
-                <p:oleObj name="think-cell Slide" r:id="rId10" imgW="413" imgH="416" progId="TCLayout.ActiveDocument.1">
+                <p:oleObj name="think-cell Slide" r:id="rId7" imgW="413" imgH="416" progId="TCLayout.ActiveDocument.1">
                   <p:embed/>
                   <p:pic>
                     <p:nvPicPr>
@@ -4340,7 +4345,7 @@
                       <p:nvPr/>
                     </p:nvPicPr>
                     <p:blipFill>
-                      <a:blip r:embed="rId11"/>
+                      <a:blip r:embed="rId8"/>
                       <a:stretch>
                         <a:fillRect/>
                       </a:stretch>
@@ -4619,7 +4624,7 @@
                 <a:tabLst/>
                 <a:defRPr/>
               </a:pPr>
-              <a:t>‹#›</a:t>
+              <a:t>‹Nº›</a:t>
             </a:fld>
             <a:endParaRPr kumimoji="0" lang="en-US" sz="900" b="0" i="0" u="none" strike="noStrike" kern="1200" cap="none" spc="0" normalizeH="0" baseline="0" noProof="0">
               <a:ln>
@@ -4695,7 +4700,7 @@
           <p:nvPr userDrawn="1"/>
         </p:nvPicPr>
         <p:blipFill rotWithShape="1">
-          <a:blip r:embed="rId12">
+          <a:blip r:embed="rId9">
             <a:clrChange>
               <a:clrFrom>
                 <a:srgbClr val="FFFFFF"/>
@@ -4781,12 +4786,12 @@
           <a:graphicData uri="http://schemas.openxmlformats.org/presentationml/2006/ole">
             <mc:AlternateContent xmlns:mc="http://schemas.openxmlformats.org/markup-compatibility/2006">
               <mc:Choice xmlns:v="urn:schemas-microsoft-com:vml" Requires="v">
-                <p:oleObj name="think-cell Slide" r:id="rId8" imgW="592" imgH="591" progId="TCLayout.ActiveDocument.1">
+                <p:oleObj name="think-cell Slide" r:id="rId6" imgW="592" imgH="591" progId="TCLayout.ActiveDocument.1">
                   <p:embed/>
                 </p:oleObj>
               </mc:Choice>
               <mc:Fallback>
-                <p:oleObj name="think-cell Slide" r:id="rId8" imgW="592" imgH="591" progId="TCLayout.ActiveDocument.1">
+                <p:oleObj name="think-cell Slide" r:id="rId6" imgW="592" imgH="591" progId="TCLayout.ActiveDocument.1">
                   <p:embed/>
                   <p:pic>
                     <p:nvPicPr>
@@ -4801,7 +4806,7 @@
                       <p:nvPr/>
                     </p:nvPicPr>
                     <p:blipFill>
-                      <a:blip r:embed="rId9"/>
+                      <a:blip r:embed="rId7"/>
                       <a:stretch>
                         <a:fillRect/>
                       </a:stretch>
@@ -4967,7 +4972,7 @@
                 </a:spcAft>
                 <a:defRPr/>
               </a:pPr>
-              <a:t>‹#›</a:t>
+              <a:t>‹Nº›</a:t>
             </a:fld>
             <a:endParaRPr lang="en-US" sz="900" b="0">
               <a:solidFill>
@@ -5092,7 +5097,7 @@
           <p:nvPr userDrawn="1"/>
         </p:nvPicPr>
         <p:blipFill rotWithShape="1">
-          <a:blip r:embed="rId10"/>
+          <a:blip r:embed="rId8"/>
           <a:srcRect l="16758" t="20725" r="11635" b="24190"/>
           <a:stretch/>
         </p:blipFill>
@@ -5167,12 +5172,12 @@
           <a:graphicData uri="http://schemas.openxmlformats.org/presentationml/2006/ole">
             <mc:AlternateContent xmlns:mc="http://schemas.openxmlformats.org/markup-compatibility/2006">
               <mc:Choice xmlns:v="urn:schemas-microsoft-com:vml" Requires="v">
-                <p:oleObj name="think-cell Slide" r:id="rId6" imgW="592" imgH="591" progId="TCLayout.ActiveDocument.1">
+                <p:oleObj name="think-cell Slide" r:id="rId4" imgW="592" imgH="591" progId="TCLayout.ActiveDocument.1">
                   <p:embed/>
                 </p:oleObj>
               </mc:Choice>
               <mc:Fallback>
-                <p:oleObj name="think-cell Slide" r:id="rId6" imgW="592" imgH="591" progId="TCLayout.ActiveDocument.1">
+                <p:oleObj name="think-cell Slide" r:id="rId4" imgW="592" imgH="591" progId="TCLayout.ActiveDocument.1">
                   <p:embed/>
                   <p:pic>
                     <p:nvPicPr>
@@ -5187,7 +5192,7 @@
                       <p:nvPr/>
                     </p:nvPicPr>
                     <p:blipFill>
-                      <a:blip r:embed="rId7"/>
+                      <a:blip r:embed="rId5"/>
                       <a:stretch>
                         <a:fillRect/>
                       </a:stretch>
@@ -5276,7 +5281,7 @@
                 </a:spcAft>
                 <a:defRPr/>
               </a:pPr>
-              <a:t>‹#›</a:t>
+              <a:t>‹Nº›</a:t>
             </a:fld>
             <a:endParaRPr lang="en-US" sz="900" b="0">
               <a:solidFill>
@@ -5304,7 +5309,7 @@
           <p:nvPr userDrawn="1"/>
         </p:nvPicPr>
         <p:blipFill rotWithShape="1">
-          <a:blip r:embed="rId8"/>
+          <a:blip r:embed="rId6"/>
           <a:srcRect l="16758" t="20725" r="11635" b="24190"/>
           <a:stretch/>
         </p:blipFill>
@@ -5379,12 +5384,12 @@
           <a:graphicData uri="http://schemas.openxmlformats.org/presentationml/2006/ole">
             <mc:AlternateContent xmlns:mc="http://schemas.openxmlformats.org/markup-compatibility/2006">
               <mc:Choice xmlns:v="urn:schemas-microsoft-com:vml" Requires="v">
-                <p:oleObj name="think-cell Slide" r:id="rId4" imgW="592" imgH="591" progId="TCLayout.ActiveDocument.1">
+                <p:oleObj name="think-cell Slide" r:id="rId3" imgW="592" imgH="591" progId="TCLayout.ActiveDocument.1">
                   <p:embed/>
                 </p:oleObj>
               </mc:Choice>
               <mc:Fallback>
-                <p:oleObj name="think-cell Slide" r:id="rId4" imgW="592" imgH="591" progId="TCLayout.ActiveDocument.1">
+                <p:oleObj name="think-cell Slide" r:id="rId3" imgW="592" imgH="591" progId="TCLayout.ActiveDocument.1">
                   <p:embed/>
                   <p:pic>
                     <p:nvPicPr>
@@ -5399,7 +5404,7 @@
                       <p:nvPr/>
                     </p:nvPicPr>
                     <p:blipFill>
-                      <a:blip r:embed="rId5"/>
+                      <a:blip r:embed="rId4"/>
                       <a:stretch>
                         <a:fillRect/>
                       </a:stretch>
@@ -6551,7 +6556,7 @@
           </a:ln>
           <a:extLst>
             <a:ext uri="{C572A759-6A51-4108-AA02-DFA0A04FC94B}">
-              <ma14:wrappingTextBoxFlag xmlns:m="http://schemas.openxmlformats.org/officeDocument/2006/math" xmlns:a14="http://schemas.microsoft.com/office/drawing/2010/main" xmlns:ma14="http://schemas.microsoft.com/office/mac/drawingml/2011/main" xmlns="" val="1"/>
+              <ma14:wrappingTextBoxFlag xmlns="" xmlns:ma14="http://schemas.microsoft.com/office/mac/drawingml/2011/main" xmlns:a14="http://schemas.microsoft.com/office/drawing/2010/main" xmlns:m="http://schemas.openxmlformats.org/officeDocument/2006/math" val="1"/>
             </a:ext>
           </a:extLst>
         </p:spPr>
@@ -7033,7 +7038,7 @@
                 </a:spcAft>
                 <a:defRPr/>
               </a:pPr>
-              <a:t>‹#›</a:t>
+              <a:t>‹Nº›</a:t>
             </a:fld>
             <a:endParaRPr lang="en-US" sz="1200" b="0">
               <a:solidFill>
@@ -7073,7 +7078,7 @@
           </a:ln>
           <a:extLst>
             <a:ext uri="{C572A759-6A51-4108-AA02-DFA0A04FC94B}">
-              <ma14:wrappingTextBoxFlag xmlns:ma14="http://schemas.microsoft.com/office/mac/drawingml/2011/main" xmlns:a14="http://schemas.microsoft.com/office/drawing/2010/main" xmlns:m="http://schemas.openxmlformats.org/officeDocument/2006/math" xmlns="" val="1"/>
+              <ma14:wrappingTextBoxFlag xmlns="" xmlns:m="http://schemas.openxmlformats.org/officeDocument/2006/math" xmlns:a14="http://schemas.microsoft.com/office/drawing/2010/main" xmlns:ma14="http://schemas.microsoft.com/office/mac/drawingml/2011/main" val="1"/>
             </a:ext>
           </a:extLst>
         </p:spPr>
@@ -7743,12 +7748,12 @@
           <a:graphicData uri="http://schemas.openxmlformats.org/presentationml/2006/ole">
             <mc:AlternateContent xmlns:mc="http://schemas.openxmlformats.org/markup-compatibility/2006">
               <mc:Choice xmlns:v="urn:schemas-microsoft-com:vml" Requires="v">
-                <p:oleObj name="think-cell Slide" r:id="rId7" imgW="592" imgH="591" progId="TCLayout.ActiveDocument.1">
+                <p:oleObj name="think-cell Slide" r:id="rId6" imgW="592" imgH="591" progId="TCLayout.ActiveDocument.1">
                   <p:embed/>
                 </p:oleObj>
               </mc:Choice>
               <mc:Fallback>
-                <p:oleObj name="think-cell Slide" r:id="rId7" imgW="592" imgH="591" progId="TCLayout.ActiveDocument.1">
+                <p:oleObj name="think-cell Slide" r:id="rId6" imgW="592" imgH="591" progId="TCLayout.ActiveDocument.1">
                   <p:embed/>
                   <p:pic>
                     <p:nvPicPr>
@@ -7763,7 +7768,7 @@
                       <p:nvPr/>
                     </p:nvPicPr>
                     <p:blipFill>
-                      <a:blip r:embed="rId8"/>
+                      <a:blip r:embed="rId7"/>
                       <a:stretch>
                         <a:fillRect/>
                       </a:stretch>
@@ -7933,7 +7938,7 @@
           <p:nvPr>
             <p:ph type="title"/>
             <p:custDataLst>
-              <p:tags r:id="rId5"/>
+              <p:tags r:id="rId4"/>
             </p:custDataLst>
           </p:nvPr>
         </p:nvSpPr>
@@ -7990,7 +7995,7 @@
           <p:nvPr userDrawn="1"/>
         </p:nvPicPr>
         <p:blipFill rotWithShape="1">
-          <a:blip r:embed="rId9"/>
+          <a:blip r:embed="rId8"/>
           <a:srcRect l="16758" t="20725" r="11635" b="24190"/>
           <a:stretch/>
         </p:blipFill>
@@ -11334,7 +11339,7 @@
                 </a:spcAft>
                 <a:defRPr/>
               </a:pPr>
-              <a:t>‹#›</a:t>
+              <a:t>‹Nº›</a:t>
             </a:fld>
             <a:endParaRPr lang="en-US" sz="1200" b="0">
               <a:solidFill>
@@ -11374,7 +11379,7 @@
           </a:ln>
           <a:extLst>
             <a:ext uri="{C572A759-6A51-4108-AA02-DFA0A04FC94B}">
-              <ma14:wrappingTextBoxFlag xmlns:ma14="http://schemas.microsoft.com/office/mac/drawingml/2011/main" xmlns:a14="http://schemas.microsoft.com/office/drawing/2010/main" xmlns:m="http://schemas.openxmlformats.org/officeDocument/2006/math" xmlns="" val="1"/>
+              <ma14:wrappingTextBoxFlag xmlns="" xmlns:m="http://schemas.openxmlformats.org/officeDocument/2006/math" xmlns:a14="http://schemas.microsoft.com/office/drawing/2010/main" xmlns:ma14="http://schemas.microsoft.com/office/mac/drawingml/2011/main" val="1"/>
             </a:ext>
           </a:extLst>
         </p:spPr>
@@ -12110,7 +12115,7 @@
                 </a:spcAft>
                 <a:defRPr/>
               </a:pPr>
-              <a:t>‹#›</a:t>
+              <a:t>‹Nº›</a:t>
             </a:fld>
             <a:endParaRPr lang="en-US" sz="1200" b="0">
               <a:solidFill>
@@ -12150,7 +12155,7 @@
           </a:ln>
           <a:extLst>
             <a:ext uri="{C572A759-6A51-4108-AA02-DFA0A04FC94B}">
-              <ma14:wrappingTextBoxFlag xmlns:ma14="http://schemas.microsoft.com/office/mac/drawingml/2011/main" xmlns:a14="http://schemas.microsoft.com/office/drawing/2010/main" xmlns:m="http://schemas.openxmlformats.org/officeDocument/2006/math" xmlns="" val="1"/>
+              <ma14:wrappingTextBoxFlag xmlns="" xmlns:m="http://schemas.openxmlformats.org/officeDocument/2006/math" xmlns:a14="http://schemas.microsoft.com/office/drawing/2010/main" xmlns:ma14="http://schemas.microsoft.com/office/mac/drawingml/2011/main" val="1"/>
             </a:ext>
           </a:extLst>
         </p:spPr>
@@ -12882,7 +12887,7 @@
                 </a:spcAft>
                 <a:defRPr/>
               </a:pPr>
-              <a:t>‹#›</a:t>
+              <a:t>‹Nº›</a:t>
             </a:fld>
             <a:endParaRPr lang="en-US" sz="1200" b="0">
               <a:solidFill>
@@ -12922,7 +12927,7 @@
           </a:ln>
           <a:extLst>
             <a:ext uri="{C572A759-6A51-4108-AA02-DFA0A04FC94B}">
-              <ma14:wrappingTextBoxFlag xmlns:ma14="http://schemas.microsoft.com/office/mac/drawingml/2011/main" xmlns:a14="http://schemas.microsoft.com/office/drawing/2010/main" xmlns:m="http://schemas.openxmlformats.org/officeDocument/2006/math" xmlns="" val="1"/>
+              <ma14:wrappingTextBoxFlag xmlns="" xmlns:m="http://schemas.openxmlformats.org/officeDocument/2006/math" xmlns:a14="http://schemas.microsoft.com/office/drawing/2010/main" xmlns:ma14="http://schemas.microsoft.com/office/mac/drawingml/2011/main" val="1"/>
             </a:ext>
           </a:extLst>
         </p:spPr>
@@ -13654,7 +13659,7 @@
                 </a:spcAft>
                 <a:defRPr/>
               </a:pPr>
-              <a:t>‹#›</a:t>
+              <a:t>‹Nº›</a:t>
             </a:fld>
             <a:endParaRPr lang="en-US" sz="1200" b="0">
               <a:solidFill>
@@ -13694,7 +13699,7 @@
           </a:ln>
           <a:extLst>
             <a:ext uri="{C572A759-6A51-4108-AA02-DFA0A04FC94B}">
-              <ma14:wrappingTextBoxFlag xmlns:m="http://schemas.openxmlformats.org/officeDocument/2006/math" xmlns:a14="http://schemas.microsoft.com/office/drawing/2010/main" xmlns:ma14="http://schemas.microsoft.com/office/mac/drawingml/2011/main" xmlns="" val="1"/>
+              <ma14:wrappingTextBoxFlag xmlns="" xmlns:ma14="http://schemas.microsoft.com/office/mac/drawingml/2011/main" xmlns:a14="http://schemas.microsoft.com/office/drawing/2010/main" xmlns:m="http://schemas.openxmlformats.org/officeDocument/2006/math" val="1"/>
             </a:ext>
           </a:extLst>
         </p:spPr>
@@ -14450,7 +14455,7 @@
                 </a:spcAft>
                 <a:defRPr/>
               </a:pPr>
-              <a:t>‹#›</a:t>
+              <a:t>‹Nº›</a:t>
             </a:fld>
             <a:endParaRPr lang="en-US" sz="1200" b="0">
               <a:solidFill>
@@ -14490,7 +14495,7 @@
           </a:ln>
           <a:extLst>
             <a:ext uri="{C572A759-6A51-4108-AA02-DFA0A04FC94B}">
-              <ma14:wrappingTextBoxFlag xmlns:m="http://schemas.openxmlformats.org/officeDocument/2006/math" xmlns:a14="http://schemas.microsoft.com/office/drawing/2010/main" xmlns:ma14="http://schemas.microsoft.com/office/mac/drawingml/2011/main" xmlns="" val="1"/>
+              <ma14:wrappingTextBoxFlag xmlns="" xmlns:ma14="http://schemas.microsoft.com/office/mac/drawingml/2011/main" xmlns:a14="http://schemas.microsoft.com/office/drawing/2010/main" xmlns:m="http://schemas.openxmlformats.org/officeDocument/2006/math" val="1"/>
             </a:ext>
           </a:extLst>
         </p:spPr>
@@ -14578,12 +14583,12 @@
           <a:graphicData uri="http://schemas.openxmlformats.org/presentationml/2006/ole">
             <mc:AlternateContent xmlns:mc="http://schemas.openxmlformats.org/markup-compatibility/2006">
               <mc:Choice xmlns:v="urn:schemas-microsoft-com:vml" Requires="v">
-                <p:oleObj name="think-cell Slide" r:id="rId9" imgW="413" imgH="416" progId="TCLayout.ActiveDocument.1">
+                <p:oleObj name="think-cell Slide" r:id="rId6" imgW="413" imgH="416" progId="TCLayout.ActiveDocument.1">
                   <p:embed/>
                 </p:oleObj>
               </mc:Choice>
               <mc:Fallback>
-                <p:oleObj name="think-cell Slide" r:id="rId9" imgW="413" imgH="416" progId="TCLayout.ActiveDocument.1">
+                <p:oleObj name="think-cell Slide" r:id="rId6" imgW="413" imgH="416" progId="TCLayout.ActiveDocument.1">
                   <p:embed/>
                   <p:pic>
                     <p:nvPicPr>
@@ -14598,7 +14603,7 @@
                       <p:nvPr/>
                     </p:nvPicPr>
                     <p:blipFill>
-                      <a:blip r:embed="rId10"/>
+                      <a:blip r:embed="rId7"/>
                       <a:stretch>
                         <a:fillRect/>
                       </a:stretch>
@@ -14710,7 +14715,7 @@
           </p:cNvSpPr>
           <p:nvPr userDrawn="1">
             <p:custDataLst>
-              <p:tags r:id="rId4"/>
+              <p:tags r:id="rId3"/>
             </p:custDataLst>
           </p:nvPr>
         </p:nvSpPr>
@@ -14764,7 +14769,7 @@
                 </a:spcAft>
                 <a:defRPr/>
               </a:pPr>
-              <a:t>‹#›</a:t>
+              <a:t>‹Nº›</a:t>
             </a:fld>
             <a:endParaRPr lang="en-US" sz="900" b="0">
               <a:solidFill>
@@ -14792,7 +14797,7 @@
           <p:nvPr>
             <p:ph type="title"/>
             <p:custDataLst>
-              <p:tags r:id="rId7"/>
+              <p:tags r:id="rId4"/>
             </p:custDataLst>
           </p:nvPr>
         </p:nvSpPr>
@@ -15447,7 +15452,7 @@
                 </a:spcAft>
                 <a:defRPr/>
               </a:pPr>
-              <a:t>‹#›</a:t>
+              <a:t>‹Nº›</a:t>
             </a:fld>
             <a:endParaRPr lang="en-US" sz="1200" b="0">
               <a:solidFill>
@@ -15487,7 +15492,7 @@
           </a:ln>
           <a:extLst>
             <a:ext uri="{C572A759-6A51-4108-AA02-DFA0A04FC94B}">
-              <ma14:wrappingTextBoxFlag xmlns:m="http://schemas.openxmlformats.org/officeDocument/2006/math" xmlns:a14="http://schemas.microsoft.com/office/drawing/2010/main" xmlns:ma14="http://schemas.microsoft.com/office/mac/drawingml/2011/main" xmlns="" val="1"/>
+              <ma14:wrappingTextBoxFlag xmlns="" xmlns:ma14="http://schemas.microsoft.com/office/mac/drawingml/2011/main" xmlns:a14="http://schemas.microsoft.com/office/drawing/2010/main" xmlns:m="http://schemas.openxmlformats.org/officeDocument/2006/math" val="1"/>
             </a:ext>
           </a:extLst>
         </p:spPr>
@@ -15951,7 +15956,7 @@
                 </a:spcAft>
                 <a:defRPr/>
               </a:pPr>
-              <a:t>‹#›</a:t>
+              <a:t>‹Nº›</a:t>
             </a:fld>
             <a:endParaRPr lang="en-US" sz="1200" b="0">
               <a:solidFill>
@@ -15991,7 +15996,7 @@
           </a:ln>
           <a:extLst>
             <a:ext uri="{C572A759-6A51-4108-AA02-DFA0A04FC94B}">
-              <ma14:wrappingTextBoxFlag xmlns:m="http://schemas.openxmlformats.org/officeDocument/2006/math" xmlns:a14="http://schemas.microsoft.com/office/drawing/2010/main" xmlns:ma14="http://schemas.microsoft.com/office/mac/drawingml/2011/main" xmlns="" val="1"/>
+              <ma14:wrappingTextBoxFlag xmlns="" xmlns:ma14="http://schemas.microsoft.com/office/mac/drawingml/2011/main" xmlns:a14="http://schemas.microsoft.com/office/drawing/2010/main" xmlns:m="http://schemas.openxmlformats.org/officeDocument/2006/math" val="1"/>
             </a:ext>
           </a:extLst>
         </p:spPr>
@@ -17173,7 +17178,7 @@
                 </a:spcAft>
                 <a:defRPr/>
               </a:pPr>
-              <a:t>‹#›</a:t>
+              <a:t>‹Nº›</a:t>
             </a:fld>
             <a:endParaRPr lang="en-US" sz="900" b="0">
               <a:solidFill>
@@ -17615,12 +17620,12 @@
           <a:graphicData uri="http://schemas.openxmlformats.org/presentationml/2006/ole">
             <mc:AlternateContent xmlns:mc="http://schemas.openxmlformats.org/markup-compatibility/2006">
               <mc:Choice xmlns:v="urn:schemas-microsoft-com:vml" Requires="v">
-                <p:oleObj name="think-cell Slide" r:id="rId9" imgW="413" imgH="416" progId="TCLayout.ActiveDocument.1">
+                <p:oleObj name="think-cell Slide" r:id="rId6" imgW="413" imgH="416" progId="TCLayout.ActiveDocument.1">
                   <p:embed/>
                 </p:oleObj>
               </mc:Choice>
               <mc:Fallback>
-                <p:oleObj name="think-cell Slide" r:id="rId9" imgW="413" imgH="416" progId="TCLayout.ActiveDocument.1">
+                <p:oleObj name="think-cell Slide" r:id="rId6" imgW="413" imgH="416" progId="TCLayout.ActiveDocument.1">
                   <p:embed/>
                   <p:pic>
                     <p:nvPicPr>
@@ -17635,7 +17640,7 @@
                       <p:nvPr/>
                     </p:nvPicPr>
                     <p:blipFill>
-                      <a:blip r:embed="rId10"/>
+                      <a:blip r:embed="rId7"/>
                       <a:stretch>
                         <a:fillRect/>
                       </a:stretch>
@@ -17795,7 +17800,7 @@
           </p:cNvSpPr>
           <p:nvPr userDrawn="1">
             <p:custDataLst>
-              <p:tags r:id="rId4"/>
+              <p:tags r:id="rId3"/>
             </p:custDataLst>
           </p:nvPr>
         </p:nvSpPr>
@@ -17849,7 +17854,7 @@
                 </a:spcAft>
                 <a:defRPr/>
               </a:pPr>
-              <a:t>‹#›</a:t>
+              <a:t>‹Nº›</a:t>
             </a:fld>
             <a:endParaRPr lang="en-US" sz="900" b="0">
               <a:solidFill>
@@ -17877,7 +17882,7 @@
           <p:nvPr userDrawn="1">
             <p:ph type="title" hasCustomPrompt="1"/>
             <p:custDataLst>
-              <p:tags r:id="rId7"/>
+              <p:tags r:id="rId4"/>
             </p:custDataLst>
           </p:nvPr>
         </p:nvSpPr>
@@ -17972,12 +17977,12 @@
           <a:graphicData uri="http://schemas.openxmlformats.org/presentationml/2006/ole">
             <mc:AlternateContent xmlns:mc="http://schemas.openxmlformats.org/markup-compatibility/2006">
               <mc:Choice xmlns:v="urn:schemas-microsoft-com:vml" Requires="v">
-                <p:oleObj name="think-cell Slide" r:id="rId8" imgW="592" imgH="591" progId="TCLayout.ActiveDocument.1">
+                <p:oleObj name="think-cell Slide" r:id="rId6" imgW="592" imgH="591" progId="TCLayout.ActiveDocument.1">
                   <p:embed/>
                 </p:oleObj>
               </mc:Choice>
               <mc:Fallback>
-                <p:oleObj name="think-cell Slide" r:id="rId8" imgW="592" imgH="591" progId="TCLayout.ActiveDocument.1">
+                <p:oleObj name="think-cell Slide" r:id="rId6" imgW="592" imgH="591" progId="TCLayout.ActiveDocument.1">
                   <p:embed/>
                   <p:pic>
                     <p:nvPicPr>
@@ -17992,7 +17997,7 @@
                       <p:nvPr/>
                     </p:nvPicPr>
                     <p:blipFill>
-                      <a:blip r:embed="rId9"/>
+                      <a:blip r:embed="rId7"/>
                       <a:stretch>
                         <a:fillRect/>
                       </a:stretch>
@@ -18211,7 +18216,7 @@
                 </a:spcAft>
                 <a:defRPr/>
               </a:pPr>
-              <a:t>‹#›</a:t>
+              <a:t>‹Nº›</a:t>
             </a:fld>
             <a:endParaRPr lang="en-US" sz="900" b="0">
               <a:solidFill>
@@ -18285,12 +18290,12 @@
           <a:graphicData uri="http://schemas.openxmlformats.org/presentationml/2006/ole">
             <mc:AlternateContent xmlns:mc="http://schemas.openxmlformats.org/markup-compatibility/2006">
               <mc:Choice xmlns:v="urn:schemas-microsoft-com:vml" Requires="v">
-                <p:oleObj name="think-cell Slide" r:id="rId8" imgW="592" imgH="591" progId="TCLayout.ActiveDocument.1">
+                <p:oleObj name="think-cell Slide" r:id="rId6" imgW="592" imgH="591" progId="TCLayout.ActiveDocument.1">
                   <p:embed/>
                 </p:oleObj>
               </mc:Choice>
               <mc:Fallback>
-                <p:oleObj name="think-cell Slide" r:id="rId8" imgW="592" imgH="591" progId="TCLayout.ActiveDocument.1">
+                <p:oleObj name="think-cell Slide" r:id="rId6" imgW="592" imgH="591" progId="TCLayout.ActiveDocument.1">
                   <p:embed/>
                   <p:pic>
                     <p:nvPicPr>
@@ -18305,7 +18310,7 @@
                       <p:nvPr/>
                     </p:nvPicPr>
                     <p:blipFill>
-                      <a:blip r:embed="rId9"/>
+                      <a:blip r:embed="rId7"/>
                       <a:stretch>
                         <a:fillRect/>
                       </a:stretch>
@@ -18521,7 +18526,7 @@
                 </a:spcAft>
                 <a:defRPr/>
               </a:pPr>
-              <a:t>‹#›</a:t>
+              <a:t>‹Nº›</a:t>
             </a:fld>
             <a:endParaRPr lang="en-US" sz="900" b="0">
               <a:solidFill>
@@ -18595,12 +18600,12 @@
           <a:graphicData uri="http://schemas.openxmlformats.org/presentationml/2006/ole">
             <mc:AlternateContent xmlns:mc="http://schemas.openxmlformats.org/markup-compatibility/2006">
               <mc:Choice xmlns:v="urn:schemas-microsoft-com:vml" Requires="v">
-                <p:oleObj name="think-cell Slide" r:id="rId8" imgW="592" imgH="591" progId="TCLayout.ActiveDocument.1">
+                <p:oleObj name="think-cell Slide" r:id="rId6" imgW="592" imgH="591" progId="TCLayout.ActiveDocument.1">
                   <p:embed/>
                 </p:oleObj>
               </mc:Choice>
               <mc:Fallback>
-                <p:oleObj name="think-cell Slide" r:id="rId8" imgW="592" imgH="591" progId="TCLayout.ActiveDocument.1">
+                <p:oleObj name="think-cell Slide" r:id="rId6" imgW="592" imgH="591" progId="TCLayout.ActiveDocument.1">
                   <p:embed/>
                   <p:pic>
                     <p:nvPicPr>
@@ -18615,7 +18620,7 @@
                       <p:nvPr/>
                     </p:nvPicPr>
                     <p:blipFill>
-                      <a:blip r:embed="rId9"/>
+                      <a:blip r:embed="rId7"/>
                       <a:stretch>
                         <a:fillRect/>
                       </a:stretch>
@@ -18826,7 +18831,7 @@
                 </a:spcAft>
                 <a:defRPr/>
               </a:pPr>
-              <a:t>‹#›</a:t>
+              <a:t>‹Nº›</a:t>
             </a:fld>
             <a:endParaRPr lang="en-US" sz="900" b="0">
               <a:solidFill>
@@ -18900,12 +18905,12 @@
           <a:graphicData uri="http://schemas.openxmlformats.org/presentationml/2006/ole">
             <mc:AlternateContent xmlns:mc="http://schemas.openxmlformats.org/markup-compatibility/2006">
               <mc:Choice xmlns:v="urn:schemas-microsoft-com:vml" Requires="v">
-                <p:oleObj name="think-cell Slide" r:id="rId9" imgW="592" imgH="591" progId="TCLayout.ActiveDocument.1">
+                <p:oleObj name="think-cell Slide" r:id="rId6" imgW="592" imgH="591" progId="TCLayout.ActiveDocument.1">
                   <p:embed/>
                 </p:oleObj>
               </mc:Choice>
               <mc:Fallback>
-                <p:oleObj name="think-cell Slide" r:id="rId9" imgW="592" imgH="591" progId="TCLayout.ActiveDocument.1">
+                <p:oleObj name="think-cell Slide" r:id="rId6" imgW="592" imgH="591" progId="TCLayout.ActiveDocument.1">
                   <p:embed/>
                   <p:pic>
                     <p:nvPicPr>
@@ -18920,7 +18925,7 @@
                       <p:nvPr/>
                     </p:nvPicPr>
                     <p:blipFill>
-                      <a:blip r:embed="rId10"/>
+                      <a:blip r:embed="rId7"/>
                       <a:stretch>
                         <a:fillRect/>
                       </a:stretch>
@@ -19080,7 +19085,7 @@
           </p:cNvSpPr>
           <p:nvPr userDrawn="1">
             <p:custDataLst>
-              <p:tags r:id="rId5"/>
+              <p:tags r:id="rId4"/>
             </p:custDataLst>
           </p:nvPr>
         </p:nvSpPr>
@@ -19134,7 +19139,7 @@
                 </a:spcAft>
                 <a:defRPr/>
               </a:pPr>
-              <a:t>‹#›</a:t>
+              <a:t>‹Nº›</a:t>
             </a:fld>
             <a:endParaRPr lang="en-US" sz="900" b="0">
               <a:solidFill>
@@ -19208,12 +19213,12 @@
           <a:graphicData uri="http://schemas.openxmlformats.org/presentationml/2006/ole">
             <mc:AlternateContent xmlns:mc="http://schemas.openxmlformats.org/markup-compatibility/2006">
               <mc:Choice xmlns:v="urn:schemas-microsoft-com:vml" Requires="v">
-                <p:oleObj name="think-cell Slide" r:id="rId10" imgW="413" imgH="416" progId="TCLayout.ActiveDocument.1">
+                <p:oleObj name="think-cell Slide" r:id="rId7" imgW="413" imgH="416" progId="TCLayout.ActiveDocument.1">
                   <p:embed/>
                 </p:oleObj>
               </mc:Choice>
               <mc:Fallback>
-                <p:oleObj name="think-cell Slide" r:id="rId10" imgW="413" imgH="416" progId="TCLayout.ActiveDocument.1">
+                <p:oleObj name="think-cell Slide" r:id="rId7" imgW="413" imgH="416" progId="TCLayout.ActiveDocument.1">
                   <p:embed/>
                   <p:pic>
                     <p:nvPicPr>
@@ -19228,7 +19233,7 @@
                       <p:nvPr/>
                     </p:nvPicPr>
                     <p:blipFill>
-                      <a:blip r:embed="rId11"/>
+                      <a:blip r:embed="rId8"/>
                       <a:stretch>
                         <a:fillRect/>
                       </a:stretch>
@@ -19461,7 +19466,7 @@
                 </a:spcAft>
                 <a:defRPr/>
               </a:pPr>
-              <a:t>‹#›</a:t>
+              <a:t>‹Nº›</a:t>
             </a:fld>
             <a:endParaRPr lang="en-US" sz="900" b="0">
               <a:solidFill>
@@ -19489,7 +19494,7 @@
           <p:nvPr>
             <p:ph type="title"/>
             <p:custDataLst>
-              <p:tags r:id="rId8"/>
+              <p:tags r:id="rId5"/>
             </p:custDataLst>
           </p:nvPr>
         </p:nvSpPr>
@@ -19531,7 +19536,7 @@
           <p:nvPr userDrawn="1"/>
         </p:nvPicPr>
         <p:blipFill rotWithShape="1">
-          <a:blip r:embed="rId12">
+          <a:blip r:embed="rId9">
             <a:clrChange>
               <a:clrFrom>
                 <a:srgbClr val="FFFFFF"/>
@@ -19625,12 +19630,12 @@
           <a:graphicData uri="http://schemas.openxmlformats.org/presentationml/2006/ole">
             <mc:AlternateContent xmlns:mc="http://schemas.openxmlformats.org/markup-compatibility/2006">
               <mc:Choice xmlns:v="urn:schemas-microsoft-com:vml" Requires="v">
-                <p:oleObj name="think-cell Slide" r:id="rId38" imgW="413" imgH="416" progId="TCLayout.ActiveDocument.1">
+                <p:oleObj name="think-cell Slide" r:id="rId37" imgW="413" imgH="416" progId="TCLayout.ActiveDocument.1">
                   <p:embed/>
                 </p:oleObj>
               </mc:Choice>
               <mc:Fallback>
-                <p:oleObj name="think-cell Slide" r:id="rId38" imgW="413" imgH="416" progId="TCLayout.ActiveDocument.1">
+                <p:oleObj name="think-cell Slide" r:id="rId37" imgW="413" imgH="416" progId="TCLayout.ActiveDocument.1">
                   <p:embed/>
                   <p:pic>
                     <p:nvPicPr>
@@ -19645,7 +19650,7 @@
                       <p:nvPr/>
                     </p:nvPicPr>
                     <p:blipFill>
-                      <a:blip r:embed="rId39"/>
+                      <a:blip r:embed="rId38"/>
                       <a:stretch>
                         <a:fillRect/>
                       </a:stretch>
@@ -25411,7 +25416,7 @@
           <p:nvPr>
             <p:ph type="title"/>
             <p:custDataLst>
-              <p:tags r:id="rId21"/>
+              <p:tags r:id="rId20"/>
             </p:custDataLst>
           </p:nvPr>
         </p:nvSpPr>
@@ -25443,7 +25448,7 @@
           <a:p>
             <a:pPr lvl="0"/>
             <a:r>
-              <a:rPr lang="en-US"/>
+              <a:rPr lang="en-US" dirty="0"/>
               <a:t>Click to edit Master title style</a:t>
             </a:r>
           </a:p>
@@ -25461,7 +25466,7 @@
           <p:cNvSpPr txBox="1"/>
           <p:nvPr userDrawn="1">
             <p:custDataLst>
-              <p:tags r:id="rId22"/>
+              <p:tags r:id="rId21"/>
             </p:custDataLst>
           </p:nvPr>
         </p:nvSpPr>
@@ -25686,14 +25691,14 @@
           <a:p>
             <a:pPr lvl="0"/>
             <a:r>
-              <a:rPr lang="en-US"/>
+              <a:rPr lang="en-US" dirty="0"/>
               <a:t>Click to edit Master text styles</a:t>
             </a:r>
           </a:p>
           <a:p>
             <a:pPr lvl="1"/>
             <a:r>
-              <a:rPr lang="en-US"/>
+              <a:rPr lang="en-US" dirty="0"/>
               <a:t>Second level</a:t>
             </a:r>
           </a:p>
@@ -25707,14 +25712,14 @@
           <a:p>
             <a:pPr lvl="3"/>
             <a:r>
-              <a:rPr lang="en-US"/>
+              <a:rPr lang="en-US" dirty="0"/>
               <a:t>Fourth level</a:t>
             </a:r>
           </a:p>
           <a:p>
             <a:pPr lvl="4"/>
             <a:r>
-              <a:rPr lang="en-US"/>
+              <a:rPr lang="en-US" dirty="0"/>
               <a:t>Fifth level</a:t>
             </a:r>
           </a:p>
@@ -26360,7 +26365,7 @@
             </p:cNvGrpSpPr>
             <p:nvPr>
               <p:custDataLst>
-                <p:tags r:id="rId23"/>
+                <p:tags r:id="rId22"/>
               </p:custDataLst>
             </p:nvPr>
           </p:nvGrpSpPr>
@@ -26384,7 +26389,7 @@
               <p:cNvSpPr/>
               <p:nvPr>
                 <p:custDataLst>
-                  <p:tags r:id="rId36"/>
+                  <p:tags r:id="rId35"/>
                 </p:custDataLst>
               </p:nvPr>
             </p:nvSpPr>
@@ -26459,7 +26464,7 @@
               <p:cNvSpPr/>
               <p:nvPr>
                 <p:custDataLst>
-                  <p:tags r:id="rId37"/>
+                  <p:tags r:id="rId36"/>
                 </p:custDataLst>
               </p:nvPr>
             </p:nvSpPr>
@@ -26534,7 +26539,7 @@
             </p:cNvGrpSpPr>
             <p:nvPr>
               <p:custDataLst>
-                <p:tags r:id="rId24"/>
+                <p:tags r:id="rId23"/>
               </p:custDataLst>
             </p:nvPr>
           </p:nvGrpSpPr>
@@ -26558,7 +26563,7 @@
               <p:cNvSpPr/>
               <p:nvPr>
                 <p:custDataLst>
-                  <p:tags r:id="rId34"/>
+                  <p:tags r:id="rId33"/>
                 </p:custDataLst>
               </p:nvPr>
             </p:nvSpPr>
@@ -26633,7 +26638,7 @@
               <p:cNvSpPr/>
               <p:nvPr>
                 <p:custDataLst>
-                  <p:tags r:id="rId35"/>
+                  <p:tags r:id="rId34"/>
                 </p:custDataLst>
               </p:nvPr>
             </p:nvSpPr>
@@ -26708,7 +26713,7 @@
             </p:cNvGrpSpPr>
             <p:nvPr>
               <p:custDataLst>
-                <p:tags r:id="rId25"/>
+                <p:tags r:id="rId24"/>
               </p:custDataLst>
             </p:nvPr>
           </p:nvGrpSpPr>
@@ -26732,7 +26737,7 @@
               <p:cNvSpPr/>
               <p:nvPr>
                 <p:custDataLst>
-                  <p:tags r:id="rId32"/>
+                  <p:tags r:id="rId31"/>
                 </p:custDataLst>
               </p:nvPr>
             </p:nvSpPr>
@@ -26807,7 +26812,7 @@
               <p:cNvSpPr/>
               <p:nvPr>
                 <p:custDataLst>
-                  <p:tags r:id="rId33"/>
+                  <p:tags r:id="rId32"/>
                 </p:custDataLst>
               </p:nvPr>
             </p:nvSpPr>
@@ -26882,7 +26887,7 @@
             </p:cNvGrpSpPr>
             <p:nvPr>
               <p:custDataLst>
-                <p:tags r:id="rId26"/>
+                <p:tags r:id="rId25"/>
               </p:custDataLst>
             </p:nvPr>
           </p:nvGrpSpPr>
@@ -26906,7 +26911,7 @@
               <p:cNvSpPr/>
               <p:nvPr>
                 <p:custDataLst>
-                  <p:tags r:id="rId30"/>
+                  <p:tags r:id="rId29"/>
                 </p:custDataLst>
               </p:nvPr>
             </p:nvSpPr>
@@ -26981,7 +26986,7 @@
               <p:cNvSpPr/>
               <p:nvPr>
                 <p:custDataLst>
-                  <p:tags r:id="rId31"/>
+                  <p:tags r:id="rId30"/>
                 </p:custDataLst>
               </p:nvPr>
             </p:nvSpPr>
@@ -27056,7 +27061,7 @@
             </p:cNvGrpSpPr>
             <p:nvPr>
               <p:custDataLst>
-                <p:tags r:id="rId27"/>
+                <p:tags r:id="rId26"/>
               </p:custDataLst>
             </p:nvPr>
           </p:nvGrpSpPr>
@@ -27080,7 +27085,7 @@
               <p:cNvSpPr/>
               <p:nvPr>
                 <p:custDataLst>
-                  <p:tags r:id="rId28"/>
+                  <p:tags r:id="rId27"/>
                 </p:custDataLst>
               </p:nvPr>
             </p:nvSpPr>
@@ -27155,7 +27160,7 @@
               <p:cNvSpPr/>
               <p:nvPr>
                 <p:custDataLst>
-                  <p:tags r:id="rId29"/>
+                  <p:tags r:id="rId28"/>
                 </p:custDataLst>
               </p:nvPr>
             </p:nvSpPr>
@@ -27768,35 +27773,6 @@
           </p:txBody>
         </p:sp>
       </p:grpSp>
-      <p:pic>
-        <p:nvPicPr>
-          <p:cNvPr id="4" name="Picture 3">
-            <a:extLst>
-              <a:ext uri="{FF2B5EF4-FFF2-40B4-BE49-F238E27FC236}">
-                <a16:creationId xmlns:a16="http://schemas.microsoft.com/office/drawing/2014/main" id="{75C452D5-403F-715C-F9EB-6692848483EB}"/>
-              </a:ext>
-            </a:extLst>
-          </p:cNvPr>
-          <p:cNvPicPr>
-            <a:picLocks noChangeAspect="1"/>
-          </p:cNvPicPr>
-          <p:nvPr userDrawn="1"/>
-        </p:nvPicPr>
-        <p:blipFill rotWithShape="1">
-          <a:blip r:embed="rId40"/>
-          <a:srcRect l="16758" t="20725" r="11635" b="24190"/>
-          <a:stretch/>
-        </p:blipFill>
-        <p:spPr>
-          <a:xfrm>
-            <a:off x="11292840" y="82296"/>
-            <a:ext cx="438912" cy="438912"/>
-          </a:xfrm>
-          <a:prstGeom prst="rect">
-            <a:avLst/>
-          </a:prstGeom>
-        </p:spPr>
-      </p:pic>
       <p:sp>
         <p:nvSpPr>
           <p:cNvPr id="47" name="CuadroTexto 46">
@@ -27839,11 +27815,47 @@
               </a:defRPr>
             </a:pPr>
             <a:r>
-              <a:t>Orange Interna</a:t>
+              <a:rPr dirty="0"/>
+              <a:t>Orange </a:t>
             </a:r>
+            <a:r>
+              <a:rPr lang="es-ES"/>
+              <a:t>España</a:t>
+            </a:r>
+            <a:endParaRPr dirty="0"/>
           </a:p>
         </p:txBody>
       </p:sp>
+      <p:pic>
+        <p:nvPicPr>
+          <p:cNvPr id="46" name="CoverLogo" descr="image.png">
+            <a:extLst>
+              <a:ext uri="{FF2B5EF4-FFF2-40B4-BE49-F238E27FC236}">
+                <a16:creationId xmlns:a16="http://schemas.microsoft.com/office/drawing/2014/main" id="{65733663-2AD1-93ED-002A-8E5D4D5D811B}"/>
+              </a:ext>
+            </a:extLst>
+          </p:cNvPr>
+          <p:cNvPicPr>
+            <a:picLocks noChangeAspect="1"/>
+          </p:cNvPicPr>
+          <p:nvPr userDrawn="1"/>
+        </p:nvPicPr>
+        <p:blipFill>
+          <a:blip r:embed="rId39"/>
+          <a:stretch>
+            <a:fillRect/>
+          </a:stretch>
+        </p:blipFill>
+        <p:spPr>
+          <a:xfrm>
+            <a:off x="11243016" y="82295"/>
+            <a:ext cx="438913" cy="438913"/>
+          </a:xfrm>
+          <a:prstGeom prst="rect">
+            <a:avLst/>
+          </a:prstGeom>
+        </p:spPr>
+      </p:pic>
     </p:spTree>
     <p:extLst>
       <p:ext uri="{BB962C8B-B14F-4D97-AF65-F5344CB8AC3E}">
@@ -28300,12 +28312,12 @@
           <a:graphicData uri="http://schemas.openxmlformats.org/presentationml/2006/ole">
             <mc:AlternateContent xmlns:mc="http://schemas.openxmlformats.org/markup-compatibility/2006">
               <mc:Choice xmlns:v="urn:schemas-microsoft-com:vml" Requires="v">
-                <p:oleObj name="think-cell Slide" r:id="rId41" imgW="413" imgH="416" progId="TCLayout.ActiveDocument.1">
+                <p:oleObj name="think-cell Slide" r:id="rId40" imgW="413" imgH="416" progId="TCLayout.ActiveDocument.1">
                   <p:embed/>
                 </p:oleObj>
               </mc:Choice>
               <mc:Fallback>
-                <p:oleObj name="think-cell Slide" r:id="rId41" imgW="413" imgH="416" progId="TCLayout.ActiveDocument.1">
+                <p:oleObj name="think-cell Slide" r:id="rId40" imgW="413" imgH="416" progId="TCLayout.ActiveDocument.1">
                   <p:embed/>
                   <p:pic>
                     <p:nvPicPr>
@@ -28320,7 +28332,7 @@
                       <p:nvPr/>
                     </p:nvPicPr>
                     <p:blipFill>
-                      <a:blip r:embed="rId42"/>
+                      <a:blip r:embed="rId41"/>
                       <a:stretch>
                         <a:fillRect/>
                       </a:stretch>
@@ -34086,7 +34098,7 @@
           <p:nvPr>
             <p:ph type="title"/>
             <p:custDataLst>
-              <p:tags r:id="rId23"/>
+              <p:tags r:id="rId22"/>
             </p:custDataLst>
           </p:nvPr>
         </p:nvSpPr>
@@ -34136,7 +34148,7 @@
           <p:cNvSpPr txBox="1"/>
           <p:nvPr userDrawn="1">
             <p:custDataLst>
-              <p:tags r:id="rId24"/>
+              <p:tags r:id="rId23"/>
             </p:custDataLst>
           </p:nvPr>
         </p:nvSpPr>
@@ -35060,7 +35072,7 @@
             </p:cNvGrpSpPr>
             <p:nvPr>
               <p:custDataLst>
-                <p:tags r:id="rId26"/>
+                <p:tags r:id="rId25"/>
               </p:custDataLst>
             </p:nvPr>
           </p:nvGrpSpPr>
@@ -35084,7 +35096,7 @@
               <p:cNvSpPr/>
               <p:nvPr>
                 <p:custDataLst>
-                  <p:tags r:id="rId39"/>
+                  <p:tags r:id="rId38"/>
                 </p:custDataLst>
               </p:nvPr>
             </p:nvSpPr>
@@ -35160,7 +35172,7 @@
               <p:cNvSpPr/>
               <p:nvPr>
                 <p:custDataLst>
-                  <p:tags r:id="rId40"/>
+                  <p:tags r:id="rId39"/>
                 </p:custDataLst>
               </p:nvPr>
             </p:nvSpPr>
@@ -35237,7 +35249,7 @@
             </p:cNvGrpSpPr>
             <p:nvPr>
               <p:custDataLst>
-                <p:tags r:id="rId27"/>
+                <p:tags r:id="rId26"/>
               </p:custDataLst>
             </p:nvPr>
           </p:nvGrpSpPr>
@@ -35261,7 +35273,7 @@
               <p:cNvSpPr/>
               <p:nvPr>
                 <p:custDataLst>
-                  <p:tags r:id="rId37"/>
+                  <p:tags r:id="rId36"/>
                 </p:custDataLst>
               </p:nvPr>
             </p:nvSpPr>
@@ -35337,7 +35349,7 @@
               <p:cNvSpPr/>
               <p:nvPr>
                 <p:custDataLst>
-                  <p:tags r:id="rId38"/>
+                  <p:tags r:id="rId37"/>
                 </p:custDataLst>
               </p:nvPr>
             </p:nvSpPr>
@@ -35414,7 +35426,7 @@
             </p:cNvGrpSpPr>
             <p:nvPr>
               <p:custDataLst>
-                <p:tags r:id="rId28"/>
+                <p:tags r:id="rId27"/>
               </p:custDataLst>
             </p:nvPr>
           </p:nvGrpSpPr>
@@ -35438,7 +35450,7 @@
               <p:cNvSpPr/>
               <p:nvPr>
                 <p:custDataLst>
-                  <p:tags r:id="rId35"/>
+                  <p:tags r:id="rId34"/>
                 </p:custDataLst>
               </p:nvPr>
             </p:nvSpPr>
@@ -35514,7 +35526,7 @@
               <p:cNvSpPr/>
               <p:nvPr>
                 <p:custDataLst>
-                  <p:tags r:id="rId36"/>
+                  <p:tags r:id="rId35"/>
                 </p:custDataLst>
               </p:nvPr>
             </p:nvSpPr>
@@ -35591,7 +35603,7 @@
             </p:cNvGrpSpPr>
             <p:nvPr>
               <p:custDataLst>
-                <p:tags r:id="rId29"/>
+                <p:tags r:id="rId28"/>
               </p:custDataLst>
             </p:nvPr>
           </p:nvGrpSpPr>
@@ -35615,7 +35627,7 @@
               <p:cNvSpPr/>
               <p:nvPr>
                 <p:custDataLst>
-                  <p:tags r:id="rId33"/>
+                  <p:tags r:id="rId32"/>
                 </p:custDataLst>
               </p:nvPr>
             </p:nvSpPr>
@@ -35691,7 +35703,7 @@
               <p:cNvSpPr/>
               <p:nvPr>
                 <p:custDataLst>
-                  <p:tags r:id="rId34"/>
+                  <p:tags r:id="rId33"/>
                 </p:custDataLst>
               </p:nvPr>
             </p:nvSpPr>
@@ -35768,7 +35780,7 @@
             </p:cNvGrpSpPr>
             <p:nvPr>
               <p:custDataLst>
-                <p:tags r:id="rId30"/>
+                <p:tags r:id="rId29"/>
               </p:custDataLst>
             </p:nvPr>
           </p:nvGrpSpPr>
@@ -35792,7 +35804,7 @@
               <p:cNvSpPr/>
               <p:nvPr>
                 <p:custDataLst>
-                  <p:tags r:id="rId31"/>
+                  <p:tags r:id="rId30"/>
                 </p:custDataLst>
               </p:nvPr>
             </p:nvSpPr>
@@ -35868,7 +35880,7 @@
               <p:cNvSpPr/>
               <p:nvPr>
                 <p:custDataLst>
-                  <p:tags r:id="rId32"/>
+                  <p:tags r:id="rId31"/>
                 </p:custDataLst>
               </p:nvPr>
             </p:nvSpPr>
@@ -36512,7 +36524,7 @@
           </p:cNvSpPr>
           <p:nvPr userDrawn="1">
             <p:custDataLst>
-              <p:tags r:id="rId25"/>
+              <p:tags r:id="rId24"/>
             </p:custDataLst>
           </p:nvPr>
         </p:nvSpPr>
@@ -36568,7 +36580,7 @@
                 </a:spcAft>
                 <a:defRPr/>
               </a:pPr>
-              <a:t>‹#›</a:t>
+              <a:t>‹Nº›</a:t>
             </a:fld>
             <a:endParaRPr lang="en-US" sz="1200" b="0">
               <a:solidFill>
@@ -36608,7 +36620,7 @@
           </a:ln>
           <a:extLst>
             <a:ext uri="{C572A759-6A51-4108-AA02-DFA0A04FC94B}">
-              <ma14:wrappingTextBoxFlag xmlns:m="http://schemas.openxmlformats.org/officeDocument/2006/math" xmlns:a14="http://schemas.microsoft.com/office/drawing/2010/main" xmlns:ma14="http://schemas.microsoft.com/office/mac/drawingml/2011/main" xmlns="" val="1"/>
+              <ma14:wrappingTextBoxFlag xmlns="" xmlns:ma14="http://schemas.microsoft.com/office/mac/drawingml/2011/main" xmlns:a14="http://schemas.microsoft.com/office/drawing/2010/main" xmlns:m="http://schemas.openxmlformats.org/officeDocument/2006/math" val="1"/>
             </a:ext>
           </a:extLst>
         </p:spPr>
@@ -43816,6 +43828,36 @@
           </p:txBody>
         </p:sp>
       </p:grpSp>
+      <p:pic>
+        <p:nvPicPr>
+          <p:cNvPr id="42" name="Imagen 41">
+            <a:extLst>
+              <a:ext uri="{FF2B5EF4-FFF2-40B4-BE49-F238E27FC236}">
+                <a16:creationId xmlns:a16="http://schemas.microsoft.com/office/drawing/2014/main" id="{446EC647-593F-8CF8-E700-187132CF10B9}"/>
+              </a:ext>
+            </a:extLst>
+          </p:cNvPr>
+          <p:cNvPicPr>
+            <a:picLocks noChangeAspect="1"/>
+          </p:cNvPicPr>
+          <p:nvPr/>
+        </p:nvPicPr>
+        <p:blipFill>
+          <a:blip r:embed="rId2"/>
+          <a:stretch>
+            <a:fillRect/>
+          </a:stretch>
+        </p:blipFill>
+        <p:spPr>
+          <a:xfrm>
+            <a:off x="11184466" y="148419"/>
+            <a:ext cx="644547" cy="644547"/>
+          </a:xfrm>
+          <a:prstGeom prst="rect">
+            <a:avLst/>
+          </a:prstGeom>
+        </p:spPr>
+      </p:pic>
     </p:spTree>
     <p:extLst>
       <p:ext uri="{BB962C8B-B14F-4D97-AF65-F5344CB8AC3E}">
@@ -43856,121 +43898,121 @@
 
 <file path=ppt/tags/tag100.xml><?xml version="1.0" encoding="utf-8"?>
 <p:tagLst xmlns:a="http://schemas.openxmlformats.org/drawingml/2006/main" xmlns:r="http://schemas.openxmlformats.org/officeDocument/2006/relationships" xmlns:p="http://schemas.openxmlformats.org/presentationml/2006/main">
-  <p:tag name="SHAPENAME" val="3. Subtitle"/>
+  <p:tag name="ANGLE" val="3"/>
 </p:tagLst>
 </file>
 
 <file path=ppt/tags/tag101.xml><?xml version="1.0" encoding="utf-8"?>
 <p:tagLst xmlns:a="http://schemas.openxmlformats.org/drawingml/2006/main" xmlns:r="http://schemas.openxmlformats.org/officeDocument/2006/relationships" xmlns:p="http://schemas.openxmlformats.org/presentationml/2006/main">
-  <p:tag name="SHAPENAME" val="5. Source"/>
+  <p:tag name="ANGLE" val="2"/>
 </p:tagLst>
 </file>
 
 <file path=ppt/tags/tag102.xml><?xml version="1.0" encoding="utf-8"?>
 <p:tagLst xmlns:a="http://schemas.openxmlformats.org/drawingml/2006/main" xmlns:r="http://schemas.openxmlformats.org/officeDocument/2006/relationships" xmlns:p="http://schemas.openxmlformats.org/presentationml/2006/main">
-  <p:tag name="SHAPENAME" val="1. On-page tracker"/>
+  <p:tag name="ANGLE" val="2"/>
 </p:tagLst>
 </file>
 
 <file path=ppt/tags/tag103.xml><?xml version="1.0" encoding="utf-8"?>
 <p:tagLst xmlns:a="http://schemas.openxmlformats.org/drawingml/2006/main" xmlns:r="http://schemas.openxmlformats.org/officeDocument/2006/relationships" xmlns:p="http://schemas.openxmlformats.org/presentationml/2006/main">
-  <p:tag name="THINKCELLSHAPEDONOTDELETE" val="thinkcellActiveDocDoNotDelete"/>
+  <p:tag name="ANGLE" val="1"/>
 </p:tagLst>
 </file>
 
 <file path=ppt/tags/tag104.xml><?xml version="1.0" encoding="utf-8"?>
 <p:tagLst xmlns:a="http://schemas.openxmlformats.org/drawingml/2006/main" xmlns:r="http://schemas.openxmlformats.org/officeDocument/2006/relationships" xmlns:p="http://schemas.openxmlformats.org/presentationml/2006/main">
-  <p:tag name="THINKCELLSHAPEDONOTDELETE" val="to9xgrPArEB1mEiMOhB5KGA"/>
+  <p:tag name="ANGLE" val="1"/>
 </p:tagLst>
 </file>
 
 <file path=ppt/tags/tag105.xml><?xml version="1.0" encoding="utf-8"?>
 <p:tagLst xmlns:a="http://schemas.openxmlformats.org/drawingml/2006/main" xmlns:r="http://schemas.openxmlformats.org/officeDocument/2006/relationships" xmlns:p="http://schemas.openxmlformats.org/presentationml/2006/main">
-  <p:tag name="SHAPENAME" val="RectangleLight"/>
+  <p:tag name="THINKCELLSHAPEDONOTDELETE" val="thinkcellActiveDocDoNotDelete"/>
 </p:tagLst>
 </file>
 
 <file path=ppt/tags/tag106.xml><?xml version="1.0" encoding="utf-8"?>
 <p:tagLst xmlns:a="http://schemas.openxmlformats.org/drawingml/2006/main" xmlns:r="http://schemas.openxmlformats.org/officeDocument/2006/relationships" xmlns:p="http://schemas.openxmlformats.org/presentationml/2006/main">
-  <p:tag name="SHAPENAME" val="Slide Number"/>
+  <p:tag name="THINKCELLSHAPEDONOTDELETE" val="tWz9_f.d6YGbJCbK0.Pg2_A"/>
 </p:tagLst>
 </file>
 
 <file path=ppt/tags/tag107.xml><?xml version="1.0" encoding="utf-8"?>
 <p:tagLst xmlns:a="http://schemas.openxmlformats.org/drawingml/2006/main" xmlns:r="http://schemas.openxmlformats.org/officeDocument/2006/relationships" xmlns:p="http://schemas.openxmlformats.org/presentationml/2006/main">
-  <p:tag name="SHAPENAME" val="2. Slide Title"/>
+  <p:tag name="SHAPENAME" val="Documenttype"/>
 </p:tagLst>
 </file>
 
 <file path=ppt/tags/tag108.xml><?xml version="1.0" encoding="utf-8"?>
 <p:tagLst xmlns:a="http://schemas.openxmlformats.org/drawingml/2006/main" xmlns:r="http://schemas.openxmlformats.org/officeDocument/2006/relationships" xmlns:p="http://schemas.openxmlformats.org/presentationml/2006/main">
-  <p:tag name="SHAPENAME" val="3. Subtitle"/>
+  <p:tag name="SHAPENAME" val="Subtitle"/>
 </p:tagLst>
 </file>
 
 <file path=ppt/tags/tag109.xml><?xml version="1.0" encoding="utf-8"?>
 <p:tagLst xmlns:a="http://schemas.openxmlformats.org/drawingml/2006/main" xmlns:r="http://schemas.openxmlformats.org/officeDocument/2006/relationships" xmlns:p="http://schemas.openxmlformats.org/presentationml/2006/main">
-  <p:tag name="SHAPENAME" val="5. Source"/>
+  <p:tag name="SHAPENAME" val="Title"/>
 </p:tagLst>
 </file>
 
 <file path=ppt/tags/tag11.xml><?xml version="1.0" encoding="utf-8"?>
 <p:tagLst xmlns:a="http://schemas.openxmlformats.org/drawingml/2006/main" xmlns:r="http://schemas.openxmlformats.org/officeDocument/2006/relationships" xmlns:p="http://schemas.openxmlformats.org/presentationml/2006/main">
-  <p:tag name="NAME" val="Moon"/>
+  <p:tag name="ANGLE" val="5"/>
 </p:tagLst>
 </file>
 
 <file path=ppt/tags/tag110.xml><?xml version="1.0" encoding="utf-8"?>
 <p:tagLst xmlns:a="http://schemas.openxmlformats.org/drawingml/2006/main" xmlns:r="http://schemas.openxmlformats.org/officeDocument/2006/relationships" xmlns:p="http://schemas.openxmlformats.org/presentationml/2006/main">
-  <p:tag name="SHAPENAME" val="1. On-page tracker"/>
+  <p:tag name="THINKCELLSHAPEDONOTDELETE" val="thinkcellActiveDocDoNotDelete"/>
 </p:tagLst>
 </file>
 
 <file path=ppt/tags/tag111.xml><?xml version="1.0" encoding="utf-8"?>
 <p:tagLst xmlns:a="http://schemas.openxmlformats.org/drawingml/2006/main" xmlns:r="http://schemas.openxmlformats.org/officeDocument/2006/relationships" xmlns:p="http://schemas.openxmlformats.org/presentationml/2006/main">
-  <p:tag name="THINKCELLSHAPEDONOTDELETE" val="thinkcellActiveDocDoNotDelete"/>
+  <p:tag name="THINKCELLSHAPEDONOTDELETE" val="tWz9_f.d6YGbJCbK0.Pg2_A"/>
 </p:tagLst>
 </file>
 
 <file path=ppt/tags/tag112.xml><?xml version="1.0" encoding="utf-8"?>
 <p:tagLst xmlns:a="http://schemas.openxmlformats.org/drawingml/2006/main" xmlns:r="http://schemas.openxmlformats.org/officeDocument/2006/relationships" xmlns:p="http://schemas.openxmlformats.org/presentationml/2006/main">
-  <p:tag name="THINKCELLSHAPEDONOTDELETE" val="txNguF4Gw2mJIhuiFXm5tKQ"/>
+  <p:tag name="SHAPENAME" val="Documenttype"/>
 </p:tagLst>
 </file>
 
 <file path=ppt/tags/tag113.xml><?xml version="1.0" encoding="utf-8"?>
 <p:tagLst xmlns:a="http://schemas.openxmlformats.org/drawingml/2006/main" xmlns:r="http://schemas.openxmlformats.org/officeDocument/2006/relationships" xmlns:p="http://schemas.openxmlformats.org/presentationml/2006/main">
-  <p:tag name="SHAPENAME" val="Slide Number"/>
+  <p:tag name="SHAPENAME" val="Subtitle"/>
 </p:tagLst>
 </file>
 
 <file path=ppt/tags/tag114.xml><?xml version="1.0" encoding="utf-8"?>
 <p:tagLst xmlns:a="http://schemas.openxmlformats.org/drawingml/2006/main" xmlns:r="http://schemas.openxmlformats.org/officeDocument/2006/relationships" xmlns:p="http://schemas.openxmlformats.org/presentationml/2006/main">
-  <p:tag name="SHAPENAME" val="2. Slide Title"/>
+  <p:tag name="SHAPENAME" val="Title"/>
 </p:tagLst>
 </file>
 
 <file path=ppt/tags/tag115.xml><?xml version="1.0" encoding="utf-8"?>
 <p:tagLst xmlns:a="http://schemas.openxmlformats.org/drawingml/2006/main" xmlns:r="http://schemas.openxmlformats.org/officeDocument/2006/relationships" xmlns:p="http://schemas.openxmlformats.org/presentationml/2006/main">
-  <p:tag name="SHAPENAME" val="5. Source"/>
+  <p:tag name="SHAPENAME" val="Slide Number"/>
 </p:tagLst>
 </file>
 
 <file path=ppt/tags/tag116.xml><?xml version="1.0" encoding="utf-8"?>
 <p:tagLst xmlns:a="http://schemas.openxmlformats.org/drawingml/2006/main" xmlns:r="http://schemas.openxmlformats.org/officeDocument/2006/relationships" xmlns:p="http://schemas.openxmlformats.org/presentationml/2006/main">
-  <p:tag name="SHAPENAME" val="1. On-page tracker"/>
+  <p:tag name="THINKCELLSHAPEDONOTDELETE" val="thinkcellActiveDocDoNotDelete"/>
 </p:tagLst>
 </file>
 
 <file path=ppt/tags/tag117.xml><?xml version="1.0" encoding="utf-8"?>
 <p:tagLst xmlns:a="http://schemas.openxmlformats.org/drawingml/2006/main" xmlns:r="http://schemas.openxmlformats.org/officeDocument/2006/relationships" xmlns:p="http://schemas.openxmlformats.org/presentationml/2006/main">
-  <p:tag name="THINKCELLSHAPEDONOTDELETE" val="thinkcellActiveDocDoNotDelete"/>
+  <p:tag name="THINKCELLSHAPEDONOTDELETE" val="t4.oZbb0sXNdu8BCibsgsUw"/>
 </p:tagLst>
 </file>
 
 <file path=ppt/tags/tag118.xml><?xml version="1.0" encoding="utf-8"?>
 <p:tagLst xmlns:a="http://schemas.openxmlformats.org/drawingml/2006/main" xmlns:r="http://schemas.openxmlformats.org/officeDocument/2006/relationships" xmlns:p="http://schemas.openxmlformats.org/presentationml/2006/main">
-  <p:tag name="SHAPENAME" val="Slide Number"/>
+  <p:tag name="SHAPENAME" val="3. Subtitle"/>
 </p:tagLst>
 </file>
 
@@ -43994,121 +44036,121 @@
 
 <file path=ppt/tags/tag121.xml><?xml version="1.0" encoding="utf-8"?>
 <p:tagLst xmlns:a="http://schemas.openxmlformats.org/drawingml/2006/main" xmlns:r="http://schemas.openxmlformats.org/officeDocument/2006/relationships" xmlns:p="http://schemas.openxmlformats.org/presentationml/2006/main">
-  <p:tag name="THINKCELLSHAPEDONOTDELETE" val="thinkcellActiveDocDoNotDelete"/>
+  <p:tag name="SHAPENAME" val="2. Slide Title"/>
 </p:tagLst>
 </file>
 
 <file path=ppt/tags/tag122.xml><?xml version="1.0" encoding="utf-8"?>
 <p:tagLst xmlns:a="http://schemas.openxmlformats.org/drawingml/2006/main" xmlns:r="http://schemas.openxmlformats.org/officeDocument/2006/relationships" xmlns:p="http://schemas.openxmlformats.org/presentationml/2006/main">
-  <p:tag name="SHAPENAME" val="5. Source"/>
+  <p:tag name="THINKCELLSHAPEDONOTDELETE" val="thinkcellActiveDocDoNotDelete"/>
 </p:tagLst>
 </file>
 
 <file path=ppt/tags/tag123.xml><?xml version="1.0" encoding="utf-8"?>
 <p:tagLst xmlns:a="http://schemas.openxmlformats.org/drawingml/2006/main" xmlns:r="http://schemas.openxmlformats.org/officeDocument/2006/relationships" xmlns:p="http://schemas.openxmlformats.org/presentationml/2006/main">
-  <p:tag name="THINKCELLSHAPEDONOTDELETE" val="thinkcellActiveDocDoNotDelete"/>
+  <p:tag name="THINKCELLSHAPEDONOTDELETE" val="t4.oZbb0sXNdu8BCibsgsUw"/>
 </p:tagLst>
 </file>
 
 <file path=ppt/tags/tag124.xml><?xml version="1.0" encoding="utf-8"?>
 <p:tagLst xmlns:a="http://schemas.openxmlformats.org/drawingml/2006/main" xmlns:r="http://schemas.openxmlformats.org/officeDocument/2006/relationships" xmlns:p="http://schemas.openxmlformats.org/presentationml/2006/main">
-  <p:tag name="THINKCELLSHAPEDONOTDELETE" val="txcgoWEzLgA0_64VDvMxGGg"/>
+  <p:tag name="SHAPENAME" val="3. Subtitle"/>
 </p:tagLst>
 </file>
 
 <file path=ppt/tags/tag125.xml><?xml version="1.0" encoding="utf-8"?>
 <p:tagLst xmlns:a="http://schemas.openxmlformats.org/drawingml/2006/main" xmlns:r="http://schemas.openxmlformats.org/officeDocument/2006/relationships" xmlns:p="http://schemas.openxmlformats.org/presentationml/2006/main">
-  <p:tag name="SHAPENAME" val="4. Footnote"/>
+  <p:tag name="SHAPENAME" val="5. Source"/>
 </p:tagLst>
 </file>
 
 <file path=ppt/tags/tag126.xml><?xml version="1.0" encoding="utf-8"?>
 <p:tagLst xmlns:a="http://schemas.openxmlformats.org/drawingml/2006/main" xmlns:r="http://schemas.openxmlformats.org/officeDocument/2006/relationships" xmlns:p="http://schemas.openxmlformats.org/presentationml/2006/main">
-  <p:tag name="SHAPENAME" val="2. Slide Title"/>
+  <p:tag name="SHAPENAME" val="1. On-page tracker"/>
 </p:tagLst>
 </file>
 
 <file path=ppt/tags/tag127.xml><?xml version="1.0" encoding="utf-8"?>
 <p:tagLst xmlns:a="http://schemas.openxmlformats.org/drawingml/2006/main" xmlns:r="http://schemas.openxmlformats.org/officeDocument/2006/relationships" xmlns:p="http://schemas.openxmlformats.org/presentationml/2006/main">
-  <p:tag name="NAME" val="ACET"/>
+  <p:tag name="SHAPENAME" val="2. Slide Title"/>
 </p:tagLst>
 </file>
 
 <file path=ppt/tags/tag128.xml><?xml version="1.0" encoding="utf-8"?>
 <p:tagLst xmlns:a="http://schemas.openxmlformats.org/drawingml/2006/main" xmlns:r="http://schemas.openxmlformats.org/officeDocument/2006/relationships" xmlns:p="http://schemas.openxmlformats.org/presentationml/2006/main">
-  <p:tag name="SHAPENAME" val="Slide Number"/>
+  <p:tag name="THINKCELLSHAPEDONOTDELETE" val="thinkcellActiveDocDoNotDelete"/>
 </p:tagLst>
 </file>
 
 <file path=ppt/tags/tag129.xml><?xml version="1.0" encoding="utf-8"?>
 <p:tagLst xmlns:a="http://schemas.openxmlformats.org/drawingml/2006/main" xmlns:r="http://schemas.openxmlformats.org/officeDocument/2006/relationships" xmlns:p="http://schemas.openxmlformats.org/presentationml/2006/main">
-  <p:tag name="NAME" val="Moon"/>
+  <p:tag name="THINKCELLSHAPEDONOTDELETE" val="trZ96ctUUqJsGDCugslwBCg"/>
 </p:tagLst>
 </file>
 
 <file path=ppt/tags/tag13.xml><?xml version="1.0" encoding="utf-8"?>
 <p:tagLst xmlns:a="http://schemas.openxmlformats.org/drawingml/2006/main" xmlns:r="http://schemas.openxmlformats.org/officeDocument/2006/relationships" xmlns:p="http://schemas.openxmlformats.org/presentationml/2006/main">
-  <p:tag name="ANGLE" val="5"/>
+  <p:tag name="ANGLE" val="4"/>
 </p:tagLst>
 </file>
 
 <file path=ppt/tags/tag130.xml><?xml version="1.0" encoding="utf-8"?>
 <p:tagLst xmlns:a="http://schemas.openxmlformats.org/drawingml/2006/main" xmlns:r="http://schemas.openxmlformats.org/officeDocument/2006/relationships" xmlns:p="http://schemas.openxmlformats.org/presentationml/2006/main">
-  <p:tag name="NAME" val="Moon"/>
+  <p:tag name="SHAPENAME" val="2. Slide Title"/>
 </p:tagLst>
 </file>
 
 <file path=ppt/tags/tag131.xml><?xml version="1.0" encoding="utf-8"?>
 <p:tagLst xmlns:a="http://schemas.openxmlformats.org/drawingml/2006/main" xmlns:r="http://schemas.openxmlformats.org/officeDocument/2006/relationships" xmlns:p="http://schemas.openxmlformats.org/presentationml/2006/main">
-  <p:tag name="NAME" val="Moon"/>
+  <p:tag name="SHAPENAME" val="5. Source"/>
 </p:tagLst>
 </file>
 
 <file path=ppt/tags/tag132.xml><?xml version="1.0" encoding="utf-8"?>
 <p:tagLst xmlns:a="http://schemas.openxmlformats.org/drawingml/2006/main" xmlns:r="http://schemas.openxmlformats.org/officeDocument/2006/relationships" xmlns:p="http://schemas.openxmlformats.org/presentationml/2006/main">
-  <p:tag name="NAME" val="Moon"/>
+  <p:tag name="SHAPENAME" val="1. On-page tracker"/>
 </p:tagLst>
 </file>
 
 <file path=ppt/tags/tag133.xml><?xml version="1.0" encoding="utf-8"?>
 <p:tagLst xmlns:a="http://schemas.openxmlformats.org/drawingml/2006/main" xmlns:r="http://schemas.openxmlformats.org/officeDocument/2006/relationships" xmlns:p="http://schemas.openxmlformats.org/presentationml/2006/main">
-  <p:tag name="NAME" val="Moon"/>
+  <p:tag name="THINKCELLSHAPEDONOTDELETE" val="thinkcellActiveDocDoNotDelete"/>
 </p:tagLst>
 </file>
 
 <file path=ppt/tags/tag134.xml><?xml version="1.0" encoding="utf-8"?>
 <p:tagLst xmlns:a="http://schemas.openxmlformats.org/drawingml/2006/main" xmlns:r="http://schemas.openxmlformats.org/officeDocument/2006/relationships" xmlns:p="http://schemas.openxmlformats.org/presentationml/2006/main">
-  <p:tag name="ANGLE" val="5"/>
+  <p:tag name="THINKCELLSHAPEDONOTDELETE" val="tAvhTnprpZIIVVQCOTQtpLw"/>
 </p:tagLst>
 </file>
 
 <file path=ppt/tags/tag135.xml><?xml version="1.0" encoding="utf-8"?>
 <p:tagLst xmlns:a="http://schemas.openxmlformats.org/drawingml/2006/main" xmlns:r="http://schemas.openxmlformats.org/officeDocument/2006/relationships" xmlns:p="http://schemas.openxmlformats.org/presentationml/2006/main">
-  <p:tag name="ANGLE" val="5"/>
+  <p:tag name="SHAPENAME" val="2. Slide Title"/>
 </p:tagLst>
 </file>
 
 <file path=ppt/tags/tag136.xml><?xml version="1.0" encoding="utf-8"?>
 <p:tagLst xmlns:a="http://schemas.openxmlformats.org/drawingml/2006/main" xmlns:r="http://schemas.openxmlformats.org/officeDocument/2006/relationships" xmlns:p="http://schemas.openxmlformats.org/presentationml/2006/main">
-  <p:tag name="ANGLE" val="4"/>
+  <p:tag name="SHAPENAME" val="5. Source"/>
 </p:tagLst>
 </file>
 
 <file path=ppt/tags/tag137.xml><?xml version="1.0" encoding="utf-8"?>
 <p:tagLst xmlns:a="http://schemas.openxmlformats.org/drawingml/2006/main" xmlns:r="http://schemas.openxmlformats.org/officeDocument/2006/relationships" xmlns:p="http://schemas.openxmlformats.org/presentationml/2006/main">
-  <p:tag name="ANGLE" val="4"/>
+  <p:tag name="SHAPENAME" val="1. On-page tracker"/>
 </p:tagLst>
 </file>
 
 <file path=ppt/tags/tag138.xml><?xml version="1.0" encoding="utf-8"?>
 <p:tagLst xmlns:a="http://schemas.openxmlformats.org/drawingml/2006/main" xmlns:r="http://schemas.openxmlformats.org/officeDocument/2006/relationships" xmlns:p="http://schemas.openxmlformats.org/presentationml/2006/main">
-  <p:tag name="ANGLE" val="3"/>
+  <p:tag name="THINKCELLSHAPEDONOTDELETE" val="thinkcellActiveDocDoNotDelete"/>
 </p:tagLst>
 </file>
 
 <file path=ppt/tags/tag139.xml><?xml version="1.0" encoding="utf-8"?>
 <p:tagLst xmlns:a="http://schemas.openxmlformats.org/drawingml/2006/main" xmlns:r="http://schemas.openxmlformats.org/officeDocument/2006/relationships" xmlns:p="http://schemas.openxmlformats.org/presentationml/2006/main">
-  <p:tag name="ANGLE" val="3"/>
+  <p:tag name="THINKCELLSHAPEDONOTDELETE" val="tVvs3CU0mhZ0iF9VK3Gc_gQ"/>
 </p:tagLst>
 </file>
 
@@ -44120,55 +44162,55 @@
 
 <file path=ppt/tags/tag140.xml><?xml version="1.0" encoding="utf-8"?>
 <p:tagLst xmlns:a="http://schemas.openxmlformats.org/drawingml/2006/main" xmlns:r="http://schemas.openxmlformats.org/officeDocument/2006/relationships" xmlns:p="http://schemas.openxmlformats.org/presentationml/2006/main">
-  <p:tag name="ANGLE" val="2"/>
+  <p:tag name="SHAPENAME" val="2. Slide Title"/>
 </p:tagLst>
 </file>
 
 <file path=ppt/tags/tag141.xml><?xml version="1.0" encoding="utf-8"?>
 <p:tagLst xmlns:a="http://schemas.openxmlformats.org/drawingml/2006/main" xmlns:r="http://schemas.openxmlformats.org/officeDocument/2006/relationships" xmlns:p="http://schemas.openxmlformats.org/presentationml/2006/main">
-  <p:tag name="ANGLE" val="2"/>
+  <p:tag name="SHAPENAME" val="5. Source"/>
 </p:tagLst>
 </file>
 
 <file path=ppt/tags/tag142.xml><?xml version="1.0" encoding="utf-8"?>
 <p:tagLst xmlns:a="http://schemas.openxmlformats.org/drawingml/2006/main" xmlns:r="http://schemas.openxmlformats.org/officeDocument/2006/relationships" xmlns:p="http://schemas.openxmlformats.org/presentationml/2006/main">
-  <p:tag name="ANGLE" val="1"/>
+  <p:tag name="SHAPENAME" val="1. On-page tracker"/>
 </p:tagLst>
 </file>
 
 <file path=ppt/tags/tag143.xml><?xml version="1.0" encoding="utf-8"?>
 <p:tagLst xmlns:a="http://schemas.openxmlformats.org/drawingml/2006/main" xmlns:r="http://schemas.openxmlformats.org/officeDocument/2006/relationships" xmlns:p="http://schemas.openxmlformats.org/presentationml/2006/main">
-  <p:tag name="ANGLE" val="1"/>
+  <p:tag name="THINKCELLSHAPEDONOTDELETE" val="thinkcellActiveDocDoNotDelete"/>
 </p:tagLst>
 </file>
 
 <file path=ppt/tags/tag144.xml><?xml version="1.0" encoding="utf-8"?>
 <p:tagLst xmlns:a="http://schemas.openxmlformats.org/drawingml/2006/main" xmlns:r="http://schemas.openxmlformats.org/officeDocument/2006/relationships" xmlns:p="http://schemas.openxmlformats.org/presentationml/2006/main">
-  <p:tag name="THINKCELLSHAPEDONOTDELETE" val="thinkcellActiveDocDoNotDelete"/>
+  <p:tag name="THINKCELLSHAPEDONOTDELETE" val="tNrcAbB4u0quRffFN3bn3Xw"/>
 </p:tagLst>
 </file>
 
 <file path=ppt/tags/tag145.xml><?xml version="1.0" encoding="utf-8"?>
 <p:tagLst xmlns:a="http://schemas.openxmlformats.org/drawingml/2006/main" xmlns:r="http://schemas.openxmlformats.org/officeDocument/2006/relationships" xmlns:p="http://schemas.openxmlformats.org/presentationml/2006/main">
-  <p:tag name="THINKCELLSHAPEDONOTDELETE" val="tWz9_f.d6YGbJCbK0.Pg2_A"/>
+  <p:tag name="SHAPENAME" val="2. Slide Title"/>
 </p:tagLst>
 </file>
 
 <file path=ppt/tags/tag146.xml><?xml version="1.0" encoding="utf-8"?>
 <p:tagLst xmlns:a="http://schemas.openxmlformats.org/drawingml/2006/main" xmlns:r="http://schemas.openxmlformats.org/officeDocument/2006/relationships" xmlns:p="http://schemas.openxmlformats.org/presentationml/2006/main">
-  <p:tag name="SHAPENAME" val="Documenttype"/>
+  <p:tag name="SHAPENAME" val="3. Subtitle"/>
 </p:tagLst>
 </file>
 
 <file path=ppt/tags/tag147.xml><?xml version="1.0" encoding="utf-8"?>
 <p:tagLst xmlns:a="http://schemas.openxmlformats.org/drawingml/2006/main" xmlns:r="http://schemas.openxmlformats.org/officeDocument/2006/relationships" xmlns:p="http://schemas.openxmlformats.org/presentationml/2006/main">
-  <p:tag name="SHAPENAME" val="Subtitle"/>
+  <p:tag name="SHAPENAME" val="5. Source"/>
 </p:tagLst>
 </file>
 
 <file path=ppt/tags/tag148.xml><?xml version="1.0" encoding="utf-8"?>
 <p:tagLst xmlns:a="http://schemas.openxmlformats.org/drawingml/2006/main" xmlns:r="http://schemas.openxmlformats.org/officeDocument/2006/relationships" xmlns:p="http://schemas.openxmlformats.org/presentationml/2006/main">
-  <p:tag name="SHAPENAME" val="Title"/>
+  <p:tag name="SHAPENAME" val="1. On-page tracker"/>
 </p:tagLst>
 </file>
 
@@ -44180,67 +44222,67 @@
 
 <file path=ppt/tags/tag15.xml><?xml version="1.0" encoding="utf-8"?>
 <p:tagLst xmlns:a="http://schemas.openxmlformats.org/drawingml/2006/main" xmlns:r="http://schemas.openxmlformats.org/officeDocument/2006/relationships" xmlns:p="http://schemas.openxmlformats.org/presentationml/2006/main">
-  <p:tag name="ANGLE" val="4"/>
+  <p:tag name="ANGLE" val="3"/>
 </p:tagLst>
 </file>
 
 <file path=ppt/tags/tag150.xml><?xml version="1.0" encoding="utf-8"?>
 <p:tagLst xmlns:a="http://schemas.openxmlformats.org/drawingml/2006/main" xmlns:r="http://schemas.openxmlformats.org/officeDocument/2006/relationships" xmlns:p="http://schemas.openxmlformats.org/presentationml/2006/main">
-  <p:tag name="THINKCELLSHAPEDONOTDELETE" val="tWz9_f.d6YGbJCbK0.Pg2_A"/>
+  <p:tag name="THINKCELLSHAPEDONOTDELETE" val="tYG_9mniplMrafceMpP.Qwg"/>
 </p:tagLst>
 </file>
 
 <file path=ppt/tags/tag151.xml><?xml version="1.0" encoding="utf-8"?>
 <p:tagLst xmlns:a="http://schemas.openxmlformats.org/drawingml/2006/main" xmlns:r="http://schemas.openxmlformats.org/officeDocument/2006/relationships" xmlns:p="http://schemas.openxmlformats.org/presentationml/2006/main">
-  <p:tag name="SHAPENAME" val="Documenttype"/>
+  <p:tag name="SHAPENAME" val="RectangleLight"/>
 </p:tagLst>
 </file>
 
 <file path=ppt/tags/tag152.xml><?xml version="1.0" encoding="utf-8"?>
 <p:tagLst xmlns:a="http://schemas.openxmlformats.org/drawingml/2006/main" xmlns:r="http://schemas.openxmlformats.org/officeDocument/2006/relationships" xmlns:p="http://schemas.openxmlformats.org/presentationml/2006/main">
-  <p:tag name="SHAPENAME" val="Subtitle"/>
+  <p:tag name="SHAPENAME" val="3. Subtitle"/>
 </p:tagLst>
 </file>
 
 <file path=ppt/tags/tag153.xml><?xml version="1.0" encoding="utf-8"?>
 <p:tagLst xmlns:a="http://schemas.openxmlformats.org/drawingml/2006/main" xmlns:r="http://schemas.openxmlformats.org/officeDocument/2006/relationships" xmlns:p="http://schemas.openxmlformats.org/presentationml/2006/main">
-  <p:tag name="SHAPENAME" val="Title"/>
+  <p:tag name="SHAPENAME" val="5. Source"/>
 </p:tagLst>
 </file>
 
 <file path=ppt/tags/tag154.xml><?xml version="1.0" encoding="utf-8"?>
 <p:tagLst xmlns:a="http://schemas.openxmlformats.org/drawingml/2006/main" xmlns:r="http://schemas.openxmlformats.org/officeDocument/2006/relationships" xmlns:p="http://schemas.openxmlformats.org/presentationml/2006/main">
-  <p:tag name="SHAPENAME" val="Slide Number"/>
+  <p:tag name="SHAPENAME" val="1. On-page tracker"/>
 </p:tagLst>
 </file>
 
 <file path=ppt/tags/tag155.xml><?xml version="1.0" encoding="utf-8"?>
 <p:tagLst xmlns:a="http://schemas.openxmlformats.org/drawingml/2006/main" xmlns:r="http://schemas.openxmlformats.org/officeDocument/2006/relationships" xmlns:p="http://schemas.openxmlformats.org/presentationml/2006/main">
-  <p:tag name="THINKCELLSHAPEDONOTDELETE" val="thinkcellActiveDocDoNotDelete"/>
+  <p:tag name="SHAPENAME" val="2. Slide Title"/>
 </p:tagLst>
 </file>
 
 <file path=ppt/tags/tag156.xml><?xml version="1.0" encoding="utf-8"?>
 <p:tagLst xmlns:a="http://schemas.openxmlformats.org/drawingml/2006/main" xmlns:r="http://schemas.openxmlformats.org/officeDocument/2006/relationships" xmlns:p="http://schemas.openxmlformats.org/presentationml/2006/main">
-  <p:tag name="THINKCELLSHAPEDONOTDELETE" val="t4.oZbb0sXNdu8BCibsgsUw"/>
+  <p:tag name="SHAPENAME" val="Slide Number"/>
 </p:tagLst>
 </file>
 
 <file path=ppt/tags/tag157.xml><?xml version="1.0" encoding="utf-8"?>
 <p:tagLst xmlns:a="http://schemas.openxmlformats.org/drawingml/2006/main" xmlns:r="http://schemas.openxmlformats.org/officeDocument/2006/relationships" xmlns:p="http://schemas.openxmlformats.org/presentationml/2006/main">
-  <p:tag name="SHAPENAME" val="3. Subtitle"/>
+  <p:tag name="THINKCELLSHAPEDONOTDELETE" val="thinkcellActiveDocDoNotDelete"/>
 </p:tagLst>
 </file>
 
 <file path=ppt/tags/tag158.xml><?xml version="1.0" encoding="utf-8"?>
 <p:tagLst xmlns:a="http://schemas.openxmlformats.org/drawingml/2006/main" xmlns:r="http://schemas.openxmlformats.org/officeDocument/2006/relationships" xmlns:p="http://schemas.openxmlformats.org/presentationml/2006/main">
-  <p:tag name="SHAPENAME" val="5. Source"/>
+  <p:tag name="THINKCELLSHAPEDONOTDELETE" val="tHbEQ8aI7AKzsdxigcAG3ZA"/>
 </p:tagLst>
 </file>
 
 <file path=ppt/tags/tag159.xml><?xml version="1.0" encoding="utf-8"?>
 <p:tagLst xmlns:a="http://schemas.openxmlformats.org/drawingml/2006/main" xmlns:r="http://schemas.openxmlformats.org/officeDocument/2006/relationships" xmlns:p="http://schemas.openxmlformats.org/presentationml/2006/main">
-  <p:tag name="SHAPENAME" val="1. On-page tracker"/>
+  <p:tag name="SHAPENAME" val="RectangleLight"/>
 </p:tagLst>
 </file>
 
@@ -44252,67 +44294,67 @@
 
 <file path=ppt/tags/tag160.xml><?xml version="1.0" encoding="utf-8"?>
 <p:tagLst xmlns:a="http://schemas.openxmlformats.org/drawingml/2006/main" xmlns:r="http://schemas.openxmlformats.org/officeDocument/2006/relationships" xmlns:p="http://schemas.openxmlformats.org/presentationml/2006/main">
-  <p:tag name="SHAPENAME" val="2. Slide Title"/>
+  <p:tag name="SHAPENAME" val="3. Subtitle"/>
 </p:tagLst>
 </file>
 
 <file path=ppt/tags/tag161.xml><?xml version="1.0" encoding="utf-8"?>
 <p:tagLst xmlns:a="http://schemas.openxmlformats.org/drawingml/2006/main" xmlns:r="http://schemas.openxmlformats.org/officeDocument/2006/relationships" xmlns:p="http://schemas.openxmlformats.org/presentationml/2006/main">
-  <p:tag name="THINKCELLSHAPEDONOTDELETE" val="thinkcellActiveDocDoNotDelete"/>
+  <p:tag name="SHAPENAME" val="5. Source"/>
 </p:tagLst>
 </file>
 
 <file path=ppt/tags/tag162.xml><?xml version="1.0" encoding="utf-8"?>
 <p:tagLst xmlns:a="http://schemas.openxmlformats.org/drawingml/2006/main" xmlns:r="http://schemas.openxmlformats.org/officeDocument/2006/relationships" xmlns:p="http://schemas.openxmlformats.org/presentationml/2006/main">
-  <p:tag name="THINKCELLSHAPEDONOTDELETE" val="t4.oZbb0sXNdu8BCibsgsUw"/>
+  <p:tag name="SHAPENAME" val="1. On-page tracker"/>
 </p:tagLst>
 </file>
 
 <file path=ppt/tags/tag163.xml><?xml version="1.0" encoding="utf-8"?>
 <p:tagLst xmlns:a="http://schemas.openxmlformats.org/drawingml/2006/main" xmlns:r="http://schemas.openxmlformats.org/officeDocument/2006/relationships" xmlns:p="http://schemas.openxmlformats.org/presentationml/2006/main">
-  <p:tag name="SHAPENAME" val="3. Subtitle"/>
+  <p:tag name="SHAPENAME" val="2. Slide Title"/>
 </p:tagLst>
 </file>
 
 <file path=ppt/tags/tag164.xml><?xml version="1.0" encoding="utf-8"?>
 <p:tagLst xmlns:a="http://schemas.openxmlformats.org/drawingml/2006/main" xmlns:r="http://schemas.openxmlformats.org/officeDocument/2006/relationships" xmlns:p="http://schemas.openxmlformats.org/presentationml/2006/main">
-  <p:tag name="SHAPENAME" val="5. Source"/>
+  <p:tag name="SHAPENAME" val="Slide Number"/>
 </p:tagLst>
 </file>
 
 <file path=ppt/tags/tag165.xml><?xml version="1.0" encoding="utf-8"?>
 <p:tagLst xmlns:a="http://schemas.openxmlformats.org/drawingml/2006/main" xmlns:r="http://schemas.openxmlformats.org/officeDocument/2006/relationships" xmlns:p="http://schemas.openxmlformats.org/presentationml/2006/main">
-  <p:tag name="SHAPENAME" val="1. On-page tracker"/>
+  <p:tag name="THINKCELLSHAPEDONOTDELETE" val="thinkcellActiveDocDoNotDelete"/>
 </p:tagLst>
 </file>
 
 <file path=ppt/tags/tag166.xml><?xml version="1.0" encoding="utf-8"?>
 <p:tagLst xmlns:a="http://schemas.openxmlformats.org/drawingml/2006/main" xmlns:r="http://schemas.openxmlformats.org/officeDocument/2006/relationships" xmlns:p="http://schemas.openxmlformats.org/presentationml/2006/main">
-  <p:tag name="SHAPENAME" val="2. Slide Title"/>
+  <p:tag name="THINKCELLSHAPEDONOTDELETE" val="tBLvs1S2qnQw1aA01IUaglg"/>
 </p:tagLst>
 </file>
 
 <file path=ppt/tags/tag167.xml><?xml version="1.0" encoding="utf-8"?>
 <p:tagLst xmlns:a="http://schemas.openxmlformats.org/drawingml/2006/main" xmlns:r="http://schemas.openxmlformats.org/officeDocument/2006/relationships" xmlns:p="http://schemas.openxmlformats.org/presentationml/2006/main">
-  <p:tag name="THINKCELLSHAPEDONOTDELETE" val="thinkcellActiveDocDoNotDelete"/>
+  <p:tag name="SHAPENAME" val="RectangleLight"/>
 </p:tagLst>
 </file>
 
 <file path=ppt/tags/tag168.xml><?xml version="1.0" encoding="utf-8"?>
 <p:tagLst xmlns:a="http://schemas.openxmlformats.org/drawingml/2006/main" xmlns:r="http://schemas.openxmlformats.org/officeDocument/2006/relationships" xmlns:p="http://schemas.openxmlformats.org/presentationml/2006/main">
-  <p:tag name="THINKCELLSHAPEDONOTDELETE" val="trZ96ctUUqJsGDCugslwBCg"/>
+  <p:tag name="SHAPENAME" val="2. Slide Title"/>
 </p:tagLst>
 </file>
 
 <file path=ppt/tags/tag169.xml><?xml version="1.0" encoding="utf-8"?>
 <p:tagLst xmlns:a="http://schemas.openxmlformats.org/drawingml/2006/main" xmlns:r="http://schemas.openxmlformats.org/officeDocument/2006/relationships" xmlns:p="http://schemas.openxmlformats.org/presentationml/2006/main">
-  <p:tag name="SHAPENAME" val="2. Slide Title"/>
+  <p:tag name="SHAPENAME" val="3. Subtitle"/>
 </p:tagLst>
 </file>
 
 <file path=ppt/tags/tag17.xml><?xml version="1.0" encoding="utf-8"?>
 <p:tagLst xmlns:a="http://schemas.openxmlformats.org/drawingml/2006/main" xmlns:r="http://schemas.openxmlformats.org/officeDocument/2006/relationships" xmlns:p="http://schemas.openxmlformats.org/presentationml/2006/main">
-  <p:tag name="ANGLE" val="3"/>
+  <p:tag name="ANGLE" val="2"/>
 </p:tagLst>
 </file>
 
@@ -44330,49 +44372,49 @@
 
 <file path=ppt/tags/tag172.xml><?xml version="1.0" encoding="utf-8"?>
 <p:tagLst xmlns:a="http://schemas.openxmlformats.org/drawingml/2006/main" xmlns:r="http://schemas.openxmlformats.org/officeDocument/2006/relationships" xmlns:p="http://schemas.openxmlformats.org/presentationml/2006/main">
-  <p:tag name="THINKCELLSHAPEDONOTDELETE" val="thinkcellActiveDocDoNotDelete"/>
+  <p:tag name="SHAPENAME" val="Slide Number"/>
 </p:tagLst>
 </file>
 
 <file path=ppt/tags/tag173.xml><?xml version="1.0" encoding="utf-8"?>
 <p:tagLst xmlns:a="http://schemas.openxmlformats.org/drawingml/2006/main" xmlns:r="http://schemas.openxmlformats.org/officeDocument/2006/relationships" xmlns:p="http://schemas.openxmlformats.org/presentationml/2006/main">
-  <p:tag name="THINKCELLSHAPEDONOTDELETE" val="tAvhTnprpZIIVVQCOTQtpLw"/>
+  <p:tag name="THINKCELLSHAPEDONOTDELETE" val="thinkcellActiveDocDoNotDelete"/>
 </p:tagLst>
 </file>
 
 <file path=ppt/tags/tag174.xml><?xml version="1.0" encoding="utf-8"?>
 <p:tagLst xmlns:a="http://schemas.openxmlformats.org/drawingml/2006/main" xmlns:r="http://schemas.openxmlformats.org/officeDocument/2006/relationships" xmlns:p="http://schemas.openxmlformats.org/presentationml/2006/main">
-  <p:tag name="SHAPENAME" val="2. Slide Title"/>
+  <p:tag name="THINKCELLSHAPEDONOTDELETE" val="tqUyDlDqWonv3hoAx.p9Rsw"/>
 </p:tagLst>
 </file>
 
 <file path=ppt/tags/tag175.xml><?xml version="1.0" encoding="utf-8"?>
 <p:tagLst xmlns:a="http://schemas.openxmlformats.org/drawingml/2006/main" xmlns:r="http://schemas.openxmlformats.org/officeDocument/2006/relationships" xmlns:p="http://schemas.openxmlformats.org/presentationml/2006/main">
-  <p:tag name="SHAPENAME" val="5. Source"/>
+  <p:tag name="SHAPENAME" val="2. Slide Title"/>
 </p:tagLst>
 </file>
 
 <file path=ppt/tags/tag176.xml><?xml version="1.0" encoding="utf-8"?>
 <p:tagLst xmlns:a="http://schemas.openxmlformats.org/drawingml/2006/main" xmlns:r="http://schemas.openxmlformats.org/officeDocument/2006/relationships" xmlns:p="http://schemas.openxmlformats.org/presentationml/2006/main">
-  <p:tag name="SHAPENAME" val="1. On-page tracker"/>
+  <p:tag name="SHAPENAME" val="RectangleLight"/>
 </p:tagLst>
 </file>
 
 <file path=ppt/tags/tag177.xml><?xml version="1.0" encoding="utf-8"?>
 <p:tagLst xmlns:a="http://schemas.openxmlformats.org/drawingml/2006/main" xmlns:r="http://schemas.openxmlformats.org/officeDocument/2006/relationships" xmlns:p="http://schemas.openxmlformats.org/presentationml/2006/main">
-  <p:tag name="THINKCELLSHAPEDONOTDELETE" val="thinkcellActiveDocDoNotDelete"/>
+  <p:tag name="SHAPENAME" val="3. Subtitle"/>
 </p:tagLst>
 </file>
 
 <file path=ppt/tags/tag178.xml><?xml version="1.0" encoding="utf-8"?>
 <p:tagLst xmlns:a="http://schemas.openxmlformats.org/drawingml/2006/main" xmlns:r="http://schemas.openxmlformats.org/officeDocument/2006/relationships" xmlns:p="http://schemas.openxmlformats.org/presentationml/2006/main">
-  <p:tag name="THINKCELLSHAPEDONOTDELETE" val="tVvs3CU0mhZ0iF9VK3Gc_gQ"/>
+  <p:tag name="SHAPENAME" val="5. Source"/>
 </p:tagLst>
 </file>
 
 <file path=ppt/tags/tag179.xml><?xml version="1.0" encoding="utf-8"?>
 <p:tagLst xmlns:a="http://schemas.openxmlformats.org/drawingml/2006/main" xmlns:r="http://schemas.openxmlformats.org/officeDocument/2006/relationships" xmlns:p="http://schemas.openxmlformats.org/presentationml/2006/main">
-  <p:tag name="SHAPENAME" val="2. Slide Title"/>
+  <p:tag name="SHAPENAME" val="1. On-page tracker"/>
 </p:tagLst>
 </file>
 
@@ -44384,25 +44426,25 @@
 
 <file path=ppt/tags/tag180.xml><?xml version="1.0" encoding="utf-8"?>
 <p:tagLst xmlns:a="http://schemas.openxmlformats.org/drawingml/2006/main" xmlns:r="http://schemas.openxmlformats.org/officeDocument/2006/relationships" xmlns:p="http://schemas.openxmlformats.org/presentationml/2006/main">
-  <p:tag name="SHAPENAME" val="5. Source"/>
+  <p:tag name="SHAPENAME" val="Slide Number"/>
 </p:tagLst>
 </file>
 
 <file path=ppt/tags/tag181.xml><?xml version="1.0" encoding="utf-8"?>
 <p:tagLst xmlns:a="http://schemas.openxmlformats.org/drawingml/2006/main" xmlns:r="http://schemas.openxmlformats.org/officeDocument/2006/relationships" xmlns:p="http://schemas.openxmlformats.org/presentationml/2006/main">
-  <p:tag name="SHAPENAME" val="1. On-page tracker"/>
+  <p:tag name="THINKCELLSHAPEDONOTDELETE" val="thinkcellActiveDocDoNotDelete"/>
 </p:tagLst>
 </file>
 
 <file path=ppt/tags/tag182.xml><?xml version="1.0" encoding="utf-8"?>
 <p:tagLst xmlns:a="http://schemas.openxmlformats.org/drawingml/2006/main" xmlns:r="http://schemas.openxmlformats.org/officeDocument/2006/relationships" xmlns:p="http://schemas.openxmlformats.org/presentationml/2006/main">
-  <p:tag name="THINKCELLSHAPEDONOTDELETE" val="thinkcellActiveDocDoNotDelete"/>
+  <p:tag name="THINKCELLSHAPEDONOTDELETE" val="to9xgrPArEB1mEiMOhB5KGA"/>
 </p:tagLst>
 </file>
 
 <file path=ppt/tags/tag183.xml><?xml version="1.0" encoding="utf-8"?>
 <p:tagLst xmlns:a="http://schemas.openxmlformats.org/drawingml/2006/main" xmlns:r="http://schemas.openxmlformats.org/officeDocument/2006/relationships" xmlns:p="http://schemas.openxmlformats.org/presentationml/2006/main">
-  <p:tag name="THINKCELLSHAPEDONOTDELETE" val="tNrcAbB4u0quRffFN3bn3Xw"/>
+  <p:tag name="SHAPENAME" val="RectangleLight"/>
 </p:tagLst>
 </file>
 
@@ -44432,31 +44474,31 @@
 
 <file path=ppt/tags/tag188.xml><?xml version="1.0" encoding="utf-8"?>
 <p:tagLst xmlns:a="http://schemas.openxmlformats.org/drawingml/2006/main" xmlns:r="http://schemas.openxmlformats.org/officeDocument/2006/relationships" xmlns:p="http://schemas.openxmlformats.org/presentationml/2006/main">
-  <p:tag name="THINKCELLSHAPEDONOTDELETE" val="thinkcellActiveDocDoNotDelete"/>
+  <p:tag name="SHAPENAME" val="Slide Number"/>
 </p:tagLst>
 </file>
 
 <file path=ppt/tags/tag189.xml><?xml version="1.0" encoding="utf-8"?>
 <p:tagLst xmlns:a="http://schemas.openxmlformats.org/drawingml/2006/main" xmlns:r="http://schemas.openxmlformats.org/officeDocument/2006/relationships" xmlns:p="http://schemas.openxmlformats.org/presentationml/2006/main">
-  <p:tag name="THINKCELLSHAPEDONOTDELETE" val="tYG_9mniplMrafceMpP.Qwg"/>
+  <p:tag name="THINKCELLSHAPEDONOTDELETE" val="thinkcellActiveDocDoNotDelete"/>
 </p:tagLst>
 </file>
 
 <file path=ppt/tags/tag19.xml><?xml version="1.0" encoding="utf-8"?>
 <p:tagLst xmlns:a="http://schemas.openxmlformats.org/drawingml/2006/main" xmlns:r="http://schemas.openxmlformats.org/officeDocument/2006/relationships" xmlns:p="http://schemas.openxmlformats.org/presentationml/2006/main">
-  <p:tag name="ANGLE" val="2"/>
+  <p:tag name="ANGLE" val="1"/>
 </p:tagLst>
 </file>
 
 <file path=ppt/tags/tag190.xml><?xml version="1.0" encoding="utf-8"?>
 <p:tagLst xmlns:a="http://schemas.openxmlformats.org/drawingml/2006/main" xmlns:r="http://schemas.openxmlformats.org/officeDocument/2006/relationships" xmlns:p="http://schemas.openxmlformats.org/presentationml/2006/main">
-  <p:tag name="SHAPENAME" val="RectangleLight"/>
+  <p:tag name="THINKCELLSHAPEDONOTDELETE" val="txNguF4Gw2mJIhuiFXm5tKQ"/>
 </p:tagLst>
 </file>
 
 <file path=ppt/tags/tag191.xml><?xml version="1.0" encoding="utf-8"?>
 <p:tagLst xmlns:a="http://schemas.openxmlformats.org/drawingml/2006/main" xmlns:r="http://schemas.openxmlformats.org/officeDocument/2006/relationships" xmlns:p="http://schemas.openxmlformats.org/presentationml/2006/main">
-  <p:tag name="SHAPENAME" val="3. Subtitle"/>
+  <p:tag name="SHAPENAME" val="2. Slide Title"/>
 </p:tagLst>
 </file>
 
@@ -44474,37 +44516,37 @@
 
 <file path=ppt/tags/tag194.xml><?xml version="1.0" encoding="utf-8"?>
 <p:tagLst xmlns:a="http://schemas.openxmlformats.org/drawingml/2006/main" xmlns:r="http://schemas.openxmlformats.org/officeDocument/2006/relationships" xmlns:p="http://schemas.openxmlformats.org/presentationml/2006/main">
-  <p:tag name="SHAPENAME" val="2. Slide Title"/>
+  <p:tag name="SHAPENAME" val="Slide Number"/>
 </p:tagLst>
 </file>
 
 <file path=ppt/tags/tag195.xml><?xml version="1.0" encoding="utf-8"?>
 <p:tagLst xmlns:a="http://schemas.openxmlformats.org/drawingml/2006/main" xmlns:r="http://schemas.openxmlformats.org/officeDocument/2006/relationships" xmlns:p="http://schemas.openxmlformats.org/presentationml/2006/main">
-  <p:tag name="SHAPENAME" val="Slide Number"/>
+  <p:tag name="THINKCELLSHAPEDONOTDELETE" val="thinkcellActiveDocDoNotDelete"/>
 </p:tagLst>
 </file>
 
 <file path=ppt/tags/tag196.xml><?xml version="1.0" encoding="utf-8"?>
 <p:tagLst xmlns:a="http://schemas.openxmlformats.org/drawingml/2006/main" xmlns:r="http://schemas.openxmlformats.org/officeDocument/2006/relationships" xmlns:p="http://schemas.openxmlformats.org/presentationml/2006/main">
-  <p:tag name="THINKCELLSHAPEDONOTDELETE" val="thinkcellActiveDocDoNotDelete"/>
+  <p:tag name="SHAPENAME" val="5. Source"/>
 </p:tagLst>
 </file>
 
 <file path=ppt/tags/tag197.xml><?xml version="1.0" encoding="utf-8"?>
 <p:tagLst xmlns:a="http://schemas.openxmlformats.org/drawingml/2006/main" xmlns:r="http://schemas.openxmlformats.org/officeDocument/2006/relationships" xmlns:p="http://schemas.openxmlformats.org/presentationml/2006/main">
-  <p:tag name="THINKCELLSHAPEDONOTDELETE" val="tHbEQ8aI7AKzsdxigcAG3ZA"/>
+  <p:tag name="SHAPENAME" val="1. On-page tracker"/>
 </p:tagLst>
 </file>
 
 <file path=ppt/tags/tag198.xml><?xml version="1.0" encoding="utf-8"?>
 <p:tagLst xmlns:a="http://schemas.openxmlformats.org/drawingml/2006/main" xmlns:r="http://schemas.openxmlformats.org/officeDocument/2006/relationships" xmlns:p="http://schemas.openxmlformats.org/presentationml/2006/main">
-  <p:tag name="SHAPENAME" val="RectangleLight"/>
+  <p:tag name="SHAPENAME" val="Slide Number"/>
 </p:tagLst>
 </file>
 
 <file path=ppt/tags/tag199.xml><?xml version="1.0" encoding="utf-8"?>
 <p:tagLst xmlns:a="http://schemas.openxmlformats.org/drawingml/2006/main" xmlns:r="http://schemas.openxmlformats.org/officeDocument/2006/relationships" xmlns:p="http://schemas.openxmlformats.org/presentationml/2006/main">
-  <p:tag name="SHAPENAME" val="3. Subtitle"/>
+  <p:tag name="THINKCELLSHAPEDONOTDELETE" val="thinkcellActiveDocDoNotDelete"/>
 </p:tagLst>
 </file>
 
@@ -44534,13 +44576,13 @@
 
 <file path=ppt/tags/tag202.xml><?xml version="1.0" encoding="utf-8"?>
 <p:tagLst xmlns:a="http://schemas.openxmlformats.org/drawingml/2006/main" xmlns:r="http://schemas.openxmlformats.org/officeDocument/2006/relationships" xmlns:p="http://schemas.openxmlformats.org/presentationml/2006/main">
-  <p:tag name="SHAPENAME" val="2. Slide Title"/>
+  <p:tag name="THINKCELLSHAPEDONOTDELETE" val="thinkcellActiveDocDoNotDelete"/>
 </p:tagLst>
 </file>
 
 <file path=ppt/tags/tag203.xml><?xml version="1.0" encoding="utf-8"?>
 <p:tagLst xmlns:a="http://schemas.openxmlformats.org/drawingml/2006/main" xmlns:r="http://schemas.openxmlformats.org/officeDocument/2006/relationships" xmlns:p="http://schemas.openxmlformats.org/presentationml/2006/main">
-  <p:tag name="SHAPENAME" val="Slide Number"/>
+  <p:tag name="SHAPENAME" val="5. Source"/>
 </p:tagLst>
 </file>
 
@@ -44552,49 +44594,49 @@
 
 <file path=ppt/tags/tag205.xml><?xml version="1.0" encoding="utf-8"?>
 <p:tagLst xmlns:a="http://schemas.openxmlformats.org/drawingml/2006/main" xmlns:r="http://schemas.openxmlformats.org/officeDocument/2006/relationships" xmlns:p="http://schemas.openxmlformats.org/presentationml/2006/main">
-  <p:tag name="THINKCELLSHAPEDONOTDELETE" val="tBLvs1S2qnQw1aA01IUaglg"/>
+  <p:tag name="THINKCELLSHAPEDONOTDELETE" val="t4.oZbb0sXNdu8BCibsgsUw"/>
 </p:tagLst>
 </file>
 
 <file path=ppt/tags/tag206.xml><?xml version="1.0" encoding="utf-8"?>
 <p:tagLst xmlns:a="http://schemas.openxmlformats.org/drawingml/2006/main" xmlns:r="http://schemas.openxmlformats.org/officeDocument/2006/relationships" xmlns:p="http://schemas.openxmlformats.org/presentationml/2006/main">
-  <p:tag name="SHAPENAME" val="RectangleLight"/>
+  <p:tag name="SHAPENAME" val="3. Subtitle"/>
 </p:tagLst>
 </file>
 
 <file path=ppt/tags/tag207.xml><?xml version="1.0" encoding="utf-8"?>
 <p:tagLst xmlns:a="http://schemas.openxmlformats.org/drawingml/2006/main" xmlns:r="http://schemas.openxmlformats.org/officeDocument/2006/relationships" xmlns:p="http://schemas.openxmlformats.org/presentationml/2006/main">
-  <p:tag name="SHAPENAME" val="2. Slide Title"/>
+  <p:tag name="SHAPENAME" val="Slide Number"/>
 </p:tagLst>
 </file>
 
 <file path=ppt/tags/tag208.xml><?xml version="1.0" encoding="utf-8"?>
 <p:tagLst xmlns:a="http://schemas.openxmlformats.org/drawingml/2006/main" xmlns:r="http://schemas.openxmlformats.org/officeDocument/2006/relationships" xmlns:p="http://schemas.openxmlformats.org/presentationml/2006/main">
-  <p:tag name="SHAPENAME" val="3. Subtitle"/>
+  <p:tag name="SHAPENAME" val="5. Source"/>
 </p:tagLst>
 </file>
 
 <file path=ppt/tags/tag209.xml><?xml version="1.0" encoding="utf-8"?>
 <p:tagLst xmlns:a="http://schemas.openxmlformats.org/drawingml/2006/main" xmlns:r="http://schemas.openxmlformats.org/officeDocument/2006/relationships" xmlns:p="http://schemas.openxmlformats.org/presentationml/2006/main">
-  <p:tag name="SHAPENAME" val="5. Source"/>
+  <p:tag name="SHAPENAME" val="1. On-page tracker"/>
 </p:tagLst>
 </file>
 
 <file path=ppt/tags/tag21.xml><?xml version="1.0" encoding="utf-8"?>
 <p:tagLst xmlns:a="http://schemas.openxmlformats.org/drawingml/2006/main" xmlns:r="http://schemas.openxmlformats.org/officeDocument/2006/relationships" xmlns:p="http://schemas.openxmlformats.org/presentationml/2006/main">
-  <p:tag name="ANGLE" val="1"/>
+  <p:tag name="THINKCELLSHAPEDONOTDELETE" val="thinkcellActiveDocDoNotDelete"/>
 </p:tagLst>
 </file>
 
 <file path=ppt/tags/tag210.xml><?xml version="1.0" encoding="utf-8"?>
 <p:tagLst xmlns:a="http://schemas.openxmlformats.org/drawingml/2006/main" xmlns:r="http://schemas.openxmlformats.org/officeDocument/2006/relationships" xmlns:p="http://schemas.openxmlformats.org/presentationml/2006/main">
-  <p:tag name="SHAPENAME" val="1. On-page tracker"/>
+  <p:tag name="SHAPENAME" val="2. Slide Title"/>
 </p:tagLst>
 </file>
 
 <file path=ppt/tags/tag211.xml><?xml version="1.0" encoding="utf-8"?>
 <p:tagLst xmlns:a="http://schemas.openxmlformats.org/drawingml/2006/main" xmlns:r="http://schemas.openxmlformats.org/officeDocument/2006/relationships" xmlns:p="http://schemas.openxmlformats.org/presentationml/2006/main">
-  <p:tag name="SHAPENAME" val="Slide Number"/>
+  <p:tag name="SLIDETYPE" val="TitleWhite"/>
 </p:tagLst>
 </file>
 
@@ -44606,307 +44648,73 @@
 
 <file path=ppt/tags/tag213.xml><?xml version="1.0" encoding="utf-8"?>
 <p:tagLst xmlns:a="http://schemas.openxmlformats.org/drawingml/2006/main" xmlns:r="http://schemas.openxmlformats.org/officeDocument/2006/relationships" xmlns:p="http://schemas.openxmlformats.org/presentationml/2006/main">
-  <p:tag name="THINKCELLSHAPEDONOTDELETE" val="tqUyDlDqWonv3hoAx.p9Rsw"/>
+  <p:tag name="THINKCELLSHAPEDONOTDELETE" val="taXr8WAgv0cG5g7IkN2Kntg"/>
 </p:tagLst>
 </file>
 
 <file path=ppt/tags/tag214.xml><?xml version="1.0" encoding="utf-8"?>
 <p:tagLst xmlns:a="http://schemas.openxmlformats.org/drawingml/2006/main" xmlns:r="http://schemas.openxmlformats.org/officeDocument/2006/relationships" xmlns:p="http://schemas.openxmlformats.org/presentationml/2006/main">
-  <p:tag name="SHAPENAME" val="2. Slide Title"/>
+  <p:tag name="SHAPENAME" val="Documenttype"/>
 </p:tagLst>
 </file>
 
 <file path=ppt/tags/tag215.xml><?xml version="1.0" encoding="utf-8"?>
 <p:tagLst xmlns:a="http://schemas.openxmlformats.org/drawingml/2006/main" xmlns:r="http://schemas.openxmlformats.org/officeDocument/2006/relationships" xmlns:p="http://schemas.openxmlformats.org/presentationml/2006/main">
-  <p:tag name="SHAPENAME" val="RectangleLight"/>
+  <p:tag name="SHAPENAME" val="Subtitle"/>
 </p:tagLst>
 </file>
 
 <file path=ppt/tags/tag216.xml><?xml version="1.0" encoding="utf-8"?>
 <p:tagLst xmlns:a="http://schemas.openxmlformats.org/drawingml/2006/main" xmlns:r="http://schemas.openxmlformats.org/officeDocument/2006/relationships" xmlns:p="http://schemas.openxmlformats.org/presentationml/2006/main">
-  <p:tag name="SHAPENAME" val="3. Subtitle"/>
-</p:tagLst>
-</file>
-
-<file path=ppt/tags/tag217.xml><?xml version="1.0" encoding="utf-8"?>
-<p:tagLst xmlns:a="http://schemas.openxmlformats.org/drawingml/2006/main" xmlns:r="http://schemas.openxmlformats.org/officeDocument/2006/relationships" xmlns:p="http://schemas.openxmlformats.org/presentationml/2006/main">
-  <p:tag name="SHAPENAME" val="5. Source"/>
-</p:tagLst>
-</file>
-
-<file path=ppt/tags/tag218.xml><?xml version="1.0" encoding="utf-8"?>
-<p:tagLst xmlns:a="http://schemas.openxmlformats.org/drawingml/2006/main" xmlns:r="http://schemas.openxmlformats.org/officeDocument/2006/relationships" xmlns:p="http://schemas.openxmlformats.org/presentationml/2006/main">
-  <p:tag name="SHAPENAME" val="1. On-page tracker"/>
-</p:tagLst>
-</file>
-
-<file path=ppt/tags/tag219.xml><?xml version="1.0" encoding="utf-8"?>
-<p:tagLst xmlns:a="http://schemas.openxmlformats.org/drawingml/2006/main" xmlns:r="http://schemas.openxmlformats.org/officeDocument/2006/relationships" xmlns:p="http://schemas.openxmlformats.org/presentationml/2006/main">
-  <p:tag name="SHAPENAME" val="Slide Number"/>
+  <p:tag name="SHAPENAME" val="Title"/>
 </p:tagLst>
 </file>
 
 <file path=ppt/tags/tag22.xml><?xml version="1.0" encoding="utf-8"?>
 <p:tagLst xmlns:a="http://schemas.openxmlformats.org/drawingml/2006/main" xmlns:r="http://schemas.openxmlformats.org/officeDocument/2006/relationships" xmlns:p="http://schemas.openxmlformats.org/presentationml/2006/main">
-  <p:tag name="THINKCELLSHAPEDONOTDELETE" val="thinkcellActiveDocDoNotDelete"/>
+  <p:tag name="THINKCELLSHAPEDONOTDELETE" val="tWz9_f.d6YGbJCbK0.Pg2_A"/>
 </p:tagLst>
 </file>
 
-<file path=ppt/tags/tag220.xml><?xml version="1.0" encoding="utf-8"?>
+<file path=ppt/tags/tag23.xml><?xml version="1.0" encoding="utf-8"?>
+<p:tagLst xmlns:a="http://schemas.openxmlformats.org/drawingml/2006/main" xmlns:r="http://schemas.openxmlformats.org/officeDocument/2006/relationships" xmlns:p="http://schemas.openxmlformats.org/presentationml/2006/main">
+  <p:tag name="SHAPENAME" val="Documenttype"/>
+</p:tagLst>
+</file>
+
+<file path=ppt/tags/tag24.xml><?xml version="1.0" encoding="utf-8"?>
+<p:tagLst xmlns:a="http://schemas.openxmlformats.org/drawingml/2006/main" xmlns:r="http://schemas.openxmlformats.org/officeDocument/2006/relationships" xmlns:p="http://schemas.openxmlformats.org/presentationml/2006/main">
+  <p:tag name="SHAPENAME" val="Title"/>
+</p:tagLst>
+</file>
+
+<file path=ppt/tags/tag25.xml><?xml version="1.0" encoding="utf-8"?>
 <p:tagLst xmlns:a="http://schemas.openxmlformats.org/drawingml/2006/main" xmlns:r="http://schemas.openxmlformats.org/officeDocument/2006/relationships" xmlns:p="http://schemas.openxmlformats.org/presentationml/2006/main">
   <p:tag name="THINKCELLSHAPEDONOTDELETE" val="thinkcellActiveDocDoNotDelete"/>
 </p:tagLst>
 </file>
 
-<file path=ppt/tags/tag221.xml><?xml version="1.0" encoding="utf-8"?>
-<p:tagLst xmlns:a="http://schemas.openxmlformats.org/drawingml/2006/main" xmlns:r="http://schemas.openxmlformats.org/officeDocument/2006/relationships" xmlns:p="http://schemas.openxmlformats.org/presentationml/2006/main">
-  <p:tag name="THINKCELLSHAPEDONOTDELETE" val="to9xgrPArEB1mEiMOhB5KGA"/>
-</p:tagLst>
-</file>
-
-<file path=ppt/tags/tag222.xml><?xml version="1.0" encoding="utf-8"?>
-<p:tagLst xmlns:a="http://schemas.openxmlformats.org/drawingml/2006/main" xmlns:r="http://schemas.openxmlformats.org/officeDocument/2006/relationships" xmlns:p="http://schemas.openxmlformats.org/presentationml/2006/main">
-  <p:tag name="SHAPENAME" val="RectangleLight"/>
-</p:tagLst>
-</file>
-
-<file path=ppt/tags/tag223.xml><?xml version="1.0" encoding="utf-8"?>
-<p:tagLst xmlns:a="http://schemas.openxmlformats.org/drawingml/2006/main" xmlns:r="http://schemas.openxmlformats.org/officeDocument/2006/relationships" xmlns:p="http://schemas.openxmlformats.org/presentationml/2006/main">
-  <p:tag name="SHAPENAME" val="2. Slide Title"/>
-</p:tagLst>
-</file>
-
-<file path=ppt/tags/tag224.xml><?xml version="1.0" encoding="utf-8"?>
-<p:tagLst xmlns:a="http://schemas.openxmlformats.org/drawingml/2006/main" xmlns:r="http://schemas.openxmlformats.org/officeDocument/2006/relationships" xmlns:p="http://schemas.openxmlformats.org/presentationml/2006/main">
-  <p:tag name="SHAPENAME" val="3. Subtitle"/>
-</p:tagLst>
-</file>
-
-<file path=ppt/tags/tag225.xml><?xml version="1.0" encoding="utf-8"?>
-<p:tagLst xmlns:a="http://schemas.openxmlformats.org/drawingml/2006/main" xmlns:r="http://schemas.openxmlformats.org/officeDocument/2006/relationships" xmlns:p="http://schemas.openxmlformats.org/presentationml/2006/main">
-  <p:tag name="SHAPENAME" val="5. Source"/>
-</p:tagLst>
-</file>
-
-<file path=ppt/tags/tag226.xml><?xml version="1.0" encoding="utf-8"?>
-<p:tagLst xmlns:a="http://schemas.openxmlformats.org/drawingml/2006/main" xmlns:r="http://schemas.openxmlformats.org/officeDocument/2006/relationships" xmlns:p="http://schemas.openxmlformats.org/presentationml/2006/main">
-  <p:tag name="SHAPENAME" val="1. On-page tracker"/>
-</p:tagLst>
-</file>
-
-<file path=ppt/tags/tag227.xml><?xml version="1.0" encoding="utf-8"?>
-<p:tagLst xmlns:a="http://schemas.openxmlformats.org/drawingml/2006/main" xmlns:r="http://schemas.openxmlformats.org/officeDocument/2006/relationships" xmlns:p="http://schemas.openxmlformats.org/presentationml/2006/main">
-  <p:tag name="SHAPENAME" val="Slide Number"/>
-</p:tagLst>
-</file>
-
-<file path=ppt/tags/tag228.xml><?xml version="1.0" encoding="utf-8"?>
-<p:tagLst xmlns:a="http://schemas.openxmlformats.org/drawingml/2006/main" xmlns:r="http://schemas.openxmlformats.org/officeDocument/2006/relationships" xmlns:p="http://schemas.openxmlformats.org/presentationml/2006/main">
-  <p:tag name="THINKCELLSHAPEDONOTDELETE" val="thinkcellActiveDocDoNotDelete"/>
-</p:tagLst>
-</file>
-
-<file path=ppt/tags/tag229.xml><?xml version="1.0" encoding="utf-8"?>
-<p:tagLst xmlns:a="http://schemas.openxmlformats.org/drawingml/2006/main" xmlns:r="http://schemas.openxmlformats.org/officeDocument/2006/relationships" xmlns:p="http://schemas.openxmlformats.org/presentationml/2006/main">
-  <p:tag name="THINKCELLSHAPEDONOTDELETE" val="txNguF4Gw2mJIhuiFXm5tKQ"/>
-</p:tagLst>
-</file>
-
-<file path=ppt/tags/tag23.xml><?xml version="1.0" encoding="utf-8"?>
+<file path=ppt/tags/tag26.xml><?xml version="1.0" encoding="utf-8"?>
 <p:tagLst xmlns:a="http://schemas.openxmlformats.org/drawingml/2006/main" xmlns:r="http://schemas.openxmlformats.org/officeDocument/2006/relationships" xmlns:p="http://schemas.openxmlformats.org/presentationml/2006/main">
   <p:tag name="THINKCELLSHAPEDONOTDELETE" val="tWz9_f.d6YGbJCbK0.Pg2_A"/>
 </p:tagLst>
 </file>
 
-<file path=ppt/tags/tag230.xml><?xml version="1.0" encoding="utf-8"?>
-<p:tagLst xmlns:a="http://schemas.openxmlformats.org/drawingml/2006/main" xmlns:r="http://schemas.openxmlformats.org/officeDocument/2006/relationships" xmlns:p="http://schemas.openxmlformats.org/presentationml/2006/main">
-  <p:tag name="SHAPENAME" val="2. Slide Title"/>
-</p:tagLst>
-</file>
-
-<file path=ppt/tags/tag231.xml><?xml version="1.0" encoding="utf-8"?>
-<p:tagLst xmlns:a="http://schemas.openxmlformats.org/drawingml/2006/main" xmlns:r="http://schemas.openxmlformats.org/officeDocument/2006/relationships" xmlns:p="http://schemas.openxmlformats.org/presentationml/2006/main">
-  <p:tag name="SHAPENAME" val="5. Source"/>
-</p:tagLst>
-</file>
-
-<file path=ppt/tags/tag232.xml><?xml version="1.0" encoding="utf-8"?>
-<p:tagLst xmlns:a="http://schemas.openxmlformats.org/drawingml/2006/main" xmlns:r="http://schemas.openxmlformats.org/officeDocument/2006/relationships" xmlns:p="http://schemas.openxmlformats.org/presentationml/2006/main">
-  <p:tag name="SHAPENAME" val="1. On-page tracker"/>
-</p:tagLst>
-</file>
-
-<file path=ppt/tags/tag233.xml><?xml version="1.0" encoding="utf-8"?>
-<p:tagLst xmlns:a="http://schemas.openxmlformats.org/drawingml/2006/main" xmlns:r="http://schemas.openxmlformats.org/officeDocument/2006/relationships" xmlns:p="http://schemas.openxmlformats.org/presentationml/2006/main">
-  <p:tag name="SHAPENAME" val="Slide Number"/>
-</p:tagLst>
-</file>
-
-<file path=ppt/tags/tag234.xml><?xml version="1.0" encoding="utf-8"?>
-<p:tagLst xmlns:a="http://schemas.openxmlformats.org/drawingml/2006/main" xmlns:r="http://schemas.openxmlformats.org/officeDocument/2006/relationships" xmlns:p="http://schemas.openxmlformats.org/presentationml/2006/main">
-  <p:tag name="THINKCELLSHAPEDONOTDELETE" val="thinkcellActiveDocDoNotDelete"/>
-</p:tagLst>
-</file>
-
-<file path=ppt/tags/tag235.xml><?xml version="1.0" encoding="utf-8"?>
-<p:tagLst xmlns:a="http://schemas.openxmlformats.org/drawingml/2006/main" xmlns:r="http://schemas.openxmlformats.org/officeDocument/2006/relationships" xmlns:p="http://schemas.openxmlformats.org/presentationml/2006/main">
-  <p:tag name="SHAPENAME" val="5. Source"/>
-</p:tagLst>
-</file>
-
-<file path=ppt/tags/tag236.xml><?xml version="1.0" encoding="utf-8"?>
-<p:tagLst xmlns:a="http://schemas.openxmlformats.org/drawingml/2006/main" xmlns:r="http://schemas.openxmlformats.org/officeDocument/2006/relationships" xmlns:p="http://schemas.openxmlformats.org/presentationml/2006/main">
-  <p:tag name="SHAPENAME" val="1. On-page tracker"/>
-</p:tagLst>
-</file>
-
-<file path=ppt/tags/tag237.xml><?xml version="1.0" encoding="utf-8"?>
-<p:tagLst xmlns:a="http://schemas.openxmlformats.org/drawingml/2006/main" xmlns:r="http://schemas.openxmlformats.org/officeDocument/2006/relationships" xmlns:p="http://schemas.openxmlformats.org/presentationml/2006/main">
-  <p:tag name="SHAPENAME" val="Slide Number"/>
-</p:tagLst>
-</file>
-
-<file path=ppt/tags/tag238.xml><?xml version="1.0" encoding="utf-8"?>
-<p:tagLst xmlns:a="http://schemas.openxmlformats.org/drawingml/2006/main" xmlns:r="http://schemas.openxmlformats.org/officeDocument/2006/relationships" xmlns:p="http://schemas.openxmlformats.org/presentationml/2006/main">
-  <p:tag name="THINKCELLSHAPEDONOTDELETE" val="thinkcellActiveDocDoNotDelete"/>
-</p:tagLst>
-</file>
-
-<file path=ppt/tags/tag239.xml><?xml version="1.0" encoding="utf-8"?>
-<p:tagLst xmlns:a="http://schemas.openxmlformats.org/drawingml/2006/main" xmlns:r="http://schemas.openxmlformats.org/officeDocument/2006/relationships" xmlns:p="http://schemas.openxmlformats.org/presentationml/2006/main">
-  <p:tag name="SHAPENAME" val="5. Source"/>
-</p:tagLst>
-</file>
-
-<file path=ppt/tags/tag24.xml><?xml version="1.0" encoding="utf-8"?>
+<file path=ppt/tags/tag27.xml><?xml version="1.0" encoding="utf-8"?>
 <p:tagLst xmlns:a="http://schemas.openxmlformats.org/drawingml/2006/main" xmlns:r="http://schemas.openxmlformats.org/officeDocument/2006/relationships" xmlns:p="http://schemas.openxmlformats.org/presentationml/2006/main">
   <p:tag name="SHAPENAME" val="Documenttype"/>
 </p:tagLst>
 </file>
 
-<file path=ppt/tags/tag240.xml><?xml version="1.0" encoding="utf-8"?>
-<p:tagLst xmlns:a="http://schemas.openxmlformats.org/drawingml/2006/main" xmlns:r="http://schemas.openxmlformats.org/officeDocument/2006/relationships" xmlns:p="http://schemas.openxmlformats.org/presentationml/2006/main">
-  <p:tag name="SHAPENAME" val="1. On-page tracker"/>
-</p:tagLst>
-</file>
-
-<file path=ppt/tags/tag241.xml><?xml version="1.0" encoding="utf-8"?>
-<p:tagLst xmlns:a="http://schemas.openxmlformats.org/drawingml/2006/main" xmlns:r="http://schemas.openxmlformats.org/officeDocument/2006/relationships" xmlns:p="http://schemas.openxmlformats.org/presentationml/2006/main">
-  <p:tag name="THINKCELLSHAPEDONOTDELETE" val="thinkcellActiveDocDoNotDelete"/>
-</p:tagLst>
-</file>
-
-<file path=ppt/tags/tag242.xml><?xml version="1.0" encoding="utf-8"?>
-<p:tagLst xmlns:a="http://schemas.openxmlformats.org/drawingml/2006/main" xmlns:r="http://schemas.openxmlformats.org/officeDocument/2006/relationships" xmlns:p="http://schemas.openxmlformats.org/presentationml/2006/main">
-  <p:tag name="SHAPENAME" val="5. Source"/>
-</p:tagLst>
-</file>
-
-<file path=ppt/tags/tag243.xml><?xml version="1.0" encoding="utf-8"?>
-<p:tagLst xmlns:a="http://schemas.openxmlformats.org/drawingml/2006/main" xmlns:r="http://schemas.openxmlformats.org/officeDocument/2006/relationships" xmlns:p="http://schemas.openxmlformats.org/presentationml/2006/main">
-  <p:tag name="THINKCELLSHAPEDONOTDELETE" val="thinkcellActiveDocDoNotDelete"/>
-</p:tagLst>
-</file>
-
-<file path=ppt/tags/tag244.xml><?xml version="1.0" encoding="utf-8"?>
-<p:tagLst xmlns:a="http://schemas.openxmlformats.org/drawingml/2006/main" xmlns:r="http://schemas.openxmlformats.org/officeDocument/2006/relationships" xmlns:p="http://schemas.openxmlformats.org/presentationml/2006/main">
-  <p:tag name="THINKCELLSHAPEDONOTDELETE" val="t4.oZbb0sXNdu8BCibsgsUw"/>
-</p:tagLst>
-</file>
-
-<file path=ppt/tags/tag245.xml><?xml version="1.0" encoding="utf-8"?>
-<p:tagLst xmlns:a="http://schemas.openxmlformats.org/drawingml/2006/main" xmlns:r="http://schemas.openxmlformats.org/officeDocument/2006/relationships" xmlns:p="http://schemas.openxmlformats.org/presentationml/2006/main">
-  <p:tag name="SHAPENAME" val="3. Subtitle"/>
-</p:tagLst>
-</file>
-
-<file path=ppt/tags/tag246.xml><?xml version="1.0" encoding="utf-8"?>
-<p:tagLst xmlns:a="http://schemas.openxmlformats.org/drawingml/2006/main" xmlns:r="http://schemas.openxmlformats.org/officeDocument/2006/relationships" xmlns:p="http://schemas.openxmlformats.org/presentationml/2006/main">
-  <p:tag name="SHAPENAME" val="Slide Number"/>
-</p:tagLst>
-</file>
-
-<file path=ppt/tags/tag247.xml><?xml version="1.0" encoding="utf-8"?>
-<p:tagLst xmlns:a="http://schemas.openxmlformats.org/drawingml/2006/main" xmlns:r="http://schemas.openxmlformats.org/officeDocument/2006/relationships" xmlns:p="http://schemas.openxmlformats.org/presentationml/2006/main">
-  <p:tag name="SHAPENAME" val="5. Source"/>
-</p:tagLst>
-</file>
-
-<file path=ppt/tags/tag248.xml><?xml version="1.0" encoding="utf-8"?>
-<p:tagLst xmlns:a="http://schemas.openxmlformats.org/drawingml/2006/main" xmlns:r="http://schemas.openxmlformats.org/officeDocument/2006/relationships" xmlns:p="http://schemas.openxmlformats.org/presentationml/2006/main">
-  <p:tag name="SHAPENAME" val="1. On-page tracker"/>
-</p:tagLst>
-</file>
-
-<file path=ppt/tags/tag249.xml><?xml version="1.0" encoding="utf-8"?>
-<p:tagLst xmlns:a="http://schemas.openxmlformats.org/drawingml/2006/main" xmlns:r="http://schemas.openxmlformats.org/officeDocument/2006/relationships" xmlns:p="http://schemas.openxmlformats.org/presentationml/2006/main">
-  <p:tag name="SHAPENAME" val="2. Slide Title"/>
-</p:tagLst>
-</file>
-
-<file path=ppt/tags/tag25.xml><?xml version="1.0" encoding="utf-8"?>
-<p:tagLst xmlns:a="http://schemas.openxmlformats.org/drawingml/2006/main" xmlns:r="http://schemas.openxmlformats.org/officeDocument/2006/relationships" xmlns:p="http://schemas.openxmlformats.org/presentationml/2006/main">
-  <p:tag name="SHAPENAME" val="Subtitle"/>
-</p:tagLst>
-</file>
-
-<file path=ppt/tags/tag250.xml><?xml version="1.0" encoding="utf-8"?>
-<p:tagLst xmlns:a="http://schemas.openxmlformats.org/drawingml/2006/main" xmlns:r="http://schemas.openxmlformats.org/officeDocument/2006/relationships" xmlns:p="http://schemas.openxmlformats.org/presentationml/2006/main">
-  <p:tag name="SLIDETYPE" val="TitleWhite"/>
-</p:tagLst>
-</file>
-
-<file path=ppt/tags/tag251.xml><?xml version="1.0" encoding="utf-8"?>
-<p:tagLst xmlns:a="http://schemas.openxmlformats.org/drawingml/2006/main" xmlns:r="http://schemas.openxmlformats.org/officeDocument/2006/relationships" xmlns:p="http://schemas.openxmlformats.org/presentationml/2006/main">
-  <p:tag name="THINKCELLSHAPEDONOTDELETE" val="thinkcellActiveDocDoNotDelete"/>
-</p:tagLst>
-</file>
-
-<file path=ppt/tags/tag252.xml><?xml version="1.0" encoding="utf-8"?>
-<p:tagLst xmlns:a="http://schemas.openxmlformats.org/drawingml/2006/main" xmlns:r="http://schemas.openxmlformats.org/officeDocument/2006/relationships" xmlns:p="http://schemas.openxmlformats.org/presentationml/2006/main">
-  <p:tag name="THINKCELLSHAPEDONOTDELETE" val="taXr8WAgv0cG5g7IkN2Kntg"/>
-</p:tagLst>
-</file>
-
-<file path=ppt/tags/tag253.xml><?xml version="1.0" encoding="utf-8"?>
-<p:tagLst xmlns:a="http://schemas.openxmlformats.org/drawingml/2006/main" xmlns:r="http://schemas.openxmlformats.org/officeDocument/2006/relationships" xmlns:p="http://schemas.openxmlformats.org/presentationml/2006/main">
-  <p:tag name="SHAPENAME" val="Documenttype"/>
-</p:tagLst>
-</file>
-
-<file path=ppt/tags/tag254.xml><?xml version="1.0" encoding="utf-8"?>
-<p:tagLst xmlns:a="http://schemas.openxmlformats.org/drawingml/2006/main" xmlns:r="http://schemas.openxmlformats.org/officeDocument/2006/relationships" xmlns:p="http://schemas.openxmlformats.org/presentationml/2006/main">
-  <p:tag name="SHAPENAME" val="Subtitle"/>
-</p:tagLst>
-</file>
-
-<file path=ppt/tags/tag255.xml><?xml version="1.0" encoding="utf-8"?>
+<file path=ppt/tags/tag28.xml><?xml version="1.0" encoding="utf-8"?>
 <p:tagLst xmlns:a="http://schemas.openxmlformats.org/drawingml/2006/main" xmlns:r="http://schemas.openxmlformats.org/officeDocument/2006/relationships" xmlns:p="http://schemas.openxmlformats.org/presentationml/2006/main">
   <p:tag name="SHAPENAME" val="Title"/>
 </p:tagLst>
 </file>
 
-<file path=ppt/tags/tag26.xml><?xml version="1.0" encoding="utf-8"?>
-<p:tagLst xmlns:a="http://schemas.openxmlformats.org/drawingml/2006/main" xmlns:r="http://schemas.openxmlformats.org/officeDocument/2006/relationships" xmlns:p="http://schemas.openxmlformats.org/presentationml/2006/main">
-  <p:tag name="SHAPENAME" val="Title"/>
-</p:tagLst>
-</file>
-
-<file path=ppt/tags/tag27.xml><?xml version="1.0" encoding="utf-8"?>
+<file path=ppt/tags/tag29.xml><?xml version="1.0" encoding="utf-8"?>
 <p:tagLst xmlns:a="http://schemas.openxmlformats.org/drawingml/2006/main" xmlns:r="http://schemas.openxmlformats.org/officeDocument/2006/relationships" xmlns:p="http://schemas.openxmlformats.org/presentationml/2006/main">
   <p:tag name="THINKCELLSHAPEDONOTDELETE" val="thinkcellActiveDocDoNotDelete"/>
-</p:tagLst>
-</file>
-
-<file path=ppt/tags/tag28.xml><?xml version="1.0" encoding="utf-8"?>
-<p:tagLst xmlns:a="http://schemas.openxmlformats.org/drawingml/2006/main" xmlns:r="http://schemas.openxmlformats.org/officeDocument/2006/relationships" xmlns:p="http://schemas.openxmlformats.org/presentationml/2006/main">
-  <p:tag name="THINKCELLSHAPEDONOTDELETE" val="tWz9_f.d6YGbJCbK0.Pg2_A"/>
-</p:tagLst>
-</file>
-
-<file path=ppt/tags/tag29.xml><?xml version="1.0" encoding="utf-8"?>
-<p:tagLst xmlns:a="http://schemas.openxmlformats.org/drawingml/2006/main" xmlns:r="http://schemas.openxmlformats.org/officeDocument/2006/relationships" xmlns:p="http://schemas.openxmlformats.org/presentationml/2006/main">
-  <p:tag name="SHAPENAME" val="Documenttype"/>
 </p:tagLst>
 </file>
 
@@ -44918,31 +44726,31 @@
 
 <file path=ppt/tags/tag30.xml><?xml version="1.0" encoding="utf-8"?>
 <p:tagLst xmlns:a="http://schemas.openxmlformats.org/drawingml/2006/main" xmlns:r="http://schemas.openxmlformats.org/officeDocument/2006/relationships" xmlns:p="http://schemas.openxmlformats.org/presentationml/2006/main">
-  <p:tag name="SHAPENAME" val="Subtitle"/>
+  <p:tag name="THINKCELLSHAPEDONOTDELETE" val="t4.oZbb0sXNdu8BCibsgsUw"/>
 </p:tagLst>
 </file>
 
 <file path=ppt/tags/tag31.xml><?xml version="1.0" encoding="utf-8"?>
 <p:tagLst xmlns:a="http://schemas.openxmlformats.org/drawingml/2006/main" xmlns:r="http://schemas.openxmlformats.org/officeDocument/2006/relationships" xmlns:p="http://schemas.openxmlformats.org/presentationml/2006/main">
-  <p:tag name="SHAPENAME" val="Title"/>
+  <p:tag name="SHAPENAME" val="Slide Number"/>
 </p:tagLst>
 </file>
 
 <file path=ppt/tags/tag32.xml><?xml version="1.0" encoding="utf-8"?>
 <p:tagLst xmlns:a="http://schemas.openxmlformats.org/drawingml/2006/main" xmlns:r="http://schemas.openxmlformats.org/officeDocument/2006/relationships" xmlns:p="http://schemas.openxmlformats.org/presentationml/2006/main">
-  <p:tag name="THINKCELLSHAPEDONOTDELETE" val="thinkcellActiveDocDoNotDelete"/>
+  <p:tag name="SHAPENAME" val="2. Slide Title"/>
 </p:tagLst>
 </file>
 
 <file path=ppt/tags/tag33.xml><?xml version="1.0" encoding="utf-8"?>
 <p:tagLst xmlns:a="http://schemas.openxmlformats.org/drawingml/2006/main" xmlns:r="http://schemas.openxmlformats.org/officeDocument/2006/relationships" xmlns:p="http://schemas.openxmlformats.org/presentationml/2006/main">
-  <p:tag name="THINKCELLSHAPEDONOTDELETE" val="t4.oZbb0sXNdu8BCibsgsUw"/>
+  <p:tag name="THINKCELLSHAPEDONOTDELETE" val="thinkcellActiveDocDoNotDelete"/>
 </p:tagLst>
 </file>
 
 <file path=ppt/tags/tag34.xml><?xml version="1.0" encoding="utf-8"?>
 <p:tagLst xmlns:a="http://schemas.openxmlformats.org/drawingml/2006/main" xmlns:r="http://schemas.openxmlformats.org/officeDocument/2006/relationships" xmlns:p="http://schemas.openxmlformats.org/presentationml/2006/main">
-  <p:tag name="SHAPENAME" val="3. Subtitle"/>
+  <p:tag name="THINKCELLSHAPEDONOTDELETE" val="t4.oZbb0sXNdu8BCibsgsUw"/>
 </p:tagLst>
 </file>
 
@@ -44954,145 +44762,145 @@
 
 <file path=ppt/tags/tag36.xml><?xml version="1.0" encoding="utf-8"?>
 <p:tagLst xmlns:a="http://schemas.openxmlformats.org/drawingml/2006/main" xmlns:r="http://schemas.openxmlformats.org/officeDocument/2006/relationships" xmlns:p="http://schemas.openxmlformats.org/presentationml/2006/main">
-  <p:tag name="SHAPENAME" val="5. Source"/>
+  <p:tag name="SHAPENAME" val="2. Slide Title"/>
 </p:tagLst>
 </file>
 
 <file path=ppt/tags/tag37.xml><?xml version="1.0" encoding="utf-8"?>
 <p:tagLst xmlns:a="http://schemas.openxmlformats.org/drawingml/2006/main" xmlns:r="http://schemas.openxmlformats.org/officeDocument/2006/relationships" xmlns:p="http://schemas.openxmlformats.org/presentationml/2006/main">
-  <p:tag name="SHAPENAME" val="1. On-page tracker"/>
+  <p:tag name="THINKCELLSHAPEDONOTDELETE" val="thinkcellActiveDocDoNotDelete"/>
 </p:tagLst>
 </file>
 
 <file path=ppt/tags/tag38.xml><?xml version="1.0" encoding="utf-8"?>
 <p:tagLst xmlns:a="http://schemas.openxmlformats.org/drawingml/2006/main" xmlns:r="http://schemas.openxmlformats.org/officeDocument/2006/relationships" xmlns:p="http://schemas.openxmlformats.org/presentationml/2006/main">
-  <p:tag name="SHAPENAME" val="2. Slide Title"/>
+  <p:tag name="THINKCELLSHAPEDONOTDELETE" val="trZ96ctUUqJsGDCugslwBCg"/>
 </p:tagLst>
 </file>
 
 <file path=ppt/tags/tag39.xml><?xml version="1.0" encoding="utf-8"?>
 <p:tagLst xmlns:a="http://schemas.openxmlformats.org/drawingml/2006/main" xmlns:r="http://schemas.openxmlformats.org/officeDocument/2006/relationships" xmlns:p="http://schemas.openxmlformats.org/presentationml/2006/main">
-  <p:tag name="THINKCELLSHAPEDONOTDELETE" val="thinkcellActiveDocDoNotDelete"/>
+  <p:tag name="SHAPENAME" val="2. Slide Title"/>
 </p:tagLst>
 </file>
 
 <file path=ppt/tags/tag4.xml><?xml version="1.0" encoding="utf-8"?>
 <p:tagLst xmlns:a="http://schemas.openxmlformats.org/drawingml/2006/main" xmlns:r="http://schemas.openxmlformats.org/officeDocument/2006/relationships" xmlns:p="http://schemas.openxmlformats.org/presentationml/2006/main">
-  <p:tag name="SHAPENAME" val="4. Footnote"/>
+  <p:tag name="SHAPENAME" val="2. Slide Title"/>
 </p:tagLst>
 </file>
 
 <file path=ppt/tags/tag40.xml><?xml version="1.0" encoding="utf-8"?>
 <p:tagLst xmlns:a="http://schemas.openxmlformats.org/drawingml/2006/main" xmlns:r="http://schemas.openxmlformats.org/officeDocument/2006/relationships" xmlns:p="http://schemas.openxmlformats.org/presentationml/2006/main">
-  <p:tag name="THINKCELLSHAPEDONOTDELETE" val="t4.oZbb0sXNdu8BCibsgsUw"/>
+  <p:tag name="SHAPENAME" val="Slide Number"/>
 </p:tagLst>
 </file>
 
 <file path=ppt/tags/tag41.xml><?xml version="1.0" encoding="utf-8"?>
 <p:tagLst xmlns:a="http://schemas.openxmlformats.org/drawingml/2006/main" xmlns:r="http://schemas.openxmlformats.org/officeDocument/2006/relationships" xmlns:p="http://schemas.openxmlformats.org/presentationml/2006/main">
-  <p:tag name="SHAPENAME" val="3. Subtitle"/>
+  <p:tag name="THINKCELLSHAPEDONOTDELETE" val="thinkcellActiveDocDoNotDelete"/>
 </p:tagLst>
 </file>
 
 <file path=ppt/tags/tag42.xml><?xml version="1.0" encoding="utf-8"?>
 <p:tagLst xmlns:a="http://schemas.openxmlformats.org/drawingml/2006/main" xmlns:r="http://schemas.openxmlformats.org/officeDocument/2006/relationships" xmlns:p="http://schemas.openxmlformats.org/presentationml/2006/main">
-  <p:tag name="SHAPENAME" val="Slide Number"/>
+  <p:tag name="THINKCELLSHAPEDONOTDELETE" val="tAvhTnprpZIIVVQCOTQtpLw"/>
 </p:tagLst>
 </file>
 
 <file path=ppt/tags/tag43.xml><?xml version="1.0" encoding="utf-8"?>
 <p:tagLst xmlns:a="http://schemas.openxmlformats.org/drawingml/2006/main" xmlns:r="http://schemas.openxmlformats.org/officeDocument/2006/relationships" xmlns:p="http://schemas.openxmlformats.org/presentationml/2006/main">
-  <p:tag name="SHAPENAME" val="5. Source"/>
+  <p:tag name="SHAPENAME" val="2. Slide Title"/>
 </p:tagLst>
 </file>
 
 <file path=ppt/tags/tag44.xml><?xml version="1.0" encoding="utf-8"?>
 <p:tagLst xmlns:a="http://schemas.openxmlformats.org/drawingml/2006/main" xmlns:r="http://schemas.openxmlformats.org/officeDocument/2006/relationships" xmlns:p="http://schemas.openxmlformats.org/presentationml/2006/main">
-  <p:tag name="SHAPENAME" val="1. On-page tracker"/>
+  <p:tag name="SHAPENAME" val="Slide Number"/>
 </p:tagLst>
 </file>
 
 <file path=ppt/tags/tag45.xml><?xml version="1.0" encoding="utf-8"?>
 <p:tagLst xmlns:a="http://schemas.openxmlformats.org/drawingml/2006/main" xmlns:r="http://schemas.openxmlformats.org/officeDocument/2006/relationships" xmlns:p="http://schemas.openxmlformats.org/presentationml/2006/main">
-  <p:tag name="SHAPENAME" val="2. Slide Title"/>
+  <p:tag name="THINKCELLSHAPEDONOTDELETE" val="thinkcellActiveDocDoNotDelete"/>
 </p:tagLst>
 </file>
 
 <file path=ppt/tags/tag46.xml><?xml version="1.0" encoding="utf-8"?>
 <p:tagLst xmlns:a="http://schemas.openxmlformats.org/drawingml/2006/main" xmlns:r="http://schemas.openxmlformats.org/officeDocument/2006/relationships" xmlns:p="http://schemas.openxmlformats.org/presentationml/2006/main">
-  <p:tag name="THINKCELLSHAPEDONOTDELETE" val="thinkcellActiveDocDoNotDelete"/>
+  <p:tag name="THINKCELLSHAPEDONOTDELETE" val="tVvs3CU0mhZ0iF9VK3Gc_gQ"/>
 </p:tagLst>
 </file>
 
 <file path=ppt/tags/tag47.xml><?xml version="1.0" encoding="utf-8"?>
 <p:tagLst xmlns:a="http://schemas.openxmlformats.org/drawingml/2006/main" xmlns:r="http://schemas.openxmlformats.org/officeDocument/2006/relationships" xmlns:p="http://schemas.openxmlformats.org/presentationml/2006/main">
-  <p:tag name="THINKCELLSHAPEDONOTDELETE" val="trZ96ctUUqJsGDCugslwBCg"/>
+  <p:tag name="SHAPENAME" val="2. Slide Title"/>
 </p:tagLst>
 </file>
 
 <file path=ppt/tags/tag48.xml><?xml version="1.0" encoding="utf-8"?>
 <p:tagLst xmlns:a="http://schemas.openxmlformats.org/drawingml/2006/main" xmlns:r="http://schemas.openxmlformats.org/officeDocument/2006/relationships" xmlns:p="http://schemas.openxmlformats.org/presentationml/2006/main">
-  <p:tag name="SHAPENAME" val="2. Slide Title"/>
+  <p:tag name="SHAPENAME" val="Slide Number"/>
 </p:tagLst>
 </file>
 
 <file path=ppt/tags/tag49.xml><?xml version="1.0" encoding="utf-8"?>
 <p:tagLst xmlns:a="http://schemas.openxmlformats.org/drawingml/2006/main" xmlns:r="http://schemas.openxmlformats.org/officeDocument/2006/relationships" xmlns:p="http://schemas.openxmlformats.org/presentationml/2006/main">
-  <p:tag name="SHAPENAME" val="Slide Number"/>
+  <p:tag name="THINKCELLSHAPEDONOTDELETE" val="thinkcellActiveDocDoNotDelete"/>
 </p:tagLst>
 </file>
 
 <file path=ppt/tags/tag5.xml><?xml version="1.0" encoding="utf-8"?>
 <p:tagLst xmlns:a="http://schemas.openxmlformats.org/drawingml/2006/main" xmlns:r="http://schemas.openxmlformats.org/officeDocument/2006/relationships" xmlns:p="http://schemas.openxmlformats.org/presentationml/2006/main">
-  <p:tag name="SHAPENAME" val="2. Slide Title"/>
+  <p:tag name="NAME" val="ACET"/>
 </p:tagLst>
 </file>
 
 <file path=ppt/tags/tag50.xml><?xml version="1.0" encoding="utf-8"?>
 <p:tagLst xmlns:a="http://schemas.openxmlformats.org/drawingml/2006/main" xmlns:r="http://schemas.openxmlformats.org/officeDocument/2006/relationships" xmlns:p="http://schemas.openxmlformats.org/presentationml/2006/main">
-  <p:tag name="SHAPENAME" val="5. Source"/>
+  <p:tag name="THINKCELLSHAPEDONOTDELETE" val="tNrcAbB4u0quRffFN3bn3Xw"/>
 </p:tagLst>
 </file>
 
 <file path=ppt/tags/tag51.xml><?xml version="1.0" encoding="utf-8"?>
 <p:tagLst xmlns:a="http://schemas.openxmlformats.org/drawingml/2006/main" xmlns:r="http://schemas.openxmlformats.org/officeDocument/2006/relationships" xmlns:p="http://schemas.openxmlformats.org/presentationml/2006/main">
-  <p:tag name="SHAPENAME" val="1. On-page tracker"/>
+  <p:tag name="SHAPENAME" val="2. Slide Title"/>
 </p:tagLst>
 </file>
 
 <file path=ppt/tags/tag52.xml><?xml version="1.0" encoding="utf-8"?>
 <p:tagLst xmlns:a="http://schemas.openxmlformats.org/drawingml/2006/main" xmlns:r="http://schemas.openxmlformats.org/officeDocument/2006/relationships" xmlns:p="http://schemas.openxmlformats.org/presentationml/2006/main">
-  <p:tag name="THINKCELLSHAPEDONOTDELETE" val="thinkcellActiveDocDoNotDelete"/>
+  <p:tag name="SHAPENAME" val="Slide Number"/>
 </p:tagLst>
 </file>
 
 <file path=ppt/tags/tag53.xml><?xml version="1.0" encoding="utf-8"?>
 <p:tagLst xmlns:a="http://schemas.openxmlformats.org/drawingml/2006/main" xmlns:r="http://schemas.openxmlformats.org/officeDocument/2006/relationships" xmlns:p="http://schemas.openxmlformats.org/presentationml/2006/main">
-  <p:tag name="THINKCELLSHAPEDONOTDELETE" val="tAvhTnprpZIIVVQCOTQtpLw"/>
+  <p:tag name="THINKCELLSHAPEDONOTDELETE" val="thinkcellActiveDocDoNotDelete"/>
 </p:tagLst>
 </file>
 
 <file path=ppt/tags/tag54.xml><?xml version="1.0" encoding="utf-8"?>
 <p:tagLst xmlns:a="http://schemas.openxmlformats.org/drawingml/2006/main" xmlns:r="http://schemas.openxmlformats.org/officeDocument/2006/relationships" xmlns:p="http://schemas.openxmlformats.org/presentationml/2006/main">
-  <p:tag name="SHAPENAME" val="2. Slide Title"/>
+  <p:tag name="THINKCELLSHAPEDONOTDELETE" val="tYG_9mniplMrafceMpP.Qwg"/>
 </p:tagLst>
 </file>
 
 <file path=ppt/tags/tag55.xml><?xml version="1.0" encoding="utf-8"?>
 <p:tagLst xmlns:a="http://schemas.openxmlformats.org/drawingml/2006/main" xmlns:r="http://schemas.openxmlformats.org/officeDocument/2006/relationships" xmlns:p="http://schemas.openxmlformats.org/presentationml/2006/main">
-  <p:tag name="SHAPENAME" val="Slide Number"/>
+  <p:tag name="SHAPENAME" val="RectangleLight"/>
 </p:tagLst>
 </file>
 
 <file path=ppt/tags/tag56.xml><?xml version="1.0" encoding="utf-8"?>
 <p:tagLst xmlns:a="http://schemas.openxmlformats.org/drawingml/2006/main" xmlns:r="http://schemas.openxmlformats.org/officeDocument/2006/relationships" xmlns:p="http://schemas.openxmlformats.org/presentationml/2006/main">
-  <p:tag name="SHAPENAME" val="5. Source"/>
+  <p:tag name="SHAPENAME" val="Slide Number"/>
 </p:tagLst>
 </file>
 
 <file path=ppt/tags/tag57.xml><?xml version="1.0" encoding="utf-8"?>
 <p:tagLst xmlns:a="http://schemas.openxmlformats.org/drawingml/2006/main" xmlns:r="http://schemas.openxmlformats.org/officeDocument/2006/relationships" xmlns:p="http://schemas.openxmlformats.org/presentationml/2006/main">
-  <p:tag name="SHAPENAME" val="1. On-page tracker"/>
+  <p:tag name="SHAPENAME" val="2. Slide Title"/>
 </p:tagLst>
 </file>
 
@@ -45104,19 +44912,19 @@
 
 <file path=ppt/tags/tag59.xml><?xml version="1.0" encoding="utf-8"?>
 <p:tagLst xmlns:a="http://schemas.openxmlformats.org/drawingml/2006/main" xmlns:r="http://schemas.openxmlformats.org/officeDocument/2006/relationships" xmlns:p="http://schemas.openxmlformats.org/presentationml/2006/main">
-  <p:tag name="THINKCELLSHAPEDONOTDELETE" val="tVvs3CU0mhZ0iF9VK3Gc_gQ"/>
+  <p:tag name="THINKCELLSHAPEDONOTDELETE" val="tHbEQ8aI7AKzsdxigcAG3ZA"/>
 </p:tagLst>
 </file>
 
 <file path=ppt/tags/tag6.xml><?xml version="1.0" encoding="utf-8"?>
 <p:tagLst xmlns:a="http://schemas.openxmlformats.org/drawingml/2006/main" xmlns:r="http://schemas.openxmlformats.org/officeDocument/2006/relationships" xmlns:p="http://schemas.openxmlformats.org/presentationml/2006/main">
-  <p:tag name="NAME" val="ACET"/>
+  <p:tag name="NAME" val="Moon"/>
 </p:tagLst>
 </file>
 
 <file path=ppt/tags/tag60.xml><?xml version="1.0" encoding="utf-8"?>
 <p:tagLst xmlns:a="http://schemas.openxmlformats.org/drawingml/2006/main" xmlns:r="http://schemas.openxmlformats.org/officeDocument/2006/relationships" xmlns:p="http://schemas.openxmlformats.org/presentationml/2006/main">
-  <p:tag name="SHAPENAME" val="2. Slide Title"/>
+  <p:tag name="SHAPENAME" val="RectangleLight"/>
 </p:tagLst>
 </file>
 
@@ -45128,49 +44936,49 @@
 
 <file path=ppt/tags/tag62.xml><?xml version="1.0" encoding="utf-8"?>
 <p:tagLst xmlns:a="http://schemas.openxmlformats.org/drawingml/2006/main" xmlns:r="http://schemas.openxmlformats.org/officeDocument/2006/relationships" xmlns:p="http://schemas.openxmlformats.org/presentationml/2006/main">
-  <p:tag name="SHAPENAME" val="5. Source"/>
+  <p:tag name="SHAPENAME" val="2. Slide Title"/>
 </p:tagLst>
 </file>
 
 <file path=ppt/tags/tag63.xml><?xml version="1.0" encoding="utf-8"?>
 <p:tagLst xmlns:a="http://schemas.openxmlformats.org/drawingml/2006/main" xmlns:r="http://schemas.openxmlformats.org/officeDocument/2006/relationships" xmlns:p="http://schemas.openxmlformats.org/presentationml/2006/main">
-  <p:tag name="SHAPENAME" val="1. On-page tracker"/>
+  <p:tag name="THINKCELLSHAPEDONOTDELETE" val="thinkcellActiveDocDoNotDelete"/>
 </p:tagLst>
 </file>
 
 <file path=ppt/tags/tag64.xml><?xml version="1.0" encoding="utf-8"?>
 <p:tagLst xmlns:a="http://schemas.openxmlformats.org/drawingml/2006/main" xmlns:r="http://schemas.openxmlformats.org/officeDocument/2006/relationships" xmlns:p="http://schemas.openxmlformats.org/presentationml/2006/main">
-  <p:tag name="THINKCELLSHAPEDONOTDELETE" val="thinkcellActiveDocDoNotDelete"/>
+  <p:tag name="THINKCELLSHAPEDONOTDELETE" val="tBLvs1S2qnQw1aA01IUaglg"/>
 </p:tagLst>
 </file>
 
 <file path=ppt/tags/tag65.xml><?xml version="1.0" encoding="utf-8"?>
 <p:tagLst xmlns:a="http://schemas.openxmlformats.org/drawingml/2006/main" xmlns:r="http://schemas.openxmlformats.org/officeDocument/2006/relationships" xmlns:p="http://schemas.openxmlformats.org/presentationml/2006/main">
-  <p:tag name="THINKCELLSHAPEDONOTDELETE" val="tNrcAbB4u0quRffFN3bn3Xw"/>
+  <p:tag name="SHAPENAME" val="RectangleLight"/>
 </p:tagLst>
 </file>
 
 <file path=ppt/tags/tag66.xml><?xml version="1.0" encoding="utf-8"?>
 <p:tagLst xmlns:a="http://schemas.openxmlformats.org/drawingml/2006/main" xmlns:r="http://schemas.openxmlformats.org/officeDocument/2006/relationships" xmlns:p="http://schemas.openxmlformats.org/presentationml/2006/main">
-  <p:tag name="SHAPENAME" val="2. Slide Title"/>
+  <p:tag name="SHAPENAME" val="Slide Number"/>
 </p:tagLst>
 </file>
 
 <file path=ppt/tags/tag67.xml><?xml version="1.0" encoding="utf-8"?>
 <p:tagLst xmlns:a="http://schemas.openxmlformats.org/drawingml/2006/main" xmlns:r="http://schemas.openxmlformats.org/officeDocument/2006/relationships" xmlns:p="http://schemas.openxmlformats.org/presentationml/2006/main">
-  <p:tag name="SHAPENAME" val="3. Subtitle"/>
+  <p:tag name="SHAPENAME" val="2. Slide Title"/>
 </p:tagLst>
 </file>
 
 <file path=ppt/tags/tag68.xml><?xml version="1.0" encoding="utf-8"?>
 <p:tagLst xmlns:a="http://schemas.openxmlformats.org/drawingml/2006/main" xmlns:r="http://schemas.openxmlformats.org/officeDocument/2006/relationships" xmlns:p="http://schemas.openxmlformats.org/presentationml/2006/main">
-  <p:tag name="SHAPENAME" val="Slide Number"/>
+  <p:tag name="THINKCELLSHAPEDONOTDELETE" val="thinkcellActiveDocDoNotDelete"/>
 </p:tagLst>
 </file>
 
 <file path=ppt/tags/tag69.xml><?xml version="1.0" encoding="utf-8"?>
 <p:tagLst xmlns:a="http://schemas.openxmlformats.org/drawingml/2006/main" xmlns:r="http://schemas.openxmlformats.org/officeDocument/2006/relationships" xmlns:p="http://schemas.openxmlformats.org/presentationml/2006/main">
-  <p:tag name="SHAPENAME" val="5. Source"/>
+  <p:tag name="THINKCELLSHAPEDONOTDELETE" val="tqUyDlDqWonv3hoAx.p9Rsw"/>
 </p:tagLst>
 </file>
 
@@ -45182,61 +44990,61 @@
 
 <file path=ppt/tags/tag70.xml><?xml version="1.0" encoding="utf-8"?>
 <p:tagLst xmlns:a="http://schemas.openxmlformats.org/drawingml/2006/main" xmlns:r="http://schemas.openxmlformats.org/officeDocument/2006/relationships" xmlns:p="http://schemas.openxmlformats.org/presentationml/2006/main">
-  <p:tag name="SHAPENAME" val="1. On-page tracker"/>
+  <p:tag name="SHAPENAME" val="2. Slide Title"/>
 </p:tagLst>
 </file>
 
 <file path=ppt/tags/tag71.xml><?xml version="1.0" encoding="utf-8"?>
 <p:tagLst xmlns:a="http://schemas.openxmlformats.org/drawingml/2006/main" xmlns:r="http://schemas.openxmlformats.org/officeDocument/2006/relationships" xmlns:p="http://schemas.openxmlformats.org/presentationml/2006/main">
-  <p:tag name="THINKCELLSHAPEDONOTDELETE" val="thinkcellActiveDocDoNotDelete"/>
+  <p:tag name="SHAPENAME" val="RectangleLight"/>
 </p:tagLst>
 </file>
 
 <file path=ppt/tags/tag72.xml><?xml version="1.0" encoding="utf-8"?>
 <p:tagLst xmlns:a="http://schemas.openxmlformats.org/drawingml/2006/main" xmlns:r="http://schemas.openxmlformats.org/officeDocument/2006/relationships" xmlns:p="http://schemas.openxmlformats.org/presentationml/2006/main">
-  <p:tag name="THINKCELLSHAPEDONOTDELETE" val="tYG_9mniplMrafceMpP.Qwg"/>
+  <p:tag name="SHAPENAME" val="Slide Number"/>
 </p:tagLst>
 </file>
 
 <file path=ppt/tags/tag73.xml><?xml version="1.0" encoding="utf-8"?>
 <p:tagLst xmlns:a="http://schemas.openxmlformats.org/drawingml/2006/main" xmlns:r="http://schemas.openxmlformats.org/officeDocument/2006/relationships" xmlns:p="http://schemas.openxmlformats.org/presentationml/2006/main">
-  <p:tag name="SHAPENAME" val="RectangleLight"/>
+  <p:tag name="THINKCELLSHAPEDONOTDELETE" val="thinkcellActiveDocDoNotDelete"/>
 </p:tagLst>
 </file>
 
 <file path=ppt/tags/tag74.xml><?xml version="1.0" encoding="utf-8"?>
 <p:tagLst xmlns:a="http://schemas.openxmlformats.org/drawingml/2006/main" xmlns:r="http://schemas.openxmlformats.org/officeDocument/2006/relationships" xmlns:p="http://schemas.openxmlformats.org/presentationml/2006/main">
-  <p:tag name="SHAPENAME" val="Slide Number"/>
+  <p:tag name="THINKCELLSHAPEDONOTDELETE" val="to9xgrPArEB1mEiMOhB5KGA"/>
 </p:tagLst>
 </file>
 
 <file path=ppt/tags/tag75.xml><?xml version="1.0" encoding="utf-8"?>
 <p:tagLst xmlns:a="http://schemas.openxmlformats.org/drawingml/2006/main" xmlns:r="http://schemas.openxmlformats.org/officeDocument/2006/relationships" xmlns:p="http://schemas.openxmlformats.org/presentationml/2006/main">
-  <p:tag name="SHAPENAME" val="3. Subtitle"/>
+  <p:tag name="SHAPENAME" val="RectangleLight"/>
 </p:tagLst>
 </file>
 
 <file path=ppt/tags/tag76.xml><?xml version="1.0" encoding="utf-8"?>
 <p:tagLst xmlns:a="http://schemas.openxmlformats.org/drawingml/2006/main" xmlns:r="http://schemas.openxmlformats.org/officeDocument/2006/relationships" xmlns:p="http://schemas.openxmlformats.org/presentationml/2006/main">
-  <p:tag name="SHAPENAME" val="5. Source"/>
+  <p:tag name="SHAPENAME" val="Slide Number"/>
 </p:tagLst>
 </file>
 
 <file path=ppt/tags/tag77.xml><?xml version="1.0" encoding="utf-8"?>
 <p:tagLst xmlns:a="http://schemas.openxmlformats.org/drawingml/2006/main" xmlns:r="http://schemas.openxmlformats.org/officeDocument/2006/relationships" xmlns:p="http://schemas.openxmlformats.org/presentationml/2006/main">
-  <p:tag name="SHAPENAME" val="1. On-page tracker"/>
+  <p:tag name="SHAPENAME" val="2. Slide Title"/>
 </p:tagLst>
 </file>
 
 <file path=ppt/tags/tag78.xml><?xml version="1.0" encoding="utf-8"?>
 <p:tagLst xmlns:a="http://schemas.openxmlformats.org/drawingml/2006/main" xmlns:r="http://schemas.openxmlformats.org/officeDocument/2006/relationships" xmlns:p="http://schemas.openxmlformats.org/presentationml/2006/main">
-  <p:tag name="SHAPENAME" val="2. Slide Title"/>
+  <p:tag name="THINKCELLSHAPEDONOTDELETE" val="thinkcellActiveDocDoNotDelete"/>
 </p:tagLst>
 </file>
 
 <file path=ppt/tags/tag79.xml><?xml version="1.0" encoding="utf-8"?>
 <p:tagLst xmlns:a="http://schemas.openxmlformats.org/drawingml/2006/main" xmlns:r="http://schemas.openxmlformats.org/officeDocument/2006/relationships" xmlns:p="http://schemas.openxmlformats.org/presentationml/2006/main">
-  <p:tag name="THINKCELLSHAPEDONOTDELETE" val="thinkcellActiveDocDoNotDelete"/>
+  <p:tag name="THINKCELLSHAPEDONOTDELETE" val="txNguF4Gw2mJIhuiFXm5tKQ"/>
 </p:tagLst>
 </file>
 
@@ -45248,61 +45056,61 @@
 
 <file path=ppt/tags/tag80.xml><?xml version="1.0" encoding="utf-8"?>
 <p:tagLst xmlns:a="http://schemas.openxmlformats.org/drawingml/2006/main" xmlns:r="http://schemas.openxmlformats.org/officeDocument/2006/relationships" xmlns:p="http://schemas.openxmlformats.org/presentationml/2006/main">
-  <p:tag name="THINKCELLSHAPEDONOTDELETE" val="tHbEQ8aI7AKzsdxigcAG3ZA"/>
+  <p:tag name="SHAPENAME" val="Slide Number"/>
 </p:tagLst>
 </file>
 
 <file path=ppt/tags/tag81.xml><?xml version="1.0" encoding="utf-8"?>
 <p:tagLst xmlns:a="http://schemas.openxmlformats.org/drawingml/2006/main" xmlns:r="http://schemas.openxmlformats.org/officeDocument/2006/relationships" xmlns:p="http://schemas.openxmlformats.org/presentationml/2006/main">
-  <p:tag name="SHAPENAME" val="RectangleLight"/>
+  <p:tag name="SHAPENAME" val="2. Slide Title"/>
 </p:tagLst>
 </file>
 
 <file path=ppt/tags/tag82.xml><?xml version="1.0" encoding="utf-8"?>
 <p:tagLst xmlns:a="http://schemas.openxmlformats.org/drawingml/2006/main" xmlns:r="http://schemas.openxmlformats.org/officeDocument/2006/relationships" xmlns:p="http://schemas.openxmlformats.org/presentationml/2006/main">
-  <p:tag name="SHAPENAME" val="Slide Number"/>
+  <p:tag name="THINKCELLSHAPEDONOTDELETE" val="thinkcellActiveDocDoNotDelete"/>
 </p:tagLst>
 </file>
 
 <file path=ppt/tags/tag83.xml><?xml version="1.0" encoding="utf-8"?>
 <p:tagLst xmlns:a="http://schemas.openxmlformats.org/drawingml/2006/main" xmlns:r="http://schemas.openxmlformats.org/officeDocument/2006/relationships" xmlns:p="http://schemas.openxmlformats.org/presentationml/2006/main">
-  <p:tag name="SHAPENAME" val="3. Subtitle"/>
+  <p:tag name="SHAPENAME" val="Slide Number"/>
 </p:tagLst>
 </file>
 
 <file path=ppt/tags/tag84.xml><?xml version="1.0" encoding="utf-8"?>
 <p:tagLst xmlns:a="http://schemas.openxmlformats.org/drawingml/2006/main" xmlns:r="http://schemas.openxmlformats.org/officeDocument/2006/relationships" xmlns:p="http://schemas.openxmlformats.org/presentationml/2006/main">
-  <p:tag name="SHAPENAME" val="5. Source"/>
+  <p:tag name="THINKCELLSHAPEDONOTDELETE" val="thinkcellActiveDocDoNotDelete"/>
 </p:tagLst>
 </file>
 
 <file path=ppt/tags/tag85.xml><?xml version="1.0" encoding="utf-8"?>
 <p:tagLst xmlns:a="http://schemas.openxmlformats.org/drawingml/2006/main" xmlns:r="http://schemas.openxmlformats.org/officeDocument/2006/relationships" xmlns:p="http://schemas.openxmlformats.org/presentationml/2006/main">
-  <p:tag name="SHAPENAME" val="1. On-page tracker"/>
+  <p:tag name="THINKCELLSHAPEDONOTDELETE" val="thinkcellActiveDocDoNotDelete"/>
 </p:tagLst>
 </file>
 
 <file path=ppt/tags/tag86.xml><?xml version="1.0" encoding="utf-8"?>
 <p:tagLst xmlns:a="http://schemas.openxmlformats.org/drawingml/2006/main" xmlns:r="http://schemas.openxmlformats.org/officeDocument/2006/relationships" xmlns:p="http://schemas.openxmlformats.org/presentationml/2006/main">
-  <p:tag name="SHAPENAME" val="2. Slide Title"/>
+  <p:tag name="THINKCELLSHAPEDONOTDELETE" val="txcgoWEzLgA0_64VDvMxGGg"/>
 </p:tagLst>
 </file>
 
 <file path=ppt/tags/tag87.xml><?xml version="1.0" encoding="utf-8"?>
 <p:tagLst xmlns:a="http://schemas.openxmlformats.org/drawingml/2006/main" xmlns:r="http://schemas.openxmlformats.org/officeDocument/2006/relationships" xmlns:p="http://schemas.openxmlformats.org/presentationml/2006/main">
-  <p:tag name="THINKCELLSHAPEDONOTDELETE" val="thinkcellActiveDocDoNotDelete"/>
+  <p:tag name="SHAPENAME" val="2. Slide Title"/>
 </p:tagLst>
 </file>
 
 <file path=ppt/tags/tag88.xml><?xml version="1.0" encoding="utf-8"?>
 <p:tagLst xmlns:a="http://schemas.openxmlformats.org/drawingml/2006/main" xmlns:r="http://schemas.openxmlformats.org/officeDocument/2006/relationships" xmlns:p="http://schemas.openxmlformats.org/presentationml/2006/main">
-  <p:tag name="THINKCELLSHAPEDONOTDELETE" val="tBLvs1S2qnQw1aA01IUaglg"/>
+  <p:tag name="NAME" val="ACET"/>
 </p:tagLst>
 </file>
 
 <file path=ppt/tags/tag89.xml><?xml version="1.0" encoding="utf-8"?>
 <p:tagLst xmlns:a="http://schemas.openxmlformats.org/drawingml/2006/main" xmlns:r="http://schemas.openxmlformats.org/officeDocument/2006/relationships" xmlns:p="http://schemas.openxmlformats.org/presentationml/2006/main">
-  <p:tag name="SHAPENAME" val="RectangleLight"/>
+  <p:tag name="SHAPENAME" val="Slide Number"/>
 </p:tagLst>
 </file>
 
@@ -45314,61 +45122,61 @@
 
 <file path=ppt/tags/tag90.xml><?xml version="1.0" encoding="utf-8"?>
 <p:tagLst xmlns:a="http://schemas.openxmlformats.org/drawingml/2006/main" xmlns:r="http://schemas.openxmlformats.org/officeDocument/2006/relationships" xmlns:p="http://schemas.openxmlformats.org/presentationml/2006/main">
-  <p:tag name="SHAPENAME" val="Slide Number"/>
+  <p:tag name="NAME" val="Moon"/>
 </p:tagLst>
 </file>
 
 <file path=ppt/tags/tag91.xml><?xml version="1.0" encoding="utf-8"?>
 <p:tagLst xmlns:a="http://schemas.openxmlformats.org/drawingml/2006/main" xmlns:r="http://schemas.openxmlformats.org/officeDocument/2006/relationships" xmlns:p="http://schemas.openxmlformats.org/presentationml/2006/main">
-  <p:tag name="SHAPENAME" val="2. Slide Title"/>
+  <p:tag name="NAME" val="Moon"/>
 </p:tagLst>
 </file>
 
 <file path=ppt/tags/tag92.xml><?xml version="1.0" encoding="utf-8"?>
 <p:tagLst xmlns:a="http://schemas.openxmlformats.org/drawingml/2006/main" xmlns:r="http://schemas.openxmlformats.org/officeDocument/2006/relationships" xmlns:p="http://schemas.openxmlformats.org/presentationml/2006/main">
-  <p:tag name="SHAPENAME" val="3. Subtitle"/>
+  <p:tag name="NAME" val="Moon"/>
 </p:tagLst>
 </file>
 
 <file path=ppt/tags/tag93.xml><?xml version="1.0" encoding="utf-8"?>
 <p:tagLst xmlns:a="http://schemas.openxmlformats.org/drawingml/2006/main" xmlns:r="http://schemas.openxmlformats.org/officeDocument/2006/relationships" xmlns:p="http://schemas.openxmlformats.org/presentationml/2006/main">
-  <p:tag name="SHAPENAME" val="5. Source"/>
+  <p:tag name="NAME" val="Moon"/>
 </p:tagLst>
 </file>
 
 <file path=ppt/tags/tag94.xml><?xml version="1.0" encoding="utf-8"?>
 <p:tagLst xmlns:a="http://schemas.openxmlformats.org/drawingml/2006/main" xmlns:r="http://schemas.openxmlformats.org/officeDocument/2006/relationships" xmlns:p="http://schemas.openxmlformats.org/presentationml/2006/main">
-  <p:tag name="SHAPENAME" val="1. On-page tracker"/>
+  <p:tag name="NAME" val="Moon"/>
 </p:tagLst>
 </file>
 
 <file path=ppt/tags/tag95.xml><?xml version="1.0" encoding="utf-8"?>
 <p:tagLst xmlns:a="http://schemas.openxmlformats.org/drawingml/2006/main" xmlns:r="http://schemas.openxmlformats.org/officeDocument/2006/relationships" xmlns:p="http://schemas.openxmlformats.org/presentationml/2006/main">
-  <p:tag name="THINKCELLSHAPEDONOTDELETE" val="thinkcellActiveDocDoNotDelete"/>
+  <p:tag name="ANGLE" val="5"/>
 </p:tagLst>
 </file>
 
 <file path=ppt/tags/tag96.xml><?xml version="1.0" encoding="utf-8"?>
 <p:tagLst xmlns:a="http://schemas.openxmlformats.org/drawingml/2006/main" xmlns:r="http://schemas.openxmlformats.org/officeDocument/2006/relationships" xmlns:p="http://schemas.openxmlformats.org/presentationml/2006/main">
-  <p:tag name="THINKCELLSHAPEDONOTDELETE" val="tqUyDlDqWonv3hoAx.p9Rsw"/>
+  <p:tag name="ANGLE" val="5"/>
 </p:tagLst>
 </file>
 
 <file path=ppt/tags/tag97.xml><?xml version="1.0" encoding="utf-8"?>
 <p:tagLst xmlns:a="http://schemas.openxmlformats.org/drawingml/2006/main" xmlns:r="http://schemas.openxmlformats.org/officeDocument/2006/relationships" xmlns:p="http://schemas.openxmlformats.org/presentationml/2006/main">
-  <p:tag name="SHAPENAME" val="2. Slide Title"/>
+  <p:tag name="ANGLE" val="4"/>
 </p:tagLst>
 </file>
 
 <file path=ppt/tags/tag98.xml><?xml version="1.0" encoding="utf-8"?>
 <p:tagLst xmlns:a="http://schemas.openxmlformats.org/drawingml/2006/main" xmlns:r="http://schemas.openxmlformats.org/officeDocument/2006/relationships" xmlns:p="http://schemas.openxmlformats.org/presentationml/2006/main">
-  <p:tag name="SHAPENAME" val="RectangleLight"/>
+  <p:tag name="ANGLE" val="4"/>
 </p:tagLst>
 </file>
 
 <file path=ppt/tags/tag99.xml><?xml version="1.0" encoding="utf-8"?>
 <p:tagLst xmlns:a="http://schemas.openxmlformats.org/drawingml/2006/main" xmlns:r="http://schemas.openxmlformats.org/officeDocument/2006/relationships" xmlns:p="http://schemas.openxmlformats.org/presentationml/2006/main">
-  <p:tag name="SHAPENAME" val="Slide Number"/>
+  <p:tag name="ANGLE" val="3"/>
 </p:tagLst>
 </file>
 
@@ -46429,26 +46237,6 @@
 </file>
 
 <file path=customXml/item1.xml><?xml version="1.0" encoding="utf-8"?>
-<p:properties xmlns:p="http://schemas.microsoft.com/office/2006/metadata/properties" xmlns:xsi="http://www.w3.org/2001/XMLSchema-instance" xmlns:pc="http://schemas.microsoft.com/office/infopath/2007/PartnerControls">
-  <documentManagement>
-    <lcf76f155ced4ddcb4097134ff3c332f xmlns="911617a9-2ec9-4645-852f-0245fbed96d5">
-      <Terms xmlns="http://schemas.microsoft.com/office/infopath/2007/PartnerControls"/>
-    </lcf76f155ced4ddcb4097134ff3c332f>
-    <TaxCatchAll xmlns="af684b11-0207-48b9-9ad1-06801cc72a76" xsi:nil="true"/>
-  </documentManagement>
-</p:properties>
-</file>
-
-<file path=customXml/item2.xml><?xml version="1.0" encoding="utf-8"?>
-<?mso-contentType ?>
-<FormTemplates xmlns="http://schemas.microsoft.com/sharepoint/v3/contenttype/forms">
-  <Display>DocumentLibraryForm</Display>
-  <Edit>DocumentLibraryForm</Edit>
-  <New>DocumentLibraryForm</New>
-</FormTemplates>
-</file>
-
-<file path=customXml/item3.xml><?xml version="1.0" encoding="utf-8"?>
 <ct:contentTypeSchema xmlns:ct="http://schemas.microsoft.com/office/2006/metadata/contentType" xmlns:ma="http://schemas.microsoft.com/office/2006/metadata/properties/metaAttributes" ct:_="" ma:_="" ma:contentTypeName="Documento" ma:contentTypeID="0x01010014A23B680462074A8AF7656793D3EC46" ma:contentTypeVersion="12" ma:contentTypeDescription="Crear nuevo documento." ma:contentTypeScope="" ma:versionID="d3b1eca52acc997fd2590238e7cb6d42">
   <xsd:schema xmlns:xsd="http://www.w3.org/2001/XMLSchema" xmlns:xs="http://www.w3.org/2001/XMLSchema" xmlns:p="http://schemas.microsoft.com/office/2006/metadata/properties" xmlns:ns2="911617a9-2ec9-4645-852f-0245fbed96d5" xmlns:ns3="af684b11-0207-48b9-9ad1-06801cc72a76" targetNamespace="http://schemas.microsoft.com/office/2006/metadata/properties" ma:root="true" ma:fieldsID="657966323f8b06294eee69941ca2e88d" ns2:_="" ns3:_="">
     <xsd:import namespace="911617a9-2ec9-4645-852f-0245fbed96d5"/>
@@ -46649,32 +46437,27 @@
 </ct:contentTypeSchema>
 </file>
 
-<file path=customXml/itemProps1.xml><?xml version="1.0" encoding="utf-8"?>
-<ds:datastoreItem xmlns:ds="http://schemas.openxmlformats.org/officeDocument/2006/customXml" ds:itemID="{F1AE8117-67ED-4B4E-B31E-080853EFE73D}">
-  <ds:schemaRefs>
-    <ds:schemaRef ds:uri="911617a9-2ec9-4645-852f-0245fbed96d5"/>
-    <ds:schemaRef ds:uri="af684b11-0207-48b9-9ad1-06801cc72a76"/>
-    <ds:schemaRef ds:uri="http://purl.org/dc/dcmitype/"/>
-    <ds:schemaRef ds:uri="http://purl.org/dc/elements/1.1/"/>
-    <ds:schemaRef ds:uri="http://purl.org/dc/terms/"/>
-    <ds:schemaRef ds:uri="http://schemas.microsoft.com/office/2006/documentManagement/types"/>
-    <ds:schemaRef ds:uri="http://schemas.microsoft.com/office/2006/metadata/properties"/>
-    <ds:schemaRef ds:uri="http://schemas.microsoft.com/office/infopath/2007/PartnerControls"/>
-    <ds:schemaRef ds:uri="http://schemas.openxmlformats.org/package/2006/metadata/core-properties"/>
-    <ds:schemaRef ds:uri="http://www.w3.org/XML/1998/namespace"/>
-  </ds:schemaRefs>
-</ds:datastoreItem>
+<file path=customXml/item2.xml><?xml version="1.0" encoding="utf-8"?>
+<?mso-contentType ?>
+<FormTemplates xmlns="http://schemas.microsoft.com/sharepoint/v3/contenttype/forms">
+  <Display>DocumentLibraryForm</Display>
+  <Edit>DocumentLibraryForm</Edit>
+  <New>DocumentLibraryForm</New>
+</FormTemplates>
 </file>
 
-<file path=customXml/itemProps2.xml><?xml version="1.0" encoding="utf-8"?>
-<ds:datastoreItem xmlns:ds="http://schemas.openxmlformats.org/officeDocument/2006/customXml" ds:itemID="{4C3BDD5B-8D08-4F85-A0AE-FAA105D1B4E7}">
-  <ds:schemaRefs>
-    <ds:schemaRef ds:uri="http://schemas.microsoft.com/sharepoint/v3/contenttype/forms"/>
-  </ds:schemaRefs>
-</ds:datastoreItem>
+<file path=customXml/item3.xml><?xml version="1.0" encoding="utf-8"?>
+<p:properties xmlns:p="http://schemas.microsoft.com/office/2006/metadata/properties" xmlns:xsi="http://www.w3.org/2001/XMLSchema-instance" xmlns:pc="http://schemas.microsoft.com/office/infopath/2007/PartnerControls">
+  <documentManagement>
+    <lcf76f155ced4ddcb4097134ff3c332f xmlns="911617a9-2ec9-4645-852f-0245fbed96d5">
+      <Terms xmlns="http://schemas.microsoft.com/office/infopath/2007/PartnerControls"/>
+    </lcf76f155ced4ddcb4097134ff3c332f>
+    <TaxCatchAll xmlns="af684b11-0207-48b9-9ad1-06801cc72a76" xsi:nil="true"/>
+  </documentManagement>
+</p:properties>
 </file>
 
-<file path=customXml/itemProps3.xml><?xml version="1.0" encoding="utf-8"?>
+<file path=customXml/itemProps1.xml><?xml version="1.0" encoding="utf-8"?>
 <ds:datastoreItem xmlns:ds="http://schemas.openxmlformats.org/officeDocument/2006/customXml" ds:itemID="{304FC2FF-8C18-446C-A66B-1977A3690EEF}">
   <ds:schemaRefs>
     <ds:schemaRef ds:uri="911617a9-2ec9-4645-852f-0245fbed96d5"/>
@@ -46693,6 +46476,31 @@
 </ds:datastoreItem>
 </file>
 
+<file path=customXml/itemProps2.xml><?xml version="1.0" encoding="utf-8"?>
+<ds:datastoreItem xmlns:ds="http://schemas.openxmlformats.org/officeDocument/2006/customXml" ds:itemID="{4C3BDD5B-8D08-4F85-A0AE-FAA105D1B4E7}">
+  <ds:schemaRefs>
+    <ds:schemaRef ds:uri="http://schemas.microsoft.com/sharepoint/v3/contenttype/forms"/>
+  </ds:schemaRefs>
+</ds:datastoreItem>
+</file>
+
+<file path=customXml/itemProps3.xml><?xml version="1.0" encoding="utf-8"?>
+<ds:datastoreItem xmlns:ds="http://schemas.openxmlformats.org/officeDocument/2006/customXml" ds:itemID="{F1AE8117-67ED-4B4E-B31E-080853EFE73D}">
+  <ds:schemaRefs>
+    <ds:schemaRef ds:uri="911617a9-2ec9-4645-852f-0245fbed96d5"/>
+    <ds:schemaRef ds:uri="af684b11-0207-48b9-9ad1-06801cc72a76"/>
+    <ds:schemaRef ds:uri="http://purl.org/dc/dcmitype/"/>
+    <ds:schemaRef ds:uri="http://purl.org/dc/elements/1.1/"/>
+    <ds:schemaRef ds:uri="http://purl.org/dc/terms/"/>
+    <ds:schemaRef ds:uri="http://schemas.microsoft.com/office/2006/documentManagement/types"/>
+    <ds:schemaRef ds:uri="http://schemas.microsoft.com/office/2006/metadata/properties"/>
+    <ds:schemaRef ds:uri="http://schemas.microsoft.com/office/infopath/2007/PartnerControls"/>
+    <ds:schemaRef ds:uri="http://schemas.openxmlformats.org/package/2006/metadata/core-properties"/>
+    <ds:schemaRef ds:uri="http://www.w3.org/XML/1998/namespace"/>
+  </ds:schemaRefs>
+</ds:datastoreItem>
+</file>
+
 <file path=docMetadata/LabelInfo.xml><?xml version="1.0" encoding="utf-8"?>
 <clbl:labelList xmlns:clbl="http://schemas.microsoft.com/office/2020/mipLabelMetadata">
   <clbl:label id="{3b4c039f-23e2-40b6-aac0-78be1568b6cc}" enabled="1" method="Standard" siteId="{c10a36d8-2981-4b7b-9b89-2ef59365493a}" removed="0"/>

</xml_diff>